<commit_message>
fix(soutenance): point image paths to real _light screenshots and regenerate PPTX (demo slides were missing captures)
</commit_message>
<xml_diff>
--- a/Rapport/Soutenance - Alumni CRM - PreMSc 2026.pptx
+++ b/Rapport/Soutenance - Alumni CRM - PreMSc 2026.pptx
@@ -5,23 +5,23 @@
     <p:sldMasterId id="2147483648" r:id="rId1"/>
   </p:sldMasterIdLst>
   <p:sldIdLst>
-    <p:sldId id="256" r:id="rId2"/>
-    <p:sldId id="257" r:id="rId3"/>
-    <p:sldId id="258" r:id="rId4"/>
-    <p:sldId id="259" r:id="rId5"/>
-    <p:sldId id="260" r:id="rId6"/>
-    <p:sldId id="261" r:id="rId7"/>
-    <p:sldId id="262" r:id="rId8"/>
-    <p:sldId id="263" r:id="rId9"/>
-    <p:sldId id="264" r:id="rId10"/>
-    <p:sldId id="265" r:id="rId11"/>
-    <p:sldId id="266" r:id="rId12"/>
-    <p:sldId id="267" r:id="rId13"/>
-    <p:sldId id="268" r:id="rId14"/>
-    <p:sldId id="269" r:id="rId15"/>
-    <p:sldId id="270" r:id="rId16"/>
+    <p:sldId id="256" r:id="rId7"/>
+    <p:sldId id="257" r:id="rId8"/>
+    <p:sldId id="258" r:id="rId9"/>
+    <p:sldId id="259" r:id="rId10"/>
+    <p:sldId id="260" r:id="rId11"/>
+    <p:sldId id="261" r:id="rId12"/>
+    <p:sldId id="262" r:id="rId13"/>
+    <p:sldId id="263" r:id="rId14"/>
+    <p:sldId id="264" r:id="rId15"/>
+    <p:sldId id="265" r:id="rId16"/>
+    <p:sldId id="266" r:id="rId17"/>
+    <p:sldId id="267" r:id="rId18"/>
+    <p:sldId id="268" r:id="rId19"/>
+    <p:sldId id="269" r:id="rId20"/>
+    <p:sldId id="270" r:id="rId21"/>
   </p:sldIdLst>
-  <p:sldSz cx="12192000" cy="6858000"/>
+  <p:sldSz cx="12191695" cy="6858000" type="screen4x3"/>
   <p:notesSz cx="6858000" cy="9144000"/>
   <p:defaultTextStyle>
     <a:defPPr>
@@ -118,52 +118,7 @@
       </a:defRPr>
     </a:lvl9pPr>
   </p:defaultTextStyle>
-  <p:extLst>
-    <p:ext uri="{EFAFB233-063F-42B5-8137-9DF3F51BA10A}">
-      <p15:sldGuideLst xmlns:p15="http://schemas.microsoft.com/office/powerpoint/2012/main">
-        <p15:guide id="1" orient="horz" pos="2160">
-          <p15:clr>
-            <a:srgbClr val="A4A3A4"/>
-          </p15:clr>
-        </p15:guide>
-        <p15:guide id="2" pos="2880">
-          <p15:clr>
-            <a:srgbClr val="A4A3A4"/>
-          </p15:clr>
-        </p15:guide>
-      </p15:sldGuideLst>
-    </p:ext>
-  </p:extLst>
 </p:presentation>
-</file>
-
-<file path=ppt/changesInfos/changesInfo1.xml><?xml version="1.0" encoding="utf-8"?>
-<pc:chgInfo xmlns:a="http://schemas.openxmlformats.org/drawingml/2006/main" xmlns:r="http://schemas.openxmlformats.org/officeDocument/2006/relationships" xmlns:ac="http://schemas.microsoft.com/office/drawing/2013/main/command" xmlns:pc="http://schemas.microsoft.com/office/powerpoint/2013/main/command">
-  <pc:docChgLst>
-    <pc:chgData name="Rafik djemadi" userId="2dcf6afdb52b8155" providerId="LiveId" clId="{ED258C4A-5798-4758-A095-3C1672EF9DFC}"/>
-    <pc:docChg chg="modSld">
-      <pc:chgData name="Rafik djemadi" userId="2dcf6afdb52b8155" providerId="LiveId" clId="{ED258C4A-5798-4758-A095-3C1672EF9DFC}" dt="2026-08-31T11:16:40.350" v="3" actId="14100"/>
-      <pc:docMkLst>
-        <pc:docMk/>
-      </pc:docMkLst>
-      <pc:sldChg chg="modSp mod">
-        <pc:chgData name="Rafik djemadi" userId="2dcf6afdb52b8155" providerId="LiveId" clId="{ED258C4A-5798-4758-A095-3C1672EF9DFC}" dt="2026-08-31T11:16:40.350" v="3" actId="14100"/>
-        <pc:sldMkLst>
-          <pc:docMk/>
-          <pc:sldMk cId="0" sldId="264"/>
-        </pc:sldMkLst>
-        <pc:picChg chg="mod">
-          <ac:chgData name="Rafik djemadi" userId="2dcf6afdb52b8155" providerId="LiveId" clId="{ED258C4A-5798-4758-A095-3C1672EF9DFC}" dt="2026-08-31T11:16:40.350" v="3" actId="14100"/>
-          <ac:picMkLst>
-            <pc:docMk/>
-            <pc:sldMk cId="0" sldId="264"/>
-            <ac:picMk id="4" creationId="{00000000-0000-0000-0000-000000000000}"/>
-          </ac:picMkLst>
-        </pc:picChg>
-      </pc:sldChg>
-    </pc:docChg>
-  </pc:docChgLst>
-</pc:chgInfo>
 </file>
 
 <file path=ppt/slideLayouts/slideLayout1.xml><?xml version="1.0" encoding="utf-8"?>
@@ -204,9 +159,10 @@
           <a:lstStyle/>
           <a:p>
             <a:r>
-              <a:rPr lang="en-US"/>
+              <a:rPr lang="en-US" smtClean="0"/>
               <a:t>Click to edit Master title style</a:t>
             </a:r>
+            <a:endParaRPr lang="en-US"/>
           </a:p>
         </p:txBody>
       </p:sp>
@@ -322,9 +278,10 @@
           </a:lstStyle>
           <a:p>
             <a:r>
-              <a:rPr lang="en-US"/>
+              <a:rPr lang="en-US" smtClean="0"/>
               <a:t>Click to edit Master subtitle style</a:t>
             </a:r>
+            <a:endParaRPr lang="en-US"/>
           </a:p>
         </p:txBody>
       </p:sp>
@@ -345,7 +302,7 @@
           <a:p>
             <a:fld id="{5BCAD085-E8A6-8845-BD4E-CB4CCA059FC4}" type="datetimeFigureOut">
               <a:rPr lang="en-US" smtClean="0"/>
-              <a:t>8/31/2026</a:t>
+              <a:t>1/27/13</a:t>
             </a:fld>
             <a:endParaRPr lang="en-US"/>
           </a:p>
@@ -439,9 +396,10 @@
           <a:lstStyle/>
           <a:p>
             <a:r>
-              <a:rPr lang="en-US"/>
+              <a:rPr lang="en-US" smtClean="0"/>
               <a:t>Click to edit Master title style</a:t>
             </a:r>
+            <a:endParaRPr lang="en-US"/>
           </a:p>
         </p:txBody>
       </p:sp>
@@ -462,37 +420,38 @@
           <a:p>
             <a:pPr lvl="0"/>
             <a:r>
-              <a:rPr lang="en-US"/>
+              <a:rPr lang="en-US" smtClean="0"/>
               <a:t>Click to edit Master text styles</a:t>
             </a:r>
           </a:p>
           <a:p>
             <a:pPr lvl="1"/>
             <a:r>
-              <a:rPr lang="en-US"/>
+              <a:rPr lang="en-US" smtClean="0"/>
               <a:t>Second level</a:t>
             </a:r>
           </a:p>
           <a:p>
             <a:pPr lvl="2"/>
             <a:r>
-              <a:rPr lang="en-US"/>
+              <a:rPr lang="en-US" smtClean="0"/>
               <a:t>Third level</a:t>
             </a:r>
           </a:p>
           <a:p>
             <a:pPr lvl="3"/>
             <a:r>
-              <a:rPr lang="en-US"/>
+              <a:rPr lang="en-US" smtClean="0"/>
               <a:t>Fourth level</a:t>
             </a:r>
           </a:p>
           <a:p>
             <a:pPr lvl="4"/>
             <a:r>
-              <a:rPr lang="en-US"/>
+              <a:rPr lang="en-US" smtClean="0"/>
               <a:t>Fifth level</a:t>
             </a:r>
+            <a:endParaRPr lang="en-US"/>
           </a:p>
         </p:txBody>
       </p:sp>
@@ -513,7 +472,7 @@
           <a:p>
             <a:fld id="{5BCAD085-E8A6-8845-BD4E-CB4CCA059FC4}" type="datetimeFigureOut">
               <a:rPr lang="en-US" smtClean="0"/>
-              <a:t>8/31/2026</a:t>
+              <a:t>1/27/13</a:t>
             </a:fld>
             <a:endParaRPr lang="en-US"/>
           </a:p>
@@ -612,9 +571,10 @@
           <a:lstStyle/>
           <a:p>
             <a:r>
-              <a:rPr lang="en-US"/>
+              <a:rPr lang="en-US" smtClean="0"/>
               <a:t>Click to edit Master title style</a:t>
             </a:r>
+            <a:endParaRPr lang="en-US"/>
           </a:p>
         </p:txBody>
       </p:sp>
@@ -640,37 +600,38 @@
           <a:p>
             <a:pPr lvl="0"/>
             <a:r>
-              <a:rPr lang="en-US"/>
+              <a:rPr lang="en-US" smtClean="0"/>
               <a:t>Click to edit Master text styles</a:t>
             </a:r>
           </a:p>
           <a:p>
             <a:pPr lvl="1"/>
             <a:r>
-              <a:rPr lang="en-US"/>
+              <a:rPr lang="en-US" smtClean="0"/>
               <a:t>Second level</a:t>
             </a:r>
           </a:p>
           <a:p>
             <a:pPr lvl="2"/>
             <a:r>
-              <a:rPr lang="en-US"/>
+              <a:rPr lang="en-US" smtClean="0"/>
               <a:t>Third level</a:t>
             </a:r>
           </a:p>
           <a:p>
             <a:pPr lvl="3"/>
             <a:r>
-              <a:rPr lang="en-US"/>
+              <a:rPr lang="en-US" smtClean="0"/>
               <a:t>Fourth level</a:t>
             </a:r>
           </a:p>
           <a:p>
             <a:pPr lvl="4"/>
             <a:r>
-              <a:rPr lang="en-US"/>
+              <a:rPr lang="en-US" smtClean="0"/>
               <a:t>Fifth level</a:t>
             </a:r>
+            <a:endParaRPr lang="en-US"/>
           </a:p>
         </p:txBody>
       </p:sp>
@@ -691,7 +652,7 @@
           <a:p>
             <a:fld id="{5BCAD085-E8A6-8845-BD4E-CB4CCA059FC4}" type="datetimeFigureOut">
               <a:rPr lang="en-US" smtClean="0"/>
-              <a:t>8/31/2026</a:t>
+              <a:t>1/27/13</a:t>
             </a:fld>
             <a:endParaRPr lang="en-US"/>
           </a:p>
@@ -785,9 +746,10 @@
           <a:lstStyle/>
           <a:p>
             <a:r>
-              <a:rPr lang="en-US"/>
+              <a:rPr lang="en-US" smtClean="0"/>
               <a:t>Click to edit Master title style</a:t>
             </a:r>
+            <a:endParaRPr lang="en-US"/>
           </a:p>
         </p:txBody>
       </p:sp>
@@ -808,37 +770,38 @@
           <a:p>
             <a:pPr lvl="0"/>
             <a:r>
-              <a:rPr lang="en-US"/>
+              <a:rPr lang="en-US" smtClean="0"/>
               <a:t>Click to edit Master text styles</a:t>
             </a:r>
           </a:p>
           <a:p>
             <a:pPr lvl="1"/>
             <a:r>
-              <a:rPr lang="en-US"/>
+              <a:rPr lang="en-US" smtClean="0"/>
               <a:t>Second level</a:t>
             </a:r>
           </a:p>
           <a:p>
             <a:pPr lvl="2"/>
             <a:r>
-              <a:rPr lang="en-US"/>
+              <a:rPr lang="en-US" smtClean="0"/>
               <a:t>Third level</a:t>
             </a:r>
           </a:p>
           <a:p>
             <a:pPr lvl="3"/>
             <a:r>
-              <a:rPr lang="en-US"/>
+              <a:rPr lang="en-US" smtClean="0"/>
               <a:t>Fourth level</a:t>
             </a:r>
           </a:p>
           <a:p>
             <a:pPr lvl="4"/>
             <a:r>
-              <a:rPr lang="en-US"/>
+              <a:rPr lang="en-US" smtClean="0"/>
               <a:t>Fifth level</a:t>
             </a:r>
+            <a:endParaRPr lang="en-US"/>
           </a:p>
         </p:txBody>
       </p:sp>
@@ -859,7 +822,7 @@
           <a:p>
             <a:fld id="{5BCAD085-E8A6-8845-BD4E-CB4CCA059FC4}" type="datetimeFigureOut">
               <a:rPr lang="en-US" smtClean="0"/>
-              <a:t>8/31/2026</a:t>
+              <a:t>1/27/13</a:t>
             </a:fld>
             <a:endParaRPr lang="en-US"/>
           </a:p>
@@ -962,9 +925,10 @@
           </a:lstStyle>
           <a:p>
             <a:r>
-              <a:rPr lang="en-US"/>
+              <a:rPr lang="en-US" smtClean="0"/>
               <a:t>Click to edit Master title style</a:t>
             </a:r>
+            <a:endParaRPr lang="en-US"/>
           </a:p>
         </p:txBody>
       </p:sp>
@@ -1081,7 +1045,7 @@
           <a:p>
             <a:pPr lvl="0"/>
             <a:r>
-              <a:rPr lang="en-US"/>
+              <a:rPr lang="en-US" smtClean="0"/>
               <a:t>Click to edit Master text styles</a:t>
             </a:r>
           </a:p>
@@ -1104,7 +1068,7 @@
           <a:p>
             <a:fld id="{5BCAD085-E8A6-8845-BD4E-CB4CCA059FC4}" type="datetimeFigureOut">
               <a:rPr lang="en-US" smtClean="0"/>
-              <a:t>8/31/2026</a:t>
+              <a:t>1/27/13</a:t>
             </a:fld>
             <a:endParaRPr lang="en-US"/>
           </a:p>
@@ -1198,9 +1162,10 @@
           <a:lstStyle/>
           <a:p>
             <a:r>
-              <a:rPr lang="en-US"/>
+              <a:rPr lang="en-US" smtClean="0"/>
               <a:t>Click to edit Master title style</a:t>
             </a:r>
+            <a:endParaRPr lang="en-US"/>
           </a:p>
         </p:txBody>
       </p:sp>
@@ -1254,37 +1219,38 @@
           <a:p>
             <a:pPr lvl="0"/>
             <a:r>
-              <a:rPr lang="en-US"/>
+              <a:rPr lang="en-US" smtClean="0"/>
               <a:t>Click to edit Master text styles</a:t>
             </a:r>
           </a:p>
           <a:p>
             <a:pPr lvl="1"/>
             <a:r>
-              <a:rPr lang="en-US"/>
+              <a:rPr lang="en-US" smtClean="0"/>
               <a:t>Second level</a:t>
             </a:r>
           </a:p>
           <a:p>
             <a:pPr lvl="2"/>
             <a:r>
-              <a:rPr lang="en-US"/>
+              <a:rPr lang="en-US" smtClean="0"/>
               <a:t>Third level</a:t>
             </a:r>
           </a:p>
           <a:p>
             <a:pPr lvl="3"/>
             <a:r>
-              <a:rPr lang="en-US"/>
+              <a:rPr lang="en-US" smtClean="0"/>
               <a:t>Fourth level</a:t>
             </a:r>
           </a:p>
           <a:p>
             <a:pPr lvl="4"/>
             <a:r>
-              <a:rPr lang="en-US"/>
+              <a:rPr lang="en-US" smtClean="0"/>
               <a:t>Fifth level</a:t>
             </a:r>
+            <a:endParaRPr lang="en-US"/>
           </a:p>
         </p:txBody>
       </p:sp>
@@ -1338,37 +1304,38 @@
           <a:p>
             <a:pPr lvl="0"/>
             <a:r>
-              <a:rPr lang="en-US"/>
+              <a:rPr lang="en-US" smtClean="0"/>
               <a:t>Click to edit Master text styles</a:t>
             </a:r>
           </a:p>
           <a:p>
             <a:pPr lvl="1"/>
             <a:r>
-              <a:rPr lang="en-US"/>
+              <a:rPr lang="en-US" smtClean="0"/>
               <a:t>Second level</a:t>
             </a:r>
           </a:p>
           <a:p>
             <a:pPr lvl="2"/>
             <a:r>
-              <a:rPr lang="en-US"/>
+              <a:rPr lang="en-US" smtClean="0"/>
               <a:t>Third level</a:t>
             </a:r>
           </a:p>
           <a:p>
             <a:pPr lvl="3"/>
             <a:r>
-              <a:rPr lang="en-US"/>
+              <a:rPr lang="en-US" smtClean="0"/>
               <a:t>Fourth level</a:t>
             </a:r>
           </a:p>
           <a:p>
             <a:pPr lvl="4"/>
             <a:r>
-              <a:rPr lang="en-US"/>
+              <a:rPr lang="en-US" smtClean="0"/>
               <a:t>Fifth level</a:t>
             </a:r>
+            <a:endParaRPr lang="en-US"/>
           </a:p>
         </p:txBody>
       </p:sp>
@@ -1389,7 +1356,7 @@
           <a:p>
             <a:fld id="{5BCAD085-E8A6-8845-BD4E-CB4CCA059FC4}" type="datetimeFigureOut">
               <a:rPr lang="en-US" smtClean="0"/>
-              <a:t>8/31/2026</a:t>
+              <a:t>1/27/13</a:t>
             </a:fld>
             <a:endParaRPr lang="en-US"/>
           </a:p>
@@ -1487,9 +1454,10 @@
           </a:lstStyle>
           <a:p>
             <a:r>
-              <a:rPr lang="en-US"/>
+              <a:rPr lang="en-US" smtClean="0"/>
               <a:t>Click to edit Master title style</a:t>
             </a:r>
+            <a:endParaRPr lang="en-US"/>
           </a:p>
         </p:txBody>
       </p:sp>
@@ -1552,7 +1520,7 @@
           <a:p>
             <a:pPr lvl="0"/>
             <a:r>
-              <a:rPr lang="en-US"/>
+              <a:rPr lang="en-US" smtClean="0"/>
               <a:t>Click to edit Master text styles</a:t>
             </a:r>
           </a:p>
@@ -1608,37 +1576,38 @@
           <a:p>
             <a:pPr lvl="0"/>
             <a:r>
-              <a:rPr lang="en-US"/>
+              <a:rPr lang="en-US" smtClean="0"/>
               <a:t>Click to edit Master text styles</a:t>
             </a:r>
           </a:p>
           <a:p>
             <a:pPr lvl="1"/>
             <a:r>
-              <a:rPr lang="en-US"/>
+              <a:rPr lang="en-US" smtClean="0"/>
               <a:t>Second level</a:t>
             </a:r>
           </a:p>
           <a:p>
             <a:pPr lvl="2"/>
             <a:r>
-              <a:rPr lang="en-US"/>
+              <a:rPr lang="en-US" smtClean="0"/>
               <a:t>Third level</a:t>
             </a:r>
           </a:p>
           <a:p>
             <a:pPr lvl="3"/>
             <a:r>
-              <a:rPr lang="en-US"/>
+              <a:rPr lang="en-US" smtClean="0"/>
               <a:t>Fourth level</a:t>
             </a:r>
           </a:p>
           <a:p>
             <a:pPr lvl="4"/>
             <a:r>
-              <a:rPr lang="en-US"/>
+              <a:rPr lang="en-US" smtClean="0"/>
               <a:t>Fifth level</a:t>
             </a:r>
+            <a:endParaRPr lang="en-US"/>
           </a:p>
         </p:txBody>
       </p:sp>
@@ -1701,7 +1670,7 @@
           <a:p>
             <a:pPr lvl="0"/>
             <a:r>
-              <a:rPr lang="en-US"/>
+              <a:rPr lang="en-US" smtClean="0"/>
               <a:t>Click to edit Master text styles</a:t>
             </a:r>
           </a:p>
@@ -1757,37 +1726,38 @@
           <a:p>
             <a:pPr lvl="0"/>
             <a:r>
-              <a:rPr lang="en-US"/>
+              <a:rPr lang="en-US" smtClean="0"/>
               <a:t>Click to edit Master text styles</a:t>
             </a:r>
           </a:p>
           <a:p>
             <a:pPr lvl="1"/>
             <a:r>
-              <a:rPr lang="en-US"/>
+              <a:rPr lang="en-US" smtClean="0"/>
               <a:t>Second level</a:t>
             </a:r>
           </a:p>
           <a:p>
             <a:pPr lvl="2"/>
             <a:r>
-              <a:rPr lang="en-US"/>
+              <a:rPr lang="en-US" smtClean="0"/>
               <a:t>Third level</a:t>
             </a:r>
           </a:p>
           <a:p>
             <a:pPr lvl="3"/>
             <a:r>
-              <a:rPr lang="en-US"/>
+              <a:rPr lang="en-US" smtClean="0"/>
               <a:t>Fourth level</a:t>
             </a:r>
           </a:p>
           <a:p>
             <a:pPr lvl="4"/>
             <a:r>
-              <a:rPr lang="en-US"/>
+              <a:rPr lang="en-US" smtClean="0"/>
               <a:t>Fifth level</a:t>
             </a:r>
+            <a:endParaRPr lang="en-US"/>
           </a:p>
         </p:txBody>
       </p:sp>
@@ -1808,7 +1778,7 @@
           <a:p>
             <a:fld id="{5BCAD085-E8A6-8845-BD4E-CB4CCA059FC4}" type="datetimeFigureOut">
               <a:rPr lang="en-US" smtClean="0"/>
-              <a:t>8/31/2026</a:t>
+              <a:t>1/27/13</a:t>
             </a:fld>
             <a:endParaRPr lang="en-US"/>
           </a:p>
@@ -1902,9 +1872,10 @@
           <a:lstStyle/>
           <a:p>
             <a:r>
-              <a:rPr lang="en-US"/>
+              <a:rPr lang="en-US" smtClean="0"/>
               <a:t>Click to edit Master title style</a:t>
             </a:r>
+            <a:endParaRPr lang="en-US"/>
           </a:p>
         </p:txBody>
       </p:sp>
@@ -1925,7 +1896,7 @@
           <a:p>
             <a:fld id="{5BCAD085-E8A6-8845-BD4E-CB4CCA059FC4}" type="datetimeFigureOut">
               <a:rPr lang="en-US" smtClean="0"/>
-              <a:t>8/31/2026</a:t>
+              <a:t>1/27/13</a:t>
             </a:fld>
             <a:endParaRPr lang="en-US"/>
           </a:p>
@@ -2020,7 +1991,7 @@
           <a:p>
             <a:fld id="{5BCAD085-E8A6-8845-BD4E-CB4CCA059FC4}" type="datetimeFigureOut">
               <a:rPr lang="en-US" smtClean="0"/>
-              <a:t>8/31/2026</a:t>
+              <a:t>1/27/13</a:t>
             </a:fld>
             <a:endParaRPr lang="en-US"/>
           </a:p>
@@ -2123,9 +2094,10 @@
           </a:lstStyle>
           <a:p>
             <a:r>
-              <a:rPr lang="en-US"/>
+              <a:rPr lang="en-US" smtClean="0"/>
               <a:t>Click to edit Master title style</a:t>
             </a:r>
+            <a:endParaRPr lang="en-US"/>
           </a:p>
         </p:txBody>
       </p:sp>
@@ -2179,37 +2151,38 @@
           <a:p>
             <a:pPr lvl="0"/>
             <a:r>
-              <a:rPr lang="en-US"/>
+              <a:rPr lang="en-US" smtClean="0"/>
               <a:t>Click to edit Master text styles</a:t>
             </a:r>
           </a:p>
           <a:p>
             <a:pPr lvl="1"/>
             <a:r>
-              <a:rPr lang="en-US"/>
+              <a:rPr lang="en-US" smtClean="0"/>
               <a:t>Second level</a:t>
             </a:r>
           </a:p>
           <a:p>
             <a:pPr lvl="2"/>
             <a:r>
-              <a:rPr lang="en-US"/>
+              <a:rPr lang="en-US" smtClean="0"/>
               <a:t>Third level</a:t>
             </a:r>
           </a:p>
           <a:p>
             <a:pPr lvl="3"/>
             <a:r>
-              <a:rPr lang="en-US"/>
+              <a:rPr lang="en-US" smtClean="0"/>
               <a:t>Fourth level</a:t>
             </a:r>
           </a:p>
           <a:p>
             <a:pPr lvl="4"/>
             <a:r>
-              <a:rPr lang="en-US"/>
+              <a:rPr lang="en-US" smtClean="0"/>
               <a:t>Fifth level</a:t>
             </a:r>
+            <a:endParaRPr lang="en-US"/>
           </a:p>
         </p:txBody>
       </p:sp>
@@ -2272,7 +2245,7 @@
           <a:p>
             <a:pPr lvl="0"/>
             <a:r>
-              <a:rPr lang="en-US"/>
+              <a:rPr lang="en-US" smtClean="0"/>
               <a:t>Click to edit Master text styles</a:t>
             </a:r>
           </a:p>
@@ -2295,7 +2268,7 @@
           <a:p>
             <a:fld id="{5BCAD085-E8A6-8845-BD4E-CB4CCA059FC4}" type="datetimeFigureOut">
               <a:rPr lang="en-US" smtClean="0"/>
-              <a:t>8/31/2026</a:t>
+              <a:t>1/27/13</a:t>
             </a:fld>
             <a:endParaRPr lang="en-US"/>
           </a:p>
@@ -2398,9 +2371,10 @@
           </a:lstStyle>
           <a:p>
             <a:r>
-              <a:rPr lang="en-US"/>
+              <a:rPr lang="en-US" smtClean="0"/>
               <a:t>Click to edit Master title style</a:t>
             </a:r>
+            <a:endParaRPr lang="en-US"/>
           </a:p>
         </p:txBody>
       </p:sp>
@@ -2524,7 +2498,7 @@
           <a:p>
             <a:pPr lvl="0"/>
             <a:r>
-              <a:rPr lang="en-US"/>
+              <a:rPr lang="en-US" smtClean="0"/>
               <a:t>Click to edit Master text styles</a:t>
             </a:r>
           </a:p>
@@ -2547,7 +2521,7 @@
           <a:p>
             <a:fld id="{5BCAD085-E8A6-8845-BD4E-CB4CCA059FC4}" type="datetimeFigureOut">
               <a:rPr lang="en-US" smtClean="0"/>
-              <a:t>8/31/2026</a:t>
+              <a:t>1/27/13</a:t>
             </a:fld>
             <a:endParaRPr lang="en-US"/>
           </a:p>
@@ -2656,9 +2630,10 @@
           <a:lstStyle/>
           <a:p>
             <a:r>
-              <a:rPr lang="en-US"/>
+              <a:rPr lang="en-US" smtClean="0"/>
               <a:t>Click to edit Master title style</a:t>
             </a:r>
+            <a:endParaRPr lang="en-US"/>
           </a:p>
         </p:txBody>
       </p:sp>
@@ -2689,37 +2664,38 @@
           <a:p>
             <a:pPr lvl="0"/>
             <a:r>
-              <a:rPr lang="en-US"/>
+              <a:rPr lang="en-US" smtClean="0"/>
               <a:t>Click to edit Master text styles</a:t>
             </a:r>
           </a:p>
           <a:p>
             <a:pPr lvl="1"/>
             <a:r>
-              <a:rPr lang="en-US"/>
+              <a:rPr lang="en-US" smtClean="0"/>
               <a:t>Second level</a:t>
             </a:r>
           </a:p>
           <a:p>
             <a:pPr lvl="2"/>
             <a:r>
-              <a:rPr lang="en-US"/>
+              <a:rPr lang="en-US" smtClean="0"/>
               <a:t>Third level</a:t>
             </a:r>
           </a:p>
           <a:p>
             <a:pPr lvl="3"/>
             <a:r>
-              <a:rPr lang="en-US"/>
+              <a:rPr lang="en-US" smtClean="0"/>
               <a:t>Fourth level</a:t>
             </a:r>
           </a:p>
           <a:p>
             <a:pPr lvl="4"/>
             <a:r>
-              <a:rPr lang="en-US"/>
+              <a:rPr lang="en-US" smtClean="0"/>
               <a:t>Fifth level</a:t>
             </a:r>
+            <a:endParaRPr lang="en-US"/>
           </a:p>
         </p:txBody>
       </p:sp>
@@ -2758,7 +2734,7 @@
           <a:p>
             <a:fld id="{5BCAD085-E8A6-8845-BD4E-CB4CCA059FC4}" type="datetimeFigureOut">
               <a:rPr lang="en-US" smtClean="0"/>
-              <a:t>8/31/2026</a:t>
+              <a:t>1/27/13</a:t>
             </a:fld>
             <a:endParaRPr lang="en-US"/>
           </a:p>
@@ -3117,7 +3093,7 @@
 </file>
 
 <file path=ppt/slides/slide1.xml><?xml version="1.0" encoding="utf-8"?>
-<p:sld xmlns:a="http://schemas.openxmlformats.org/drawingml/2006/main" xmlns:r="http://schemas.openxmlformats.org/officeDocument/2006/relationships" xmlns:p="http://schemas.openxmlformats.org/presentationml/2006/main">
+<p:sld xmlns:a="http://schemas.openxmlformats.org/drawingml/2006/main" xmlns:p="http://schemas.openxmlformats.org/presentationml/2006/main" xmlns:r="http://schemas.openxmlformats.org/officeDocument/2006/relationships">
   <p:cSld>
     <p:bg>
       <p:bgPr>
@@ -3133,14 +3109,7 @@
         <p:cNvGrpSpPr/>
         <p:nvPr/>
       </p:nvGrpSpPr>
-      <p:grpSpPr>
-        <a:xfrm>
-          <a:off x="0" y="0"/>
-          <a:ext cx="0" cy="0"/>
-          <a:chOff x="0" y="0"/>
-          <a:chExt cx="0" cy="0"/>
-        </a:xfrm>
-      </p:grpSpPr>
+      <p:grpSpPr/>
       <p:sp>
         <p:nvSpPr>
           <p:cNvPr id="2" name="Rectangle 1"/>
@@ -3181,7 +3150,6 @@
           <a:lstStyle/>
           <a:p>
             <a:pPr algn="ctr"/>
-            <a:endParaRPr/>
           </a:p>
         </p:txBody>
       </p:sp>
@@ -3225,7 +3193,6 @@
           <a:lstStyle/>
           <a:p>
             <a:pPr algn="ctr"/>
-            <a:endParaRPr/>
           </a:p>
         </p:txBody>
       </p:sp>
@@ -3246,7 +3213,7 @@
           <a:noFill/>
         </p:spPr>
         <p:txBody>
-          <a:bodyPr wrap="square" lIns="45720" tIns="27432" rIns="45720" bIns="27432">
+          <a:bodyPr wrap="square" lIns="45720" rIns="45720" tIns="27432" bIns="27432">
             <a:spAutoFit/>
           </a:bodyPr>
           <a:lstStyle/>
@@ -3284,7 +3251,7 @@
           <a:noFill/>
         </p:spPr>
         <p:txBody>
-          <a:bodyPr wrap="square" lIns="45720" tIns="27432" rIns="45720" bIns="27432">
+          <a:bodyPr wrap="square" lIns="45720" rIns="45720" tIns="27432" bIns="27432">
             <a:spAutoFit/>
           </a:bodyPr>
           <a:lstStyle/>
@@ -3322,7 +3289,7 @@
           <a:noFill/>
         </p:spPr>
         <p:txBody>
-          <a:bodyPr wrap="square" lIns="45720" tIns="27432" rIns="45720" bIns="27432">
+          <a:bodyPr wrap="square" lIns="45720" rIns="45720" tIns="27432" bIns="27432">
             <a:spAutoFit/>
           </a:bodyPr>
           <a:lstStyle/>
@@ -3360,7 +3327,7 @@
           <a:noFill/>
         </p:spPr>
         <p:txBody>
-          <a:bodyPr wrap="square" lIns="45720" tIns="27432" rIns="45720" bIns="27432">
+          <a:bodyPr wrap="square" lIns="45720" rIns="45720" tIns="27432" bIns="27432">
             <a:spAutoFit/>
           </a:bodyPr>
           <a:lstStyle/>
@@ -3398,7 +3365,7 @@
           <a:noFill/>
         </p:spPr>
         <p:txBody>
-          <a:bodyPr wrap="square" lIns="45720" tIns="27432" rIns="45720" bIns="27432">
+          <a:bodyPr wrap="square" lIns="45720" rIns="45720" tIns="27432" bIns="27432">
             <a:spAutoFit/>
           </a:bodyPr>
           <a:lstStyle/>
@@ -3436,7 +3403,7 @@
           <a:noFill/>
         </p:spPr>
         <p:txBody>
-          <a:bodyPr wrap="square" lIns="45720" tIns="27432" rIns="45720" bIns="27432">
+          <a:bodyPr wrap="square" lIns="45720" rIns="45720" tIns="27432" bIns="27432">
             <a:spAutoFit/>
           </a:bodyPr>
           <a:lstStyle/>
@@ -3466,7 +3433,7 @@
 </file>
 
 <file path=ppt/slides/slide10.xml><?xml version="1.0" encoding="utf-8"?>
-<p:sld xmlns:a="http://schemas.openxmlformats.org/drawingml/2006/main" xmlns:r="http://schemas.openxmlformats.org/officeDocument/2006/relationships" xmlns:p="http://schemas.openxmlformats.org/presentationml/2006/main">
+<p:sld xmlns:a="http://schemas.openxmlformats.org/drawingml/2006/main" xmlns:p="http://schemas.openxmlformats.org/presentationml/2006/main" xmlns:r="http://schemas.openxmlformats.org/officeDocument/2006/relationships">
   <p:cSld>
     <p:bg>
       <p:bgPr>
@@ -3482,14 +3449,7 @@
         <p:cNvGrpSpPr/>
         <p:nvPr/>
       </p:nvGrpSpPr>
-      <p:grpSpPr>
-        <a:xfrm>
-          <a:off x="0" y="0"/>
-          <a:ext cx="0" cy="0"/>
-          <a:chOff x="0" y="0"/>
-          <a:chExt cx="0" cy="0"/>
-        </a:xfrm>
-      </p:grpSpPr>
+      <p:grpSpPr/>
       <p:sp>
         <p:nvSpPr>
           <p:cNvPr id="2" name="Rectangle 1"/>
@@ -3526,7 +3486,7 @@
           </a:fontRef>
         </p:style>
         <p:txBody>
-          <a:bodyPr wrap="square" lIns="457200" tIns="137160" rtlCol="0" anchor="ctr"/>
+          <a:bodyPr rtlCol="0" anchor="ctr" lIns="457200" tIns="137160" wrap="square"/>
           <a:lstStyle/>
           <a:p>
             <a:pPr algn="ctr">
@@ -3594,13 +3554,12 @@
           <a:lstStyle/>
           <a:p>
             <a:pPr algn="ctr"/>
-            <a:endParaRPr/>
           </a:p>
         </p:txBody>
       </p:sp>
       <p:pic>
         <p:nvPicPr>
-          <p:cNvPr id="4" name="Picture 3" descr="anC_parcours.png"/>
+          <p:cNvPr id="4" name="Picture 3" descr="anC_parcours_light.png"/>
           <p:cNvPicPr>
             <a:picLocks noChangeAspect="1"/>
           </p:cNvPicPr>
@@ -3666,7 +3625,7 @@
 </file>
 
 <file path=ppt/slides/slide11.xml><?xml version="1.0" encoding="utf-8"?>
-<p:sld xmlns:a="http://schemas.openxmlformats.org/drawingml/2006/main" xmlns:r="http://schemas.openxmlformats.org/officeDocument/2006/relationships" xmlns:p="http://schemas.openxmlformats.org/presentationml/2006/main">
+<p:sld xmlns:a="http://schemas.openxmlformats.org/drawingml/2006/main" xmlns:p="http://schemas.openxmlformats.org/presentationml/2006/main" xmlns:r="http://schemas.openxmlformats.org/officeDocument/2006/relationships">
   <p:cSld>
     <p:bg>
       <p:bgPr>
@@ -3682,14 +3641,7 @@
         <p:cNvGrpSpPr/>
         <p:nvPr/>
       </p:nvGrpSpPr>
-      <p:grpSpPr>
-        <a:xfrm>
-          <a:off x="0" y="0"/>
-          <a:ext cx="0" cy="0"/>
-          <a:chOff x="0" y="0"/>
-          <a:chExt cx="0" cy="0"/>
-        </a:xfrm>
-      </p:grpSpPr>
+      <p:grpSpPr/>
       <p:sp>
         <p:nvSpPr>
           <p:cNvPr id="2" name="Rectangle 1"/>
@@ -3726,7 +3678,7 @@
           </a:fontRef>
         </p:style>
         <p:txBody>
-          <a:bodyPr wrap="square" lIns="457200" tIns="137160" rtlCol="0" anchor="ctr"/>
+          <a:bodyPr rtlCol="0" anchor="ctr" lIns="457200" tIns="137160" wrap="square"/>
           <a:lstStyle/>
           <a:p>
             <a:pPr algn="ctr">
@@ -3782,7 +3734,6 @@
           <a:lstStyle/>
           <a:p>
             <a:pPr algn="ctr"/>
-            <a:endParaRPr/>
           </a:p>
         </p:txBody>
       </p:sp>
@@ -3856,7 +3807,7 @@
       </p:sp>
       <p:pic>
         <p:nvPicPr>
-          <p:cNvPr id="5" name="Picture 4" descr="anC_consentement.png"/>
+          <p:cNvPr id="5" name="Picture 4" descr="anC_consentement_light.png"/>
           <p:cNvPicPr>
             <a:picLocks noChangeAspect="1"/>
           </p:cNvPicPr>
@@ -3880,7 +3831,7 @@
       </p:pic>
       <p:pic>
         <p:nvPicPr>
-          <p:cNvPr id="6" name="Picture 5" descr="anB_demandes_rgpd.png"/>
+          <p:cNvPr id="6" name="Picture 5" descr="anB_demandes_rgpd_light.png"/>
           <p:cNvPicPr>
             <a:picLocks noChangeAspect="1"/>
           </p:cNvPicPr>
@@ -3946,7 +3897,7 @@
 </file>
 
 <file path=ppt/slides/slide12.xml><?xml version="1.0" encoding="utf-8"?>
-<p:sld xmlns:a="http://schemas.openxmlformats.org/drawingml/2006/main" xmlns:r="http://schemas.openxmlformats.org/officeDocument/2006/relationships" xmlns:p="http://schemas.openxmlformats.org/presentationml/2006/main">
+<p:sld xmlns:a="http://schemas.openxmlformats.org/drawingml/2006/main" xmlns:p="http://schemas.openxmlformats.org/presentationml/2006/main" xmlns:r="http://schemas.openxmlformats.org/officeDocument/2006/relationships">
   <p:cSld>
     <p:bg>
       <p:bgPr>
@@ -3962,14 +3913,7 @@
         <p:cNvGrpSpPr/>
         <p:nvPr/>
       </p:nvGrpSpPr>
-      <p:grpSpPr>
-        <a:xfrm>
-          <a:off x="0" y="0"/>
-          <a:ext cx="0" cy="0"/>
-          <a:chOff x="0" y="0"/>
-          <a:chExt cx="0" cy="0"/>
-        </a:xfrm>
-      </p:grpSpPr>
+      <p:grpSpPr/>
       <p:sp>
         <p:nvSpPr>
           <p:cNvPr id="2" name="Rectangle 1"/>
@@ -4006,7 +3950,7 @@
           </a:fontRef>
         </p:style>
         <p:txBody>
-          <a:bodyPr wrap="square" lIns="457200" tIns="137160" rtlCol="0" anchor="ctr"/>
+          <a:bodyPr rtlCol="0" anchor="ctr" lIns="457200" tIns="137160" wrap="square"/>
           <a:lstStyle/>
           <a:p>
             <a:pPr algn="ctr">
@@ -4062,7 +4006,6 @@
           <a:lstStyle/>
           <a:p>
             <a:pPr algn="ctr"/>
-            <a:endParaRPr/>
           </a:p>
         </p:txBody>
       </p:sp>
@@ -4181,7 +4124,7 @@
       </p:sp>
       <p:pic>
         <p:nvPicPr>
-          <p:cNvPr id="5" name="Picture 4" descr="anB_dashboard.png"/>
+          <p:cNvPr id="5" name="Picture 4" descr="anB_dashboard_light.png"/>
           <p:cNvPicPr>
             <a:picLocks noChangeAspect="1"/>
           </p:cNvPicPr>
@@ -4247,7 +4190,7 @@
 </file>
 
 <file path=ppt/slides/slide13.xml><?xml version="1.0" encoding="utf-8"?>
-<p:sld xmlns:a="http://schemas.openxmlformats.org/drawingml/2006/main" xmlns:r="http://schemas.openxmlformats.org/officeDocument/2006/relationships" xmlns:p="http://schemas.openxmlformats.org/presentationml/2006/main">
+<p:sld xmlns:a="http://schemas.openxmlformats.org/drawingml/2006/main" xmlns:p="http://schemas.openxmlformats.org/presentationml/2006/main" xmlns:r="http://schemas.openxmlformats.org/officeDocument/2006/relationships">
   <p:cSld>
     <p:bg>
       <p:bgPr>
@@ -4263,14 +4206,7 @@
         <p:cNvGrpSpPr/>
         <p:nvPr/>
       </p:nvGrpSpPr>
-      <p:grpSpPr>
-        <a:xfrm>
-          <a:off x="0" y="0"/>
-          <a:ext cx="0" cy="0"/>
-          <a:chOff x="0" y="0"/>
-          <a:chExt cx="0" cy="0"/>
-        </a:xfrm>
-      </p:grpSpPr>
+      <p:grpSpPr/>
       <p:sp>
         <p:nvSpPr>
           <p:cNvPr id="2" name="Rectangle 1"/>
@@ -4307,7 +4243,7 @@
           </a:fontRef>
         </p:style>
         <p:txBody>
-          <a:bodyPr wrap="square" lIns="457200" tIns="137160" rtlCol="0" anchor="ctr"/>
+          <a:bodyPr rtlCol="0" anchor="ctr" lIns="457200" tIns="137160" wrap="square"/>
           <a:lstStyle/>
           <a:p>
             <a:pPr algn="ctr">
@@ -4363,7 +4299,6 @@
           <a:lstStyle/>
           <a:p>
             <a:pPr algn="ctr"/>
-            <a:endParaRPr/>
           </a:p>
         </p:txBody>
       </p:sp>
@@ -4524,7 +4459,7 @@
 </file>
 
 <file path=ppt/slides/slide14.xml><?xml version="1.0" encoding="utf-8"?>
-<p:sld xmlns:a="http://schemas.openxmlformats.org/drawingml/2006/main" xmlns:r="http://schemas.openxmlformats.org/officeDocument/2006/relationships" xmlns:p="http://schemas.openxmlformats.org/presentationml/2006/main">
+<p:sld xmlns:a="http://schemas.openxmlformats.org/drawingml/2006/main" xmlns:p="http://schemas.openxmlformats.org/presentationml/2006/main" xmlns:r="http://schemas.openxmlformats.org/officeDocument/2006/relationships">
   <p:cSld>
     <p:bg>
       <p:bgPr>
@@ -4540,14 +4475,7 @@
         <p:cNvGrpSpPr/>
         <p:nvPr/>
       </p:nvGrpSpPr>
-      <p:grpSpPr>
-        <a:xfrm>
-          <a:off x="0" y="0"/>
-          <a:ext cx="0" cy="0"/>
-          <a:chOff x="0" y="0"/>
-          <a:chExt cx="0" cy="0"/>
-        </a:xfrm>
-      </p:grpSpPr>
+      <p:grpSpPr/>
       <p:sp>
         <p:nvSpPr>
           <p:cNvPr id="2" name="Rectangle 1"/>
@@ -4584,7 +4512,7 @@
           </a:fontRef>
         </p:style>
         <p:txBody>
-          <a:bodyPr wrap="square" lIns="457200" tIns="137160" rtlCol="0" anchor="ctr"/>
+          <a:bodyPr rtlCol="0" anchor="ctr" lIns="457200" tIns="137160" wrap="square"/>
           <a:lstStyle/>
           <a:p>
             <a:pPr algn="ctr">
@@ -4640,7 +4568,6 @@
           <a:lstStyle/>
           <a:p>
             <a:pPr algn="ctr"/>
-            <a:endParaRPr/>
           </a:p>
         </p:txBody>
       </p:sp>
@@ -4824,7 +4751,7 @@
 </file>
 
 <file path=ppt/slides/slide15.xml><?xml version="1.0" encoding="utf-8"?>
-<p:sld xmlns:a="http://schemas.openxmlformats.org/drawingml/2006/main" xmlns:r="http://schemas.openxmlformats.org/officeDocument/2006/relationships" xmlns:p="http://schemas.openxmlformats.org/presentationml/2006/main">
+<p:sld xmlns:a="http://schemas.openxmlformats.org/drawingml/2006/main" xmlns:p="http://schemas.openxmlformats.org/presentationml/2006/main" xmlns:r="http://schemas.openxmlformats.org/officeDocument/2006/relationships">
   <p:cSld>
     <p:bg>
       <p:bgPr>
@@ -4840,14 +4767,7 @@
         <p:cNvGrpSpPr/>
         <p:nvPr/>
       </p:nvGrpSpPr>
-      <p:grpSpPr>
-        <a:xfrm>
-          <a:off x="0" y="0"/>
-          <a:ext cx="0" cy="0"/>
-          <a:chOff x="0" y="0"/>
-          <a:chExt cx="0" cy="0"/>
-        </a:xfrm>
-      </p:grpSpPr>
+      <p:grpSpPr/>
       <p:sp>
         <p:nvSpPr>
           <p:cNvPr id="2" name="Rectangle 1"/>
@@ -4888,7 +4808,6 @@
           <a:lstStyle/>
           <a:p>
             <a:pPr algn="ctr"/>
-            <a:endParaRPr/>
           </a:p>
         </p:txBody>
       </p:sp>
@@ -4909,7 +4828,7 @@
           <a:noFill/>
         </p:spPr>
         <p:txBody>
-          <a:bodyPr wrap="square" lIns="45720" tIns="27432" rIns="45720" bIns="27432">
+          <a:bodyPr wrap="square" lIns="45720" rIns="45720" tIns="27432" bIns="27432">
             <a:spAutoFit/>
           </a:bodyPr>
           <a:lstStyle/>
@@ -4947,7 +4866,7 @@
           <a:noFill/>
         </p:spPr>
         <p:txBody>
-          <a:bodyPr wrap="square" lIns="45720" tIns="27432" rIns="45720" bIns="27432">
+          <a:bodyPr wrap="square" lIns="45720" rIns="45720" tIns="27432" bIns="27432">
             <a:spAutoFit/>
           </a:bodyPr>
           <a:lstStyle/>
@@ -4985,7 +4904,7 @@
           <a:noFill/>
         </p:spPr>
         <p:txBody>
-          <a:bodyPr wrap="square" lIns="45720" tIns="27432" rIns="45720" bIns="27432">
+          <a:bodyPr wrap="square" lIns="45720" rIns="45720" tIns="27432" bIns="27432">
             <a:spAutoFit/>
           </a:bodyPr>
           <a:lstStyle/>
@@ -5030,7 +4949,7 @@
 </file>
 
 <file path=ppt/slides/slide2.xml><?xml version="1.0" encoding="utf-8"?>
-<p:sld xmlns:a="http://schemas.openxmlformats.org/drawingml/2006/main" xmlns:r="http://schemas.openxmlformats.org/officeDocument/2006/relationships" xmlns:p="http://schemas.openxmlformats.org/presentationml/2006/main">
+<p:sld xmlns:a="http://schemas.openxmlformats.org/drawingml/2006/main" xmlns:p="http://schemas.openxmlformats.org/presentationml/2006/main" xmlns:r="http://schemas.openxmlformats.org/officeDocument/2006/relationships">
   <p:cSld>
     <p:bg>
       <p:bgPr>
@@ -5046,14 +4965,7 @@
         <p:cNvGrpSpPr/>
         <p:nvPr/>
       </p:nvGrpSpPr>
-      <p:grpSpPr>
-        <a:xfrm>
-          <a:off x="0" y="0"/>
-          <a:ext cx="0" cy="0"/>
-          <a:chOff x="0" y="0"/>
-          <a:chExt cx="0" cy="0"/>
-        </a:xfrm>
-      </p:grpSpPr>
+      <p:grpSpPr/>
       <p:sp>
         <p:nvSpPr>
           <p:cNvPr id="2" name="Rectangle 1"/>
@@ -5090,7 +5002,7 @@
           </a:fontRef>
         </p:style>
         <p:txBody>
-          <a:bodyPr wrap="square" lIns="457200" tIns="137160" rtlCol="0" anchor="ctr"/>
+          <a:bodyPr rtlCol="0" anchor="ctr" lIns="457200" tIns="137160" wrap="square"/>
           <a:lstStyle/>
           <a:p>
             <a:pPr algn="ctr">
@@ -5146,7 +5058,6 @@
           <a:lstStyle/>
           <a:p>
             <a:pPr algn="ctr"/>
-            <a:endParaRPr/>
           </a:p>
         </p:txBody>
       </p:sp>
@@ -5187,7 +5098,7 @@
           </a:fontRef>
         </p:style>
         <p:txBody>
-          <a:bodyPr wrap="square" rtlCol="0" anchor="ctr"/>
+          <a:bodyPr rtlCol="0" anchor="ctr" wrap="square"/>
           <a:lstStyle/>
           <a:p>
             <a:pPr algn="ctr">
@@ -5220,7 +5131,7 @@
           <a:noFill/>
         </p:spPr>
         <p:txBody>
-          <a:bodyPr wrap="square" lIns="45720" tIns="27432" rIns="45720" bIns="27432">
+          <a:bodyPr wrap="square" lIns="45720" rIns="45720" tIns="27432" bIns="27432">
             <a:spAutoFit/>
           </a:bodyPr>
           <a:lstStyle/>
@@ -5236,26 +5147,8 @@
               </a:defRPr>
             </a:pPr>
             <a:r>
-              <a:rPr dirty="0" err="1"/>
-              <a:t>Contexte</a:t>
-            </a:r>
-            <a:r>
-              <a:rPr dirty="0"/>
-              <a:t>, </a:t>
-            </a:r>
-            <a:r>
-              <a:rPr dirty="0" err="1"/>
-              <a:t>objectifs</a:t>
-            </a:r>
-            <a:r>
-              <a:rPr dirty="0"/>
-              <a:t> et </a:t>
-            </a:r>
-            <a:r>
-              <a:rPr dirty="0" err="1"/>
-              <a:t>problématique</a:t>
-            </a:r>
-            <a:endParaRPr dirty="0"/>
+              <a:t>Contexte, objectifs et problématique</a:t>
+            </a:r>
           </a:p>
         </p:txBody>
       </p:sp>
@@ -5296,7 +5189,7 @@
           </a:fontRef>
         </p:style>
         <p:txBody>
-          <a:bodyPr wrap="square" rtlCol="0" anchor="ctr"/>
+          <a:bodyPr rtlCol="0" anchor="ctr" wrap="square"/>
           <a:lstStyle/>
           <a:p>
             <a:pPr algn="ctr">
@@ -5329,7 +5222,7 @@
           <a:noFill/>
         </p:spPr>
         <p:txBody>
-          <a:bodyPr wrap="square" lIns="45720" tIns="27432" rIns="45720" bIns="27432">
+          <a:bodyPr wrap="square" lIns="45720" rIns="45720" tIns="27432" bIns="27432">
             <a:spAutoFit/>
           </a:bodyPr>
           <a:lstStyle/>
@@ -5387,7 +5280,7 @@
           </a:fontRef>
         </p:style>
         <p:txBody>
-          <a:bodyPr wrap="square" rtlCol="0" anchor="ctr"/>
+          <a:bodyPr rtlCol="0" anchor="ctr" wrap="square"/>
           <a:lstStyle/>
           <a:p>
             <a:pPr algn="ctr">
@@ -5420,7 +5313,7 @@
           <a:noFill/>
         </p:spPr>
         <p:txBody>
-          <a:bodyPr wrap="square" lIns="45720" tIns="27432" rIns="45720" bIns="27432">
+          <a:bodyPr wrap="square" lIns="45720" rIns="45720" tIns="27432" bIns="27432">
             <a:spAutoFit/>
           </a:bodyPr>
           <a:lstStyle/>
@@ -5478,7 +5371,7 @@
           </a:fontRef>
         </p:style>
         <p:txBody>
-          <a:bodyPr wrap="square" rtlCol="0" anchor="ctr"/>
+          <a:bodyPr rtlCol="0" anchor="ctr" wrap="square"/>
           <a:lstStyle/>
           <a:p>
             <a:pPr algn="ctr">
@@ -5511,7 +5404,7 @@
           <a:noFill/>
         </p:spPr>
         <p:txBody>
-          <a:bodyPr wrap="square" lIns="45720" tIns="27432" rIns="45720" bIns="27432">
+          <a:bodyPr wrap="square" lIns="45720" rIns="45720" tIns="27432" bIns="27432">
             <a:spAutoFit/>
           </a:bodyPr>
           <a:lstStyle/>
@@ -5569,7 +5462,7 @@
           </a:fontRef>
         </p:style>
         <p:txBody>
-          <a:bodyPr wrap="square" rtlCol="0" anchor="ctr"/>
+          <a:bodyPr rtlCol="0" anchor="ctr" wrap="square"/>
           <a:lstStyle/>
           <a:p>
             <a:pPr algn="ctr">
@@ -5602,7 +5495,7 @@
           <a:noFill/>
         </p:spPr>
         <p:txBody>
-          <a:bodyPr wrap="square" lIns="45720" tIns="27432" rIns="45720" bIns="27432">
+          <a:bodyPr wrap="square" lIns="45720" rIns="45720" tIns="27432" bIns="27432">
             <a:spAutoFit/>
           </a:bodyPr>
           <a:lstStyle/>
@@ -5660,7 +5553,7 @@
           </a:fontRef>
         </p:style>
         <p:txBody>
-          <a:bodyPr wrap="square" rtlCol="0" anchor="ctr"/>
+          <a:bodyPr rtlCol="0" anchor="ctr" wrap="square"/>
           <a:lstStyle/>
           <a:p>
             <a:pPr algn="ctr">
@@ -5693,7 +5586,7 @@
           <a:noFill/>
         </p:spPr>
         <p:txBody>
-          <a:bodyPr wrap="square" lIns="45720" tIns="27432" rIns="45720" bIns="27432">
+          <a:bodyPr wrap="square" lIns="45720" rIns="45720" tIns="27432" bIns="27432">
             <a:spAutoFit/>
           </a:bodyPr>
           <a:lstStyle/>
@@ -5758,7 +5651,7 @@
 </file>
 
 <file path=ppt/slides/slide3.xml><?xml version="1.0" encoding="utf-8"?>
-<p:sld xmlns:a="http://schemas.openxmlformats.org/drawingml/2006/main" xmlns:r="http://schemas.openxmlformats.org/officeDocument/2006/relationships" xmlns:p="http://schemas.openxmlformats.org/presentationml/2006/main">
+<p:sld xmlns:a="http://schemas.openxmlformats.org/drawingml/2006/main" xmlns:p="http://schemas.openxmlformats.org/presentationml/2006/main" xmlns:r="http://schemas.openxmlformats.org/officeDocument/2006/relationships">
   <p:cSld>
     <p:bg>
       <p:bgPr>
@@ -5774,14 +5667,7 @@
         <p:cNvGrpSpPr/>
         <p:nvPr/>
       </p:nvGrpSpPr>
-      <p:grpSpPr>
-        <a:xfrm>
-          <a:off x="0" y="0"/>
-          <a:ext cx="0" cy="0"/>
-          <a:chOff x="0" y="0"/>
-          <a:chExt cx="0" cy="0"/>
-        </a:xfrm>
-      </p:grpSpPr>
+      <p:grpSpPr/>
       <p:sp>
         <p:nvSpPr>
           <p:cNvPr id="2" name="Rectangle 1"/>
@@ -5818,7 +5704,7 @@
           </a:fontRef>
         </p:style>
         <p:txBody>
-          <a:bodyPr wrap="square" lIns="457200" tIns="137160" rtlCol="0" anchor="ctr"/>
+          <a:bodyPr rtlCol="0" anchor="ctr" lIns="457200" tIns="137160" wrap="square"/>
           <a:lstStyle/>
           <a:p>
             <a:pPr algn="ctr">
@@ -5874,7 +5760,6 @@
           <a:lstStyle/>
           <a:p>
             <a:pPr algn="ctr"/>
-            <a:endParaRPr/>
           </a:p>
         </p:txBody>
       </p:sp>
@@ -6002,7 +5887,6 @@
           <a:lstStyle/>
           <a:p>
             <a:pPr algn="ctr"/>
-            <a:endParaRPr/>
           </a:p>
         </p:txBody>
       </p:sp>
@@ -6023,7 +5907,7 @@
           <a:noFill/>
         </p:spPr>
         <p:txBody>
-          <a:bodyPr wrap="square" lIns="45720" tIns="27432" rIns="45720" bIns="27432">
+          <a:bodyPr wrap="square" lIns="45720" rIns="45720" tIns="27432" bIns="27432">
             <a:spAutoFit/>
           </a:bodyPr>
           <a:lstStyle/>
@@ -6088,7 +5972,7 @@
 </file>
 
 <file path=ppt/slides/slide4.xml><?xml version="1.0" encoding="utf-8"?>
-<p:sld xmlns:a="http://schemas.openxmlformats.org/drawingml/2006/main" xmlns:r="http://schemas.openxmlformats.org/officeDocument/2006/relationships" xmlns:p="http://schemas.openxmlformats.org/presentationml/2006/main">
+<p:sld xmlns:a="http://schemas.openxmlformats.org/drawingml/2006/main" xmlns:p="http://schemas.openxmlformats.org/presentationml/2006/main" xmlns:r="http://schemas.openxmlformats.org/officeDocument/2006/relationships">
   <p:cSld>
     <p:bg>
       <p:bgPr>
@@ -6104,14 +5988,7 @@
         <p:cNvGrpSpPr/>
         <p:nvPr/>
       </p:nvGrpSpPr>
-      <p:grpSpPr>
-        <a:xfrm>
-          <a:off x="0" y="0"/>
-          <a:ext cx="0" cy="0"/>
-          <a:chOff x="0" y="0"/>
-          <a:chExt cx="0" cy="0"/>
-        </a:xfrm>
-      </p:grpSpPr>
+      <p:grpSpPr/>
       <p:sp>
         <p:nvSpPr>
           <p:cNvPr id="2" name="Rectangle 1"/>
@@ -6148,7 +6025,7 @@
           </a:fontRef>
         </p:style>
         <p:txBody>
-          <a:bodyPr wrap="square" lIns="457200" tIns="137160" rtlCol="0" anchor="ctr"/>
+          <a:bodyPr rtlCol="0" anchor="ctr" lIns="457200" tIns="137160" wrap="square"/>
           <a:lstStyle/>
           <a:p>
             <a:pPr algn="ctr">
@@ -6204,7 +6081,6 @@
           <a:lstStyle/>
           <a:p>
             <a:pPr algn="ctr"/>
-            <a:endParaRPr/>
           </a:p>
         </p:txBody>
       </p:sp>
@@ -6245,7 +6121,7 @@
           </a:fontRef>
         </p:style>
         <p:txBody>
-          <a:bodyPr wrap="square" rtlCol="0" anchor="ctr"/>
+          <a:bodyPr rtlCol="0" anchor="ctr" wrap="square"/>
           <a:lstStyle/>
           <a:p>
             <a:pPr algn="ctr">
@@ -6278,7 +6154,7 @@
           <a:noFill/>
         </p:spPr>
         <p:txBody>
-          <a:bodyPr wrap="square" lIns="45720" tIns="27432" rIns="45720" bIns="27432">
+          <a:bodyPr wrap="square" lIns="45720" rIns="45720" tIns="27432" bIns="27432">
             <a:spAutoFit/>
           </a:bodyPr>
           <a:lstStyle/>
@@ -6336,7 +6212,7 @@
           </a:fontRef>
         </p:style>
         <p:txBody>
-          <a:bodyPr wrap="square" rtlCol="0" anchor="ctr"/>
+          <a:bodyPr rtlCol="0" anchor="ctr" wrap="square"/>
           <a:lstStyle/>
           <a:p>
             <a:pPr algn="ctr">
@@ -6369,7 +6245,7 @@
           <a:noFill/>
         </p:spPr>
         <p:txBody>
-          <a:bodyPr wrap="square" lIns="45720" tIns="27432" rIns="45720" bIns="27432">
+          <a:bodyPr wrap="square" lIns="45720" rIns="45720" tIns="27432" bIns="27432">
             <a:spAutoFit/>
           </a:bodyPr>
           <a:lstStyle/>
@@ -6427,7 +6303,7 @@
           </a:fontRef>
         </p:style>
         <p:txBody>
-          <a:bodyPr wrap="square" rtlCol="0" anchor="ctr"/>
+          <a:bodyPr rtlCol="0" anchor="ctr" wrap="square"/>
           <a:lstStyle/>
           <a:p>
             <a:pPr algn="ctr">
@@ -6460,7 +6336,7 @@
           <a:noFill/>
         </p:spPr>
         <p:txBody>
-          <a:bodyPr wrap="square" lIns="45720" tIns="27432" rIns="45720" bIns="27432">
+          <a:bodyPr wrap="square" lIns="45720" rIns="45720" tIns="27432" bIns="27432">
             <a:spAutoFit/>
           </a:bodyPr>
           <a:lstStyle/>
@@ -6518,7 +6394,7 @@
           </a:fontRef>
         </p:style>
         <p:txBody>
-          <a:bodyPr wrap="square" rtlCol="0" anchor="ctr"/>
+          <a:bodyPr rtlCol="0" anchor="ctr" wrap="square"/>
           <a:lstStyle/>
           <a:p>
             <a:pPr algn="ctr">
@@ -6551,7 +6427,7 @@
           <a:noFill/>
         </p:spPr>
         <p:txBody>
-          <a:bodyPr wrap="square" lIns="45720" tIns="27432" rIns="45720" bIns="27432">
+          <a:bodyPr wrap="square" lIns="45720" rIns="45720" tIns="27432" bIns="27432">
             <a:spAutoFit/>
           </a:bodyPr>
           <a:lstStyle/>
@@ -6609,7 +6485,7 @@
           </a:fontRef>
         </p:style>
         <p:txBody>
-          <a:bodyPr wrap="square" rtlCol="0" anchor="ctr"/>
+          <a:bodyPr rtlCol="0" anchor="ctr" wrap="square"/>
           <a:lstStyle/>
           <a:p>
             <a:pPr algn="ctr">
@@ -6642,7 +6518,7 @@
           <a:noFill/>
         </p:spPr>
         <p:txBody>
-          <a:bodyPr wrap="square" lIns="45720" tIns="27432" rIns="45720" bIns="27432">
+          <a:bodyPr wrap="square" lIns="45720" rIns="45720" tIns="27432" bIns="27432">
             <a:spAutoFit/>
           </a:bodyPr>
           <a:lstStyle/>
@@ -6700,7 +6576,7 @@
           </a:fontRef>
         </p:style>
         <p:txBody>
-          <a:bodyPr wrap="square" rtlCol="0" anchor="ctr"/>
+          <a:bodyPr rtlCol="0" anchor="ctr" wrap="square"/>
           <a:lstStyle/>
           <a:p>
             <a:pPr algn="ctr">
@@ -6733,7 +6609,7 @@
           <a:noFill/>
         </p:spPr>
         <p:txBody>
-          <a:bodyPr wrap="square" lIns="45720" tIns="27432" rIns="45720" bIns="27432">
+          <a:bodyPr wrap="square" lIns="45720" rIns="45720" tIns="27432" bIns="27432">
             <a:spAutoFit/>
           </a:bodyPr>
           <a:lstStyle/>
@@ -6798,7 +6674,7 @@
 </file>
 
 <file path=ppt/slides/slide5.xml><?xml version="1.0" encoding="utf-8"?>
-<p:sld xmlns:a="http://schemas.openxmlformats.org/drawingml/2006/main" xmlns:r="http://schemas.openxmlformats.org/officeDocument/2006/relationships" xmlns:p="http://schemas.openxmlformats.org/presentationml/2006/main">
+<p:sld xmlns:a="http://schemas.openxmlformats.org/drawingml/2006/main" xmlns:p="http://schemas.openxmlformats.org/presentationml/2006/main" xmlns:r="http://schemas.openxmlformats.org/officeDocument/2006/relationships">
   <p:cSld>
     <p:bg>
       <p:bgPr>
@@ -6814,14 +6690,7 @@
         <p:cNvGrpSpPr/>
         <p:nvPr/>
       </p:nvGrpSpPr>
-      <p:grpSpPr>
-        <a:xfrm>
-          <a:off x="0" y="0"/>
-          <a:ext cx="0" cy="0"/>
-          <a:chOff x="0" y="0"/>
-          <a:chExt cx="0" cy="0"/>
-        </a:xfrm>
-      </p:grpSpPr>
+      <p:grpSpPr/>
       <p:sp>
         <p:nvSpPr>
           <p:cNvPr id="2" name="Rectangle 1"/>
@@ -6858,7 +6727,7 @@
           </a:fontRef>
         </p:style>
         <p:txBody>
-          <a:bodyPr wrap="square" lIns="457200" tIns="137160" rtlCol="0" anchor="ctr"/>
+          <a:bodyPr rtlCol="0" anchor="ctr" lIns="457200" tIns="137160" wrap="square"/>
           <a:lstStyle/>
           <a:p>
             <a:pPr algn="ctr">
@@ -6914,7 +6783,6 @@
           <a:lstStyle/>
           <a:p>
             <a:pPr algn="ctr"/>
-            <a:endParaRPr/>
           </a:p>
         </p:txBody>
       </p:sp>
@@ -7098,7 +6966,7 @@
 </file>
 
 <file path=ppt/slides/slide6.xml><?xml version="1.0" encoding="utf-8"?>
-<p:sld xmlns:a="http://schemas.openxmlformats.org/drawingml/2006/main" xmlns:r="http://schemas.openxmlformats.org/officeDocument/2006/relationships" xmlns:p="http://schemas.openxmlformats.org/presentationml/2006/main">
+<p:sld xmlns:a="http://schemas.openxmlformats.org/drawingml/2006/main" xmlns:p="http://schemas.openxmlformats.org/presentationml/2006/main" xmlns:r="http://schemas.openxmlformats.org/officeDocument/2006/relationships">
   <p:cSld>
     <p:bg>
       <p:bgPr>
@@ -7114,14 +6982,7 @@
         <p:cNvGrpSpPr/>
         <p:nvPr/>
       </p:nvGrpSpPr>
-      <p:grpSpPr>
-        <a:xfrm>
-          <a:off x="0" y="0"/>
-          <a:ext cx="0" cy="0"/>
-          <a:chOff x="0" y="0"/>
-          <a:chExt cx="0" cy="0"/>
-        </a:xfrm>
-      </p:grpSpPr>
+      <p:grpSpPr/>
       <p:sp>
         <p:nvSpPr>
           <p:cNvPr id="2" name="Rectangle 1"/>
@@ -7158,7 +7019,7 @@
           </a:fontRef>
         </p:style>
         <p:txBody>
-          <a:bodyPr wrap="square" lIns="457200" tIns="137160" rtlCol="0" anchor="ctr"/>
+          <a:bodyPr rtlCol="0" anchor="ctr" lIns="457200" tIns="137160" wrap="square"/>
           <a:lstStyle/>
           <a:p>
             <a:pPr algn="ctr">
@@ -7214,7 +7075,6 @@
           <a:lstStyle/>
           <a:p>
             <a:pPr algn="ctr"/>
-            <a:endParaRPr/>
           </a:p>
         </p:txBody>
       </p:sp>
@@ -7259,7 +7119,6 @@
           <a:lstStyle/>
           <a:p>
             <a:pPr algn="ctr"/>
-            <a:endParaRPr/>
           </a:p>
         </p:txBody>
       </p:sp>
@@ -7280,7 +7139,7 @@
           <a:noFill/>
         </p:spPr>
         <p:txBody>
-          <a:bodyPr wrap="square" lIns="45720" tIns="27432" rIns="45720" bIns="27432">
+          <a:bodyPr wrap="square" lIns="45720" rIns="45720" tIns="27432" bIns="27432">
             <a:spAutoFit/>
           </a:bodyPr>
           <a:lstStyle/>
@@ -7318,7 +7177,7 @@
           <a:noFill/>
         </p:spPr>
         <p:txBody>
-          <a:bodyPr wrap="square" lIns="45720" tIns="27432" rIns="45720" bIns="27432">
+          <a:bodyPr wrap="square" lIns="45720" rIns="45720" tIns="27432" bIns="27432">
             <a:spAutoFit/>
           </a:bodyPr>
           <a:lstStyle/>
@@ -7356,7 +7215,7 @@
           <a:noFill/>
         </p:spPr>
         <p:txBody>
-          <a:bodyPr wrap="square" lIns="45720" tIns="27432" rIns="45720" bIns="27432">
+          <a:bodyPr wrap="square" lIns="45720" rIns="45720" tIns="27432" bIns="27432">
             <a:spAutoFit/>
           </a:bodyPr>
           <a:lstStyle/>
@@ -7418,7 +7277,6 @@
           <a:lstStyle/>
           <a:p>
             <a:pPr algn="ctr"/>
-            <a:endParaRPr/>
           </a:p>
         </p:txBody>
       </p:sp>
@@ -7439,7 +7297,7 @@
           <a:noFill/>
         </p:spPr>
         <p:txBody>
-          <a:bodyPr wrap="square" lIns="45720" tIns="27432" rIns="45720" bIns="27432">
+          <a:bodyPr wrap="square" lIns="45720" rIns="45720" tIns="27432" bIns="27432">
             <a:spAutoFit/>
           </a:bodyPr>
           <a:lstStyle/>
@@ -7477,7 +7335,7 @@
           <a:noFill/>
         </p:spPr>
         <p:txBody>
-          <a:bodyPr wrap="square" lIns="45720" tIns="27432" rIns="45720" bIns="27432">
+          <a:bodyPr wrap="square" lIns="45720" rIns="45720" tIns="27432" bIns="27432">
             <a:spAutoFit/>
           </a:bodyPr>
           <a:lstStyle/>
@@ -7515,7 +7373,7 @@
           <a:noFill/>
         </p:spPr>
         <p:txBody>
-          <a:bodyPr wrap="square" lIns="45720" tIns="27432" rIns="45720" bIns="27432">
+          <a:bodyPr wrap="square" lIns="45720" rIns="45720" tIns="27432" bIns="27432">
             <a:spAutoFit/>
           </a:bodyPr>
           <a:lstStyle/>
@@ -7577,7 +7435,6 @@
           <a:lstStyle/>
           <a:p>
             <a:pPr algn="ctr"/>
-            <a:endParaRPr/>
           </a:p>
         </p:txBody>
       </p:sp>
@@ -7598,7 +7455,7 @@
           <a:noFill/>
         </p:spPr>
         <p:txBody>
-          <a:bodyPr wrap="square" lIns="45720" tIns="27432" rIns="45720" bIns="27432">
+          <a:bodyPr wrap="square" lIns="45720" rIns="45720" tIns="27432" bIns="27432">
             <a:spAutoFit/>
           </a:bodyPr>
           <a:lstStyle/>
@@ -7636,7 +7493,7 @@
           <a:noFill/>
         </p:spPr>
         <p:txBody>
-          <a:bodyPr wrap="square" lIns="45720" tIns="27432" rIns="45720" bIns="27432">
+          <a:bodyPr wrap="square" lIns="45720" rIns="45720" tIns="27432" bIns="27432">
             <a:spAutoFit/>
           </a:bodyPr>
           <a:lstStyle/>
@@ -7674,7 +7531,7 @@
           <a:noFill/>
         </p:spPr>
         <p:txBody>
-          <a:bodyPr wrap="square" lIns="45720" tIns="27432" rIns="45720" bIns="27432">
+          <a:bodyPr wrap="square" lIns="45720" rIns="45720" tIns="27432" bIns="27432">
             <a:spAutoFit/>
           </a:bodyPr>
           <a:lstStyle/>
@@ -7736,7 +7593,6 @@
           <a:lstStyle/>
           <a:p>
             <a:pPr algn="ctr"/>
-            <a:endParaRPr/>
           </a:p>
         </p:txBody>
       </p:sp>
@@ -7757,7 +7613,7 @@
           <a:noFill/>
         </p:spPr>
         <p:txBody>
-          <a:bodyPr wrap="square" lIns="45720" tIns="27432" rIns="45720" bIns="27432">
+          <a:bodyPr wrap="square" lIns="45720" rIns="45720" tIns="27432" bIns="27432">
             <a:spAutoFit/>
           </a:bodyPr>
           <a:lstStyle/>
@@ -7795,7 +7651,7 @@
           <a:noFill/>
         </p:spPr>
         <p:txBody>
-          <a:bodyPr wrap="square" lIns="45720" tIns="27432" rIns="45720" bIns="27432">
+          <a:bodyPr wrap="square" lIns="45720" rIns="45720" tIns="27432" bIns="27432">
             <a:spAutoFit/>
           </a:bodyPr>
           <a:lstStyle/>
@@ -7833,7 +7689,7 @@
           <a:noFill/>
         </p:spPr>
         <p:txBody>
-          <a:bodyPr wrap="square" lIns="45720" tIns="27432" rIns="45720" bIns="27432">
+          <a:bodyPr wrap="square" lIns="45720" rIns="45720" tIns="27432" bIns="27432">
             <a:spAutoFit/>
           </a:bodyPr>
           <a:lstStyle/>
@@ -7898,7 +7754,7 @@
 </file>
 
 <file path=ppt/slides/slide7.xml><?xml version="1.0" encoding="utf-8"?>
-<p:sld xmlns:a="http://schemas.openxmlformats.org/drawingml/2006/main" xmlns:r="http://schemas.openxmlformats.org/officeDocument/2006/relationships" xmlns:p="http://schemas.openxmlformats.org/presentationml/2006/main">
+<p:sld xmlns:a="http://schemas.openxmlformats.org/drawingml/2006/main" xmlns:p="http://schemas.openxmlformats.org/presentationml/2006/main" xmlns:r="http://schemas.openxmlformats.org/officeDocument/2006/relationships">
   <p:cSld>
     <p:bg>
       <p:bgPr>
@@ -7914,14 +7770,7 @@
         <p:cNvGrpSpPr/>
         <p:nvPr/>
       </p:nvGrpSpPr>
-      <p:grpSpPr>
-        <a:xfrm>
-          <a:off x="0" y="0"/>
-          <a:ext cx="0" cy="0"/>
-          <a:chOff x="0" y="0"/>
-          <a:chExt cx="0" cy="0"/>
-        </a:xfrm>
-      </p:grpSpPr>
+      <p:grpSpPr/>
       <p:sp>
         <p:nvSpPr>
           <p:cNvPr id="2" name="Rectangle 1"/>
@@ -7958,7 +7807,7 @@
           </a:fontRef>
         </p:style>
         <p:txBody>
-          <a:bodyPr wrap="square" lIns="457200" tIns="137160" rtlCol="0" anchor="ctr"/>
+          <a:bodyPr rtlCol="0" anchor="ctr" lIns="457200" tIns="137160" wrap="square"/>
           <a:lstStyle/>
           <a:p>
             <a:pPr algn="ctr">
@@ -8014,7 +7863,6 @@
           <a:lstStyle/>
           <a:p>
             <a:pPr algn="ctr"/>
-            <a:endParaRPr/>
           </a:p>
         </p:txBody>
       </p:sp>
@@ -8163,7 +8011,7 @@
           <a:noFill/>
         </p:spPr>
         <p:txBody>
-          <a:bodyPr wrap="square" lIns="45720" tIns="27432" rIns="45720" bIns="27432">
+          <a:bodyPr wrap="square" lIns="45720" rIns="45720" tIns="27432" bIns="27432">
             <a:spAutoFit/>
           </a:bodyPr>
           <a:lstStyle/>
@@ -8225,7 +8073,6 @@
           <a:lstStyle/>
           <a:p>
             <a:pPr algn="ctr"/>
-            <a:endParaRPr/>
           </a:p>
         </p:txBody>
       </p:sp>
@@ -8270,7 +8117,6 @@
           <a:lstStyle/>
           <a:p>
             <a:pPr algn="ctr"/>
-            <a:endParaRPr/>
           </a:p>
         </p:txBody>
       </p:sp>
@@ -8291,7 +8137,7 @@
           <a:noFill/>
         </p:spPr>
         <p:txBody>
-          <a:bodyPr wrap="square" lIns="45720" tIns="27432" rIns="45720" bIns="27432">
+          <a:bodyPr wrap="square" lIns="45720" rIns="45720" tIns="27432" bIns="27432">
             <a:spAutoFit/>
           </a:bodyPr>
           <a:lstStyle/>
@@ -8329,7 +8175,7 @@
           <a:noFill/>
         </p:spPr>
         <p:txBody>
-          <a:bodyPr wrap="square" lIns="45720" tIns="27432" rIns="45720" bIns="27432">
+          <a:bodyPr wrap="square" lIns="45720" rIns="45720" tIns="27432" bIns="27432">
             <a:spAutoFit/>
           </a:bodyPr>
           <a:lstStyle/>
@@ -8394,7 +8240,7 @@
 </file>
 
 <file path=ppt/slides/slide8.xml><?xml version="1.0" encoding="utf-8"?>
-<p:sld xmlns:a="http://schemas.openxmlformats.org/drawingml/2006/main" xmlns:r="http://schemas.openxmlformats.org/officeDocument/2006/relationships" xmlns:p="http://schemas.openxmlformats.org/presentationml/2006/main">
+<p:sld xmlns:a="http://schemas.openxmlformats.org/drawingml/2006/main" xmlns:p="http://schemas.openxmlformats.org/presentationml/2006/main" xmlns:r="http://schemas.openxmlformats.org/officeDocument/2006/relationships">
   <p:cSld>
     <p:bg>
       <p:bgPr>
@@ -8410,14 +8256,7 @@
         <p:cNvGrpSpPr/>
         <p:nvPr/>
       </p:nvGrpSpPr>
-      <p:grpSpPr>
-        <a:xfrm>
-          <a:off x="0" y="0"/>
-          <a:ext cx="0" cy="0"/>
-          <a:chOff x="0" y="0"/>
-          <a:chExt cx="0" cy="0"/>
-        </a:xfrm>
-      </p:grpSpPr>
+      <p:grpSpPr/>
       <p:sp>
         <p:nvSpPr>
           <p:cNvPr id="2" name="Rectangle 1"/>
@@ -8454,7 +8293,7 @@
           </a:fontRef>
         </p:style>
         <p:txBody>
-          <a:bodyPr wrap="square" lIns="457200" tIns="137160" rtlCol="0" anchor="ctr"/>
+          <a:bodyPr rtlCol="0" anchor="ctr" lIns="457200" tIns="137160" wrap="square"/>
           <a:lstStyle/>
           <a:p>
             <a:pPr algn="ctr">
@@ -8510,7 +8349,6 @@
           <a:lstStyle/>
           <a:p>
             <a:pPr algn="ctr"/>
-            <a:endParaRPr/>
           </a:p>
         </p:txBody>
       </p:sp>
@@ -8551,7 +8389,7 @@
           </a:fontRef>
         </p:style>
         <p:txBody>
-          <a:bodyPr wrap="square" rtlCol="0" anchor="ctr"/>
+          <a:bodyPr rtlCol="0" anchor="ctr" wrap="square"/>
           <a:lstStyle/>
           <a:p>
             <a:pPr algn="ctr">
@@ -8627,7 +8465,6 @@
           <a:lstStyle/>
           <a:p>
             <a:pPr algn="ctr"/>
-            <a:endParaRPr/>
           </a:p>
         </p:txBody>
       </p:sp>
@@ -8668,7 +8505,7 @@
           </a:fontRef>
         </p:style>
         <p:txBody>
-          <a:bodyPr wrap="square" rtlCol="0" anchor="ctr"/>
+          <a:bodyPr rtlCol="0" anchor="ctr" wrap="square"/>
           <a:lstStyle/>
           <a:p>
             <a:pPr algn="ctr">
@@ -8740,7 +8577,6 @@
           <a:lstStyle/>
           <a:p>
             <a:pPr algn="ctr"/>
-            <a:endParaRPr/>
           </a:p>
         </p:txBody>
       </p:sp>
@@ -8781,7 +8617,7 @@
           </a:fontRef>
         </p:style>
         <p:txBody>
-          <a:bodyPr wrap="square" rtlCol="0" anchor="ctr"/>
+          <a:bodyPr rtlCol="0" anchor="ctr" wrap="square"/>
           <a:lstStyle/>
           <a:p>
             <a:pPr algn="ctr">
@@ -8830,7 +8666,7 @@
           <a:noFill/>
         </p:spPr>
         <p:txBody>
-          <a:bodyPr wrap="square" lIns="45720" tIns="27432" rIns="45720" bIns="27432">
+          <a:bodyPr wrap="square" lIns="45720" rIns="45720" tIns="27432" bIns="27432">
             <a:spAutoFit/>
           </a:bodyPr>
           <a:lstStyle/>
@@ -8895,7 +8731,7 @@
 </file>
 
 <file path=ppt/slides/slide9.xml><?xml version="1.0" encoding="utf-8"?>
-<p:sld xmlns:a="http://schemas.openxmlformats.org/drawingml/2006/main" xmlns:r="http://schemas.openxmlformats.org/officeDocument/2006/relationships" xmlns:p="http://schemas.openxmlformats.org/presentationml/2006/main">
+<p:sld xmlns:a="http://schemas.openxmlformats.org/drawingml/2006/main" xmlns:p="http://schemas.openxmlformats.org/presentationml/2006/main" xmlns:r="http://schemas.openxmlformats.org/officeDocument/2006/relationships">
   <p:cSld>
     <p:bg>
       <p:bgPr>
@@ -8911,14 +8747,7 @@
         <p:cNvGrpSpPr/>
         <p:nvPr/>
       </p:nvGrpSpPr>
-      <p:grpSpPr>
-        <a:xfrm>
-          <a:off x="0" y="0"/>
-          <a:ext cx="0" cy="0"/>
-          <a:chOff x="0" y="0"/>
-          <a:chExt cx="0" cy="0"/>
-        </a:xfrm>
-      </p:grpSpPr>
+      <p:grpSpPr/>
       <p:sp>
         <p:nvSpPr>
           <p:cNvPr id="2" name="Rectangle 1"/>
@@ -8955,7 +8784,7 @@
           </a:fontRef>
         </p:style>
         <p:txBody>
-          <a:bodyPr wrap="square" lIns="457200" tIns="137160" rtlCol="0" anchor="ctr"/>
+          <a:bodyPr rtlCol="0" anchor="ctr" lIns="457200" tIns="137160" wrap="square"/>
           <a:lstStyle/>
           <a:p>
             <a:pPr algn="ctr">
@@ -9023,13 +8852,12 @@
           <a:lstStyle/>
           <a:p>
             <a:pPr algn="ctr"/>
-            <a:endParaRPr/>
           </a:p>
         </p:txBody>
       </p:sp>
       <p:pic>
         <p:nvPicPr>
-          <p:cNvPr id="4" name="Picture 3" descr="anB_dashboard.png"/>
+          <p:cNvPr id="4" name="Picture 3" descr="anB_dashboard_light.png"/>
           <p:cNvPicPr>
             <a:picLocks noChangeAspect="1"/>
           </p:cNvPicPr>
@@ -9043,8 +8871,8 @@
         </p:blipFill>
         <p:spPr>
           <a:xfrm>
-            <a:off x="1288870" y="1113745"/>
-            <a:ext cx="8736874" cy="5460546"/>
+            <a:off x="822960" y="1280160"/>
+            <a:ext cx="10607040" cy="6629400"/>
           </a:xfrm>
           <a:prstGeom prst="rect">
             <a:avLst/>

</xml_diff>

<commit_message>
refactor(soutenance): slim deck 15->11 slides, merge redundant slides and condense text
</commit_message>
<xml_diff>
--- a/Rapport/Soutenance - Alumni CRM - PreMSc 2026.pptx
+++ b/Rapport/Soutenance - Alumni CRM - PreMSc 2026.pptx
@@ -16,10 +16,6 @@
     <p:sldId id="264" r:id="rId15"/>
     <p:sldId id="265" r:id="rId16"/>
     <p:sldId id="266" r:id="rId17"/>
-    <p:sldId id="267" r:id="rId18"/>
-    <p:sldId id="268" r:id="rId19"/>
-    <p:sldId id="269" r:id="rId20"/>
-    <p:sldId id="270" r:id="rId21"/>
   </p:sldIdLst>
   <p:sldSz cx="12191695" cy="6858000" type="screen4x3"/>
   <p:notesSz cx="6858000" cy="9144000"/>
@@ -3497,19 +3493,7 @@
               </a:defRPr>
             </a:pPr>
             <a:r>
-              <a:t>Démonstration — Espace Alumni</a:t>
-            </a:r>
-          </a:p>
-          <a:p>
-            <a:pPr>
-              <a:defRPr sz="1400">
-                <a:solidFill>
-                  <a:srgbClr val="EFF6FF"/>
-                </a:solidFill>
-              </a:defRPr>
-            </a:pPr>
-            <a:r>
-              <a:t>Profil, parcours, consentement, questionnaire</a:t>
+              <a:t>Bilan, difficultés et perspectives</a:t>
             </a:r>
           </a:p>
         </p:txBody>
@@ -3557,33 +3541,153 @@
           </a:p>
         </p:txBody>
       </p:sp>
-      <p:pic>
-        <p:nvPicPr>
-          <p:cNvPr id="4" name="Picture 3" descr="anC_parcours_light.png"/>
-          <p:cNvPicPr>
-            <a:picLocks noChangeAspect="1"/>
-          </p:cNvPicPr>
-          <p:nvPr/>
-        </p:nvPicPr>
-        <p:blipFill>
-          <a:blip r:embed="rId2"/>
-          <a:stretch>
-            <a:fillRect/>
-          </a:stretch>
-        </p:blipFill>
+      <p:sp>
+        <p:nvSpPr>
+          <p:cNvPr id="4" name="TextBox 3"/>
+          <p:cNvSpPr txBox="1"/>
+          <p:nvPr/>
+        </p:nvSpPr>
         <p:spPr>
           <a:xfrm>
             <a:off x="822960" y="1280160"/>
-            <a:ext cx="10607040" cy="6629400"/>
+            <a:ext cx="10607040" cy="2011680"/>
           </a:xfrm>
           <a:prstGeom prst="rect">
             <a:avLst/>
           </a:prstGeom>
-        </p:spPr>
-      </p:pic>
+          <a:noFill/>
+        </p:spPr>
+        <p:txBody>
+          <a:bodyPr wrap="square" lIns="45720" tIns="27432">
+            <a:spAutoFit/>
+          </a:bodyPr>
+          <a:lstStyle/>
+          <a:p>
+            <a:pPr>
+              <a:spcAft>
+                <a:spcPts val="800"/>
+              </a:spcAft>
+              <a:defRPr sz="1700">
+                <a:solidFill>
+                  <a:srgbClr val="111827"/>
+                </a:solidFill>
+              </a:defRPr>
+            </a:pPr>
+            <a:r>
+              <a:t>• Prototype complet et opérationnel, documenté « comme du code ».</a:t>
+            </a:r>
+          </a:p>
+          <a:p>
+            <a:pPr>
+              <a:spcAft>
+                <a:spcPts val="800"/>
+              </a:spcAft>
+              <a:defRPr sz="1700">
+                <a:solidFill>
+                  <a:srgbClr val="111827"/>
+                </a:solidFill>
+              </a:defRPr>
+            </a:pPr>
+            <a:r>
+              <a:t>• Compétences : full-stack, sécurité applicative, migrations versionnées, RGPD.</a:t>
+            </a:r>
+          </a:p>
+        </p:txBody>
+      </p:sp>
       <p:sp>
         <p:nvSpPr>
           <p:cNvPr id="5" name="TextBox 4"/>
+          <p:cNvSpPr txBox="1"/>
+          <p:nvPr/>
+        </p:nvSpPr>
+        <p:spPr>
+          <a:xfrm>
+            <a:off x="822960" y="3200400"/>
+            <a:ext cx="10607040" cy="1554480"/>
+          </a:xfrm>
+          <a:prstGeom prst="rect">
+            <a:avLst/>
+          </a:prstGeom>
+          <a:noFill/>
+        </p:spPr>
+        <p:txBody>
+          <a:bodyPr wrap="square" lIns="45720" tIns="27432">
+            <a:spAutoFit/>
+          </a:bodyPr>
+          <a:lstStyle/>
+          <a:p>
+            <a:pPr>
+              <a:spcAft>
+                <a:spcPts val="800"/>
+              </a:spcAft>
+              <a:defRPr sz="1600">
+                <a:solidFill>
+                  <a:srgbClr val="111827"/>
+                </a:solidFill>
+              </a:defRPr>
+            </a:pPr>
+            <a:r>
+              <a:t>• Limites assumées : tests automatisés non conservés, newsletter et mise à jour d'expérience à faire.</a:t>
+            </a:r>
+          </a:p>
+        </p:txBody>
+      </p:sp>
+      <p:sp>
+        <p:nvSpPr>
+          <p:cNvPr id="6" name="TextBox 5"/>
+          <p:cNvSpPr txBox="1"/>
+          <p:nvPr/>
+        </p:nvSpPr>
+        <p:spPr>
+          <a:xfrm>
+            <a:off x="822960" y="4480560"/>
+            <a:ext cx="10607040" cy="1828800"/>
+          </a:xfrm>
+          <a:prstGeom prst="rect">
+            <a:avLst/>
+          </a:prstGeom>
+          <a:noFill/>
+        </p:spPr>
+        <p:txBody>
+          <a:bodyPr wrap="square" lIns="45720" tIns="27432">
+            <a:spAutoFit/>
+          </a:bodyPr>
+          <a:lstStyle/>
+          <a:p>
+            <a:pPr>
+              <a:spcAft>
+                <a:spcPts val="600"/>
+              </a:spcAft>
+              <a:defRPr sz="1600">
+                <a:solidFill>
+                  <a:srgbClr val="111827"/>
+                </a:solidFill>
+              </a:defRPr>
+            </a:pPr>
+            <a:r>
+              <a:t>• Court terme : suite de tests, automatisation du questionnaire, frontend newsletter.</a:t>
+            </a:r>
+          </a:p>
+          <a:p>
+            <a:pPr>
+              <a:spcAft>
+                <a:spcPts val="600"/>
+              </a:spcAft>
+              <a:defRPr sz="1600">
+                <a:solidFill>
+                  <a:srgbClr val="111827"/>
+                </a:solidFill>
+              </a:defRPr>
+            </a:pPr>
+            <a:r>
+              <a:t>• Moyen/long terme : mentorat, chiffrement applicatif, application mobile / PWA.</a:t>
+            </a:r>
+          </a:p>
+        </p:txBody>
+      </p:sp>
+      <p:sp>
+        <p:nvSpPr>
+          <p:cNvPr id="7" name="TextBox 6"/>
           <p:cNvSpPr txBox="1"/>
           <p:nvPr/>
         </p:nvSpPr>
@@ -3651,1132 +3755,6 @@
         <p:spPr>
           <a:xfrm>
             <a:off x="0" y="0"/>
-            <a:ext cx="12191695" cy="1005840"/>
-          </a:xfrm>
-          <a:prstGeom prst="rect">
-            <a:avLst/>
-          </a:prstGeom>
-          <a:solidFill>
-            <a:srgbClr val="1E40AF"/>
-          </a:solidFill>
-          <a:ln>
-            <a:noFill/>
-          </a:ln>
-        </p:spPr>
-        <p:style>
-          <a:lnRef idx="1">
-            <a:schemeClr val="accent1"/>
-          </a:lnRef>
-          <a:fillRef idx="3">
-            <a:schemeClr val="accent1"/>
-          </a:fillRef>
-          <a:effectRef idx="2">
-            <a:schemeClr val="accent1"/>
-          </a:effectRef>
-          <a:fontRef idx="minor">
-            <a:schemeClr val="lt1"/>
-          </a:fontRef>
-        </p:style>
-        <p:txBody>
-          <a:bodyPr rtlCol="0" anchor="ctr" lIns="457200" tIns="137160" wrap="square"/>
-          <a:lstStyle/>
-          <a:p>
-            <a:pPr algn="ctr">
-              <a:defRPr sz="2800" b="1">
-                <a:solidFill>
-                  <a:srgbClr val="FFFFFF"/>
-                </a:solidFill>
-              </a:defRPr>
-            </a:pPr>
-            <a:r>
-              <a:t>Conformité RGPD</a:t>
-            </a:r>
-          </a:p>
-        </p:txBody>
-      </p:sp>
-      <p:sp>
-        <p:nvSpPr>
-          <p:cNvPr id="3" name="Rectangle 2"/>
-          <p:cNvSpPr/>
-          <p:nvPr/>
-        </p:nvSpPr>
-        <p:spPr>
-          <a:xfrm>
-            <a:off x="0" y="1005840"/>
-            <a:ext cx="12191695" cy="54864"/>
-          </a:xfrm>
-          <a:prstGeom prst="rect">
-            <a:avLst/>
-          </a:prstGeom>
-          <a:solidFill>
-            <a:srgbClr val="10B981"/>
-          </a:solidFill>
-          <a:ln>
-            <a:noFill/>
-          </a:ln>
-        </p:spPr>
-        <p:style>
-          <a:lnRef idx="1">
-            <a:schemeClr val="accent1"/>
-          </a:lnRef>
-          <a:fillRef idx="3">
-            <a:schemeClr val="accent1"/>
-          </a:fillRef>
-          <a:effectRef idx="2">
-            <a:schemeClr val="accent1"/>
-          </a:effectRef>
-          <a:fontRef idx="minor">
-            <a:schemeClr val="lt1"/>
-          </a:fontRef>
-        </p:style>
-        <p:txBody>
-          <a:bodyPr rtlCol="0" anchor="ctr"/>
-          <a:lstStyle/>
-          <a:p>
-            <a:pPr algn="ctr"/>
-          </a:p>
-        </p:txBody>
-      </p:sp>
-      <p:sp>
-        <p:nvSpPr>
-          <p:cNvPr id="4" name="TextBox 3"/>
-          <p:cNvSpPr txBox="1"/>
-          <p:nvPr/>
-        </p:nvSpPr>
-        <p:spPr>
-          <a:xfrm>
-            <a:off x="822960" y="1371600"/>
-            <a:ext cx="10607040" cy="1463040"/>
-          </a:xfrm>
-          <a:prstGeom prst="rect">
-            <a:avLst/>
-          </a:prstGeom>
-          <a:noFill/>
-        </p:spPr>
-        <p:txBody>
-          <a:bodyPr wrap="square" lIns="45720" tIns="27432">
-            <a:spAutoFit/>
-          </a:bodyPr>
-          <a:lstStyle/>
-          <a:p>
-            <a:pPr>
-              <a:spcAft>
-                <a:spcPts val="800"/>
-              </a:spcAft>
-              <a:defRPr sz="1800">
-                <a:solidFill>
-                  <a:srgbClr val="111827"/>
-                </a:solidFill>
-              </a:defRPr>
-            </a:pPr>
-            <a:r>
-              <a:t>• Consentement explicite : 4 types (contact, partenaires, enquêtes, newsletter), horodaté et réellement consommé.</a:t>
-            </a:r>
-          </a:p>
-          <a:p>
-            <a:pPr>
-              <a:spcAft>
-                <a:spcPts val="800"/>
-              </a:spcAft>
-              <a:defRPr sz="1800">
-                <a:solidFill>
-                  <a:srgbClr val="111827"/>
-                </a:solidFill>
-              </a:defRPr>
-            </a:pPr>
-            <a:r>
-              <a:t>• Droits des personnes : export en auto-service (JSON/Excel/CSV), demande de suppression avec workflow verrouillé.</a:t>
-            </a:r>
-          </a:p>
-          <a:p>
-            <a:pPr>
-              <a:spcAft>
-                <a:spcPts val="800"/>
-              </a:spcAft>
-              <a:defRPr sz="1800">
-                <a:solidFill>
-                  <a:srgbClr val="111827"/>
-                </a:solidFill>
-              </a:defRPr>
-            </a:pPr>
-            <a:r>
-              <a:t>• Anonymisation vs suppression ; traçabilité via journal d'audit ; purge différée des comptes anonymisés.</a:t>
-            </a:r>
-          </a:p>
-        </p:txBody>
-      </p:sp>
-      <p:pic>
-        <p:nvPicPr>
-          <p:cNvPr id="5" name="Picture 4" descr="anC_consentement_light.png"/>
-          <p:cNvPicPr>
-            <a:picLocks noChangeAspect="1"/>
-          </p:cNvPicPr>
-          <p:nvPr/>
-        </p:nvPicPr>
-        <p:blipFill>
-          <a:blip r:embed="rId2"/>
-          <a:stretch>
-            <a:fillRect/>
-          </a:stretch>
-        </p:blipFill>
-        <p:spPr>
-          <a:xfrm>
-            <a:off x="822960" y="2926080"/>
-            <a:ext cx="5303520" cy="3314700"/>
-          </a:xfrm>
-          <a:prstGeom prst="rect">
-            <a:avLst/>
-          </a:prstGeom>
-        </p:spPr>
-      </p:pic>
-      <p:pic>
-        <p:nvPicPr>
-          <p:cNvPr id="6" name="Picture 5" descr="anB_demandes_rgpd_light.png"/>
-          <p:cNvPicPr>
-            <a:picLocks noChangeAspect="1"/>
-          </p:cNvPicPr>
-          <p:nvPr/>
-        </p:nvPicPr>
-        <p:blipFill>
-          <a:blip r:embed="rId3"/>
-          <a:stretch>
-            <a:fillRect/>
-          </a:stretch>
-        </p:blipFill>
-        <p:spPr>
-          <a:xfrm>
-            <a:off x="6400800" y="2926080"/>
-            <a:ext cx="5303520" cy="3314700"/>
-          </a:xfrm>
-          <a:prstGeom prst="rect">
-            <a:avLst/>
-          </a:prstGeom>
-        </p:spPr>
-      </p:pic>
-      <p:sp>
-        <p:nvSpPr>
-          <p:cNvPr id="7" name="TextBox 6"/>
-          <p:cNvSpPr txBox="1"/>
-          <p:nvPr/>
-        </p:nvSpPr>
-        <p:spPr>
-          <a:xfrm>
-            <a:off x="365760" y="6446520"/>
-            <a:ext cx="11430000" cy="365760"/>
-          </a:xfrm>
-          <a:prstGeom prst="rect">
-            <a:avLst/>
-          </a:prstGeom>
-          <a:noFill/>
-        </p:spPr>
-        <p:txBody>
-          <a:bodyPr wrap="none">
-            <a:spAutoFit/>
-          </a:bodyPr>
-          <a:lstStyle/>
-          <a:p>
-            <a:pPr>
-              <a:defRPr sz="1100">
-                <a:solidFill>
-                  <a:srgbClr val="6B7280"/>
-                </a:solidFill>
-              </a:defRPr>
-            </a:pPr>
-            <a:r>
-              <a:t>Alumni CRM — Stage PreMSc 2026 — IONIS-STM        11</a:t>
-            </a:r>
-          </a:p>
-        </p:txBody>
-      </p:sp>
-    </p:spTree>
-  </p:cSld>
-  <p:clrMapOvr>
-    <a:masterClrMapping/>
-  </p:clrMapOvr>
-</p:sld>
-</file>
-
-<file path=ppt/slides/slide12.xml><?xml version="1.0" encoding="utf-8"?>
-<p:sld xmlns:a="http://schemas.openxmlformats.org/drawingml/2006/main" xmlns:p="http://schemas.openxmlformats.org/presentationml/2006/main" xmlns:r="http://schemas.openxmlformats.org/officeDocument/2006/relationships">
-  <p:cSld>
-    <p:bg>
-      <p:bgPr>
-        <a:solidFill>
-          <a:srgbClr val="FFFFFF"/>
-        </a:solidFill>
-        <a:effectLst/>
-      </p:bgPr>
-    </p:bg>
-    <p:spTree>
-      <p:nvGrpSpPr>
-        <p:cNvPr id="1" name=""/>
-        <p:cNvGrpSpPr/>
-        <p:nvPr/>
-      </p:nvGrpSpPr>
-      <p:grpSpPr/>
-      <p:sp>
-        <p:nvSpPr>
-          <p:cNvPr id="2" name="Rectangle 1"/>
-          <p:cNvSpPr/>
-          <p:nvPr/>
-        </p:nvSpPr>
-        <p:spPr>
-          <a:xfrm>
-            <a:off x="0" y="0"/>
-            <a:ext cx="12191695" cy="1005840"/>
-          </a:xfrm>
-          <a:prstGeom prst="rect">
-            <a:avLst/>
-          </a:prstGeom>
-          <a:solidFill>
-            <a:srgbClr val="1E40AF"/>
-          </a:solidFill>
-          <a:ln>
-            <a:noFill/>
-          </a:ln>
-        </p:spPr>
-        <p:style>
-          <a:lnRef idx="1">
-            <a:schemeClr val="accent1"/>
-          </a:lnRef>
-          <a:fillRef idx="3">
-            <a:schemeClr val="accent1"/>
-          </a:fillRef>
-          <a:effectRef idx="2">
-            <a:schemeClr val="accent1"/>
-          </a:effectRef>
-          <a:fontRef idx="minor">
-            <a:schemeClr val="lt1"/>
-          </a:fontRef>
-        </p:style>
-        <p:txBody>
-          <a:bodyPr rtlCol="0" anchor="ctr" lIns="457200" tIns="137160" wrap="square"/>
-          <a:lstStyle/>
-          <a:p>
-            <a:pPr algn="ctr">
-              <a:defRPr sz="2800" b="1">
-                <a:solidFill>
-                  <a:srgbClr val="FFFFFF"/>
-                </a:solidFill>
-              </a:defRPr>
-            </a:pPr>
-            <a:r>
-              <a:t>Indicateurs d'insertion professionnelle</a:t>
-            </a:r>
-          </a:p>
-        </p:txBody>
-      </p:sp>
-      <p:sp>
-        <p:nvSpPr>
-          <p:cNvPr id="3" name="Rectangle 2"/>
-          <p:cNvSpPr/>
-          <p:nvPr/>
-        </p:nvSpPr>
-        <p:spPr>
-          <a:xfrm>
-            <a:off x="0" y="1005840"/>
-            <a:ext cx="12191695" cy="54864"/>
-          </a:xfrm>
-          <a:prstGeom prst="rect">
-            <a:avLst/>
-          </a:prstGeom>
-          <a:solidFill>
-            <a:srgbClr val="10B981"/>
-          </a:solidFill>
-          <a:ln>
-            <a:noFill/>
-          </a:ln>
-        </p:spPr>
-        <p:style>
-          <a:lnRef idx="1">
-            <a:schemeClr val="accent1"/>
-          </a:lnRef>
-          <a:fillRef idx="3">
-            <a:schemeClr val="accent1"/>
-          </a:fillRef>
-          <a:effectRef idx="2">
-            <a:schemeClr val="accent1"/>
-          </a:effectRef>
-          <a:fontRef idx="minor">
-            <a:schemeClr val="lt1"/>
-          </a:fontRef>
-        </p:style>
-        <p:txBody>
-          <a:bodyPr rtlCol="0" anchor="ctr"/>
-          <a:lstStyle/>
-          <a:p>
-            <a:pPr algn="ctr"/>
-          </a:p>
-        </p:txBody>
-      </p:sp>
-      <p:sp>
-        <p:nvSpPr>
-          <p:cNvPr id="4" name="TextBox 3"/>
-          <p:cNvSpPr txBox="1"/>
-          <p:nvPr/>
-        </p:nvSpPr>
-        <p:spPr>
-          <a:xfrm>
-            <a:off x="822960" y="1371600"/>
-            <a:ext cx="5303520" cy="4937760"/>
-          </a:xfrm>
-          <a:prstGeom prst="rect">
-            <a:avLst/>
-          </a:prstGeom>
-          <a:noFill/>
-        </p:spPr>
-        <p:txBody>
-          <a:bodyPr wrap="square" lIns="45720" tIns="27432">
-            <a:spAutoFit/>
-          </a:bodyPr>
-          <a:lstStyle/>
-          <a:p>
-            <a:pPr>
-              <a:spcAft>
-                <a:spcPts val="800"/>
-              </a:spcAft>
-              <a:defRPr sz="1700">
-                <a:solidFill>
-                  <a:srgbClr val="111827"/>
-                </a:solidFill>
-              </a:defRPr>
-            </a:pPr>
-            <a:r>
-              <a:t>• 8 indicateurs reproductibles, avec formule et source de données explicites.</a:t>
-            </a:r>
-          </a:p>
-          <a:p>
-            <a:pPr>
-              <a:spcAft>
-                <a:spcPts val="800"/>
-              </a:spcAft>
-              <a:defRPr sz="1700">
-                <a:solidFill>
-                  <a:srgbClr val="111827"/>
-                </a:solidFill>
-              </a:defRPr>
-            </a:pPr>
-            <a:r>
-              <a:t>• Taux d'emploi à 6 mois : expériences actives à la date de référence.</a:t>
-            </a:r>
-          </a:p>
-          <a:p>
-            <a:pPr>
-              <a:spcAft>
-                <a:spcPts val="800"/>
-              </a:spcAft>
-              <a:defRPr sz="1700">
-                <a:solidFill>
-                  <a:srgbClr val="111827"/>
-                </a:solidFill>
-              </a:defRPr>
-            </a:pPr>
-            <a:r>
-              <a:t>• Adéquation formation/emploi via les tags KPI du questionnaire.</a:t>
-            </a:r>
-          </a:p>
-          <a:p>
-            <a:pPr>
-              <a:spcAft>
-                <a:spcPts val="800"/>
-              </a:spcAft>
-              <a:defRPr sz="1700">
-                <a:solidFill>
-                  <a:srgbClr val="111827"/>
-                </a:solidFill>
-              </a:defRPr>
-            </a:pPr>
-            <a:r>
-              <a:t>• Salaire moyen / min / max sur le champ salaire annuel.</a:t>
-            </a:r>
-          </a:p>
-          <a:p>
-            <a:pPr>
-              <a:spcAft>
-                <a:spcPts val="800"/>
-              </a:spcAft>
-              <a:defRPr sz="1700">
-                <a:solidFill>
-                  <a:srgbClr val="111827"/>
-                </a:solidFill>
-              </a:defRPr>
-            </a:pPr>
-            <a:r>
-              <a:t>• Répartition par promotion et par secteur, taux de complétion.</a:t>
-            </a:r>
-          </a:p>
-          <a:p>
-            <a:pPr>
-              <a:spcAft>
-                <a:spcPts val="800"/>
-              </a:spcAft>
-              <a:defRPr sz="1700">
-                <a:solidFill>
-                  <a:srgbClr val="111827"/>
-                </a:solidFill>
-              </a:defRPr>
-            </a:pPr>
-            <a:r>
-              <a:t>• Refus d'afficher un chiffre trompeur (cohortes immatures → non disponible).</a:t>
-            </a:r>
-          </a:p>
-        </p:txBody>
-      </p:sp>
-      <p:pic>
-        <p:nvPicPr>
-          <p:cNvPr id="5" name="Picture 4" descr="anB_dashboard_light.png"/>
-          <p:cNvPicPr>
-            <a:picLocks noChangeAspect="1"/>
-          </p:cNvPicPr>
-          <p:nvPr/>
-        </p:nvPicPr>
-        <p:blipFill>
-          <a:blip r:embed="rId2"/>
-          <a:stretch>
-            <a:fillRect/>
-          </a:stretch>
-        </p:blipFill>
-        <p:spPr>
-          <a:xfrm>
-            <a:off x="6400800" y="1737360"/>
-            <a:ext cx="5120640" cy="3200400"/>
-          </a:xfrm>
-          <a:prstGeom prst="rect">
-            <a:avLst/>
-          </a:prstGeom>
-        </p:spPr>
-      </p:pic>
-      <p:sp>
-        <p:nvSpPr>
-          <p:cNvPr id="6" name="TextBox 5"/>
-          <p:cNvSpPr txBox="1"/>
-          <p:nvPr/>
-        </p:nvSpPr>
-        <p:spPr>
-          <a:xfrm>
-            <a:off x="365760" y="6446520"/>
-            <a:ext cx="11430000" cy="365760"/>
-          </a:xfrm>
-          <a:prstGeom prst="rect">
-            <a:avLst/>
-          </a:prstGeom>
-          <a:noFill/>
-        </p:spPr>
-        <p:txBody>
-          <a:bodyPr wrap="none">
-            <a:spAutoFit/>
-          </a:bodyPr>
-          <a:lstStyle/>
-          <a:p>
-            <a:pPr>
-              <a:defRPr sz="1100">
-                <a:solidFill>
-                  <a:srgbClr val="6B7280"/>
-                </a:solidFill>
-              </a:defRPr>
-            </a:pPr>
-            <a:r>
-              <a:t>Alumni CRM — Stage PreMSc 2026 — IONIS-STM        12</a:t>
-            </a:r>
-          </a:p>
-        </p:txBody>
-      </p:sp>
-    </p:spTree>
-  </p:cSld>
-  <p:clrMapOvr>
-    <a:masterClrMapping/>
-  </p:clrMapOvr>
-</p:sld>
-</file>
-
-<file path=ppt/slides/slide13.xml><?xml version="1.0" encoding="utf-8"?>
-<p:sld xmlns:a="http://schemas.openxmlformats.org/drawingml/2006/main" xmlns:p="http://schemas.openxmlformats.org/presentationml/2006/main" xmlns:r="http://schemas.openxmlformats.org/officeDocument/2006/relationships">
-  <p:cSld>
-    <p:bg>
-      <p:bgPr>
-        <a:solidFill>
-          <a:srgbClr val="FFFFFF"/>
-        </a:solidFill>
-        <a:effectLst/>
-      </p:bgPr>
-    </p:bg>
-    <p:spTree>
-      <p:nvGrpSpPr>
-        <p:cNvPr id="1" name=""/>
-        <p:cNvGrpSpPr/>
-        <p:nvPr/>
-      </p:nvGrpSpPr>
-      <p:grpSpPr/>
-      <p:sp>
-        <p:nvSpPr>
-          <p:cNvPr id="2" name="Rectangle 1"/>
-          <p:cNvSpPr/>
-          <p:nvPr/>
-        </p:nvSpPr>
-        <p:spPr>
-          <a:xfrm>
-            <a:off x="0" y="0"/>
-            <a:ext cx="12191695" cy="1005840"/>
-          </a:xfrm>
-          <a:prstGeom prst="rect">
-            <a:avLst/>
-          </a:prstGeom>
-          <a:solidFill>
-            <a:srgbClr val="1E40AF"/>
-          </a:solidFill>
-          <a:ln>
-            <a:noFill/>
-          </a:ln>
-        </p:spPr>
-        <p:style>
-          <a:lnRef idx="1">
-            <a:schemeClr val="accent1"/>
-          </a:lnRef>
-          <a:fillRef idx="3">
-            <a:schemeClr val="accent1"/>
-          </a:fillRef>
-          <a:effectRef idx="2">
-            <a:schemeClr val="accent1"/>
-          </a:effectRef>
-          <a:fontRef idx="minor">
-            <a:schemeClr val="lt1"/>
-          </a:fontRef>
-        </p:style>
-        <p:txBody>
-          <a:bodyPr rtlCol="0" anchor="ctr" lIns="457200" tIns="137160" wrap="square"/>
-          <a:lstStyle/>
-          <a:p>
-            <a:pPr algn="ctr">
-              <a:defRPr sz="2800" b="1">
-                <a:solidFill>
-                  <a:srgbClr val="FFFFFF"/>
-                </a:solidFill>
-              </a:defRPr>
-            </a:pPr>
-            <a:r>
-              <a:t>Difficultés rencontrées et solutions</a:t>
-            </a:r>
-          </a:p>
-        </p:txBody>
-      </p:sp>
-      <p:sp>
-        <p:nvSpPr>
-          <p:cNvPr id="3" name="Rectangle 2"/>
-          <p:cNvSpPr/>
-          <p:nvPr/>
-        </p:nvSpPr>
-        <p:spPr>
-          <a:xfrm>
-            <a:off x="0" y="1005840"/>
-            <a:ext cx="12191695" cy="54864"/>
-          </a:xfrm>
-          <a:prstGeom prst="rect">
-            <a:avLst/>
-          </a:prstGeom>
-          <a:solidFill>
-            <a:srgbClr val="10B981"/>
-          </a:solidFill>
-          <a:ln>
-            <a:noFill/>
-          </a:ln>
-        </p:spPr>
-        <p:style>
-          <a:lnRef idx="1">
-            <a:schemeClr val="accent1"/>
-          </a:lnRef>
-          <a:fillRef idx="3">
-            <a:schemeClr val="accent1"/>
-          </a:fillRef>
-          <a:effectRef idx="2">
-            <a:schemeClr val="accent1"/>
-          </a:effectRef>
-          <a:fontRef idx="minor">
-            <a:schemeClr val="lt1"/>
-          </a:fontRef>
-        </p:style>
-        <p:txBody>
-          <a:bodyPr rtlCol="0" anchor="ctr"/>
-          <a:lstStyle/>
-          <a:p>
-            <a:pPr algn="ctr"/>
-          </a:p>
-        </p:txBody>
-      </p:sp>
-      <p:sp>
-        <p:nvSpPr>
-          <p:cNvPr id="4" name="TextBox 3"/>
-          <p:cNvSpPr txBox="1"/>
-          <p:nvPr/>
-        </p:nvSpPr>
-        <p:spPr>
-          <a:xfrm>
-            <a:off x="822960" y="1371600"/>
-            <a:ext cx="10607040" cy="4754880"/>
-          </a:xfrm>
-          <a:prstGeom prst="rect">
-            <a:avLst/>
-          </a:prstGeom>
-          <a:noFill/>
-        </p:spPr>
-        <p:txBody>
-          <a:bodyPr wrap="square" lIns="45720" tIns="27432">
-            <a:spAutoFit/>
-          </a:bodyPr>
-          <a:lstStyle/>
-          <a:p>
-            <a:pPr>
-              <a:spcAft>
-                <a:spcPts val="800"/>
-              </a:spcAft>
-              <a:defRPr sz="1800">
-                <a:solidFill>
-                  <a:srgbClr val="111827"/>
-                </a:solidFill>
-              </a:defRPr>
-            </a:pPr>
-            <a:r>
-              <a:t>• Auth croisée admin/alumni (403) → clés distinctes, vérification du rôle, purge des sessions orphelines.</a:t>
-            </a:r>
-          </a:p>
-          <a:p>
-            <a:pPr>
-              <a:spcAft>
-                <a:spcPts val="800"/>
-              </a:spcAft>
-              <a:defRPr sz="1800">
-                <a:solidFill>
-                  <a:srgbClr val="111827"/>
-                </a:solidFill>
-              </a:defRPr>
-            </a:pPr>
-            <a:r>
-              <a:t>• Dérive modèle/base → migrations correctives + rejeu complet sur base vide.</a:t>
-            </a:r>
-          </a:p>
-          <a:p>
-            <a:pPr>
-              <a:spcAft>
-                <a:spcPts val="800"/>
-              </a:spcAft>
-              <a:defRPr sz="1800">
-                <a:solidFill>
-                  <a:srgbClr val="111827"/>
-                </a:solidFill>
-              </a:defRPr>
-            </a:pPr>
-            <a:r>
-              <a:t>• Indicateur d'insertion trompeur → filtrage des expériences actives, exclusion des cohortes immatures.</a:t>
-            </a:r>
-          </a:p>
-          <a:p>
-            <a:pPr>
-              <a:spcAft>
-                <a:spcPts val="800"/>
-              </a:spcAft>
-              <a:defRPr sz="1800">
-                <a:solidFill>
-                  <a:srgbClr val="111827"/>
-                </a:solidFill>
-              </a:defRPr>
-            </a:pPr>
-            <a:r>
-              <a:t>• Incident OneDrive → dépôt Git + .gitignore consolidé (versionner avant la première ligne de code).</a:t>
-            </a:r>
-          </a:p>
-          <a:p>
-            <a:pPr>
-              <a:spcAft>
-                <a:spcPts val="800"/>
-              </a:spcAft>
-              <a:defRPr sz="1800">
-                <a:solidFill>
-                  <a:srgbClr val="111827"/>
-                </a:solidFill>
-              </a:defRPr>
-            </a:pPr>
-            <a:r>
-              <a:t>• Failles sécurité (IDOR, upload, secrets) → correctifs documentés, sanitisation des erreurs.</a:t>
-            </a:r>
-          </a:p>
-          <a:p>
-            <a:pPr>
-              <a:spcAft>
-                <a:spcPts val="800"/>
-              </a:spcAft>
-              <a:defRPr sz="1800">
-                <a:solidFill>
-                  <a:srgbClr val="111827"/>
-                </a:solidFill>
-              </a:defRPr>
-            </a:pPr>
-            <a:r>
-              <a:t>• Limites exposées de façon transparente (tests, newsletter, mise à jour d'expérience).</a:t>
-            </a:r>
-          </a:p>
-        </p:txBody>
-      </p:sp>
-      <p:sp>
-        <p:nvSpPr>
-          <p:cNvPr id="5" name="TextBox 4"/>
-          <p:cNvSpPr txBox="1"/>
-          <p:nvPr/>
-        </p:nvSpPr>
-        <p:spPr>
-          <a:xfrm>
-            <a:off x="365760" y="6446520"/>
-            <a:ext cx="11430000" cy="365760"/>
-          </a:xfrm>
-          <a:prstGeom prst="rect">
-            <a:avLst/>
-          </a:prstGeom>
-          <a:noFill/>
-        </p:spPr>
-        <p:txBody>
-          <a:bodyPr wrap="none">
-            <a:spAutoFit/>
-          </a:bodyPr>
-          <a:lstStyle/>
-          <a:p>
-            <a:pPr>
-              <a:defRPr sz="1100">
-                <a:solidFill>
-                  <a:srgbClr val="6B7280"/>
-                </a:solidFill>
-              </a:defRPr>
-            </a:pPr>
-            <a:r>
-              <a:t>Alumni CRM — Stage PreMSc 2026 — IONIS-STM        13</a:t>
-            </a:r>
-          </a:p>
-        </p:txBody>
-      </p:sp>
-    </p:spTree>
-  </p:cSld>
-  <p:clrMapOvr>
-    <a:masterClrMapping/>
-  </p:clrMapOvr>
-</p:sld>
-</file>
-
-<file path=ppt/slides/slide14.xml><?xml version="1.0" encoding="utf-8"?>
-<p:sld xmlns:a="http://schemas.openxmlformats.org/drawingml/2006/main" xmlns:p="http://schemas.openxmlformats.org/presentationml/2006/main" xmlns:r="http://schemas.openxmlformats.org/officeDocument/2006/relationships">
-  <p:cSld>
-    <p:bg>
-      <p:bgPr>
-        <a:solidFill>
-          <a:srgbClr val="FFFFFF"/>
-        </a:solidFill>
-        <a:effectLst/>
-      </p:bgPr>
-    </p:bg>
-    <p:spTree>
-      <p:nvGrpSpPr>
-        <p:cNvPr id="1" name=""/>
-        <p:cNvGrpSpPr/>
-        <p:nvPr/>
-      </p:nvGrpSpPr>
-      <p:grpSpPr/>
-      <p:sp>
-        <p:nvSpPr>
-          <p:cNvPr id="2" name="Rectangle 1"/>
-          <p:cNvSpPr/>
-          <p:nvPr/>
-        </p:nvSpPr>
-        <p:spPr>
-          <a:xfrm>
-            <a:off x="0" y="0"/>
-            <a:ext cx="12191695" cy="1005840"/>
-          </a:xfrm>
-          <a:prstGeom prst="rect">
-            <a:avLst/>
-          </a:prstGeom>
-          <a:solidFill>
-            <a:srgbClr val="1E40AF"/>
-          </a:solidFill>
-          <a:ln>
-            <a:noFill/>
-          </a:ln>
-        </p:spPr>
-        <p:style>
-          <a:lnRef idx="1">
-            <a:schemeClr val="accent1"/>
-          </a:lnRef>
-          <a:fillRef idx="3">
-            <a:schemeClr val="accent1"/>
-          </a:fillRef>
-          <a:effectRef idx="2">
-            <a:schemeClr val="accent1"/>
-          </a:effectRef>
-          <a:fontRef idx="minor">
-            <a:schemeClr val="lt1"/>
-          </a:fontRef>
-        </p:style>
-        <p:txBody>
-          <a:bodyPr rtlCol="0" anchor="ctr" lIns="457200" tIns="137160" wrap="square"/>
-          <a:lstStyle/>
-          <a:p>
-            <a:pPr algn="ctr">
-              <a:defRPr sz="2800" b="1">
-                <a:solidFill>
-                  <a:srgbClr val="FFFFFF"/>
-                </a:solidFill>
-              </a:defRPr>
-            </a:pPr>
-            <a:r>
-              <a:t>Bilan et perspectives</a:t>
-            </a:r>
-          </a:p>
-        </p:txBody>
-      </p:sp>
-      <p:sp>
-        <p:nvSpPr>
-          <p:cNvPr id="3" name="Rectangle 2"/>
-          <p:cNvSpPr/>
-          <p:nvPr/>
-        </p:nvSpPr>
-        <p:spPr>
-          <a:xfrm>
-            <a:off x="0" y="1005840"/>
-            <a:ext cx="12191695" cy="54864"/>
-          </a:xfrm>
-          <a:prstGeom prst="rect">
-            <a:avLst/>
-          </a:prstGeom>
-          <a:solidFill>
-            <a:srgbClr val="10B981"/>
-          </a:solidFill>
-          <a:ln>
-            <a:noFill/>
-          </a:ln>
-        </p:spPr>
-        <p:style>
-          <a:lnRef idx="1">
-            <a:schemeClr val="accent1"/>
-          </a:lnRef>
-          <a:fillRef idx="3">
-            <a:schemeClr val="accent1"/>
-          </a:fillRef>
-          <a:effectRef idx="2">
-            <a:schemeClr val="accent1"/>
-          </a:effectRef>
-          <a:fontRef idx="minor">
-            <a:schemeClr val="lt1"/>
-          </a:fontRef>
-        </p:style>
-        <p:txBody>
-          <a:bodyPr rtlCol="0" anchor="ctr"/>
-          <a:lstStyle/>
-          <a:p>
-            <a:pPr algn="ctr"/>
-          </a:p>
-        </p:txBody>
-      </p:sp>
-      <p:sp>
-        <p:nvSpPr>
-          <p:cNvPr id="4" name="TextBox 3"/>
-          <p:cNvSpPr txBox="1"/>
-          <p:nvPr/>
-        </p:nvSpPr>
-        <p:spPr>
-          <a:xfrm>
-            <a:off x="822960" y="1371600"/>
-            <a:ext cx="10607040" cy="3108960"/>
-          </a:xfrm>
-          <a:prstGeom prst="rect">
-            <a:avLst/>
-          </a:prstGeom>
-          <a:noFill/>
-        </p:spPr>
-        <p:txBody>
-          <a:bodyPr wrap="square" lIns="45720" tIns="27432">
-            <a:spAutoFit/>
-          </a:bodyPr>
-          <a:lstStyle/>
-          <a:p>
-            <a:pPr>
-              <a:spcAft>
-                <a:spcPts val="800"/>
-              </a:spcAft>
-              <a:defRPr sz="1800">
-                <a:solidFill>
-                  <a:srgbClr val="111827"/>
-                </a:solidFill>
-              </a:defRPr>
-            </a:pPr>
-            <a:r>
-              <a:t>• Prototype complet et opérationnel : 82 endpoints, 14 pages, 14 tables, conformité RGPD.</a:t>
-            </a:r>
-          </a:p>
-          <a:p>
-            <a:pPr>
-              <a:spcAft>
-                <a:spcPts val="800"/>
-              </a:spcAft>
-              <a:defRPr sz="1800">
-                <a:solidFill>
-                  <a:srgbClr val="111827"/>
-                </a:solidFill>
-              </a:defRPr>
-            </a:pPr>
-            <a:r>
-              <a:t>• Compétences : full-stack, sécurité applicative, migrations versionnées, RGPD, méthodologie.</a:t>
-            </a:r>
-          </a:p>
-          <a:p>
-            <a:pPr>
-              <a:spcAft>
-                <a:spcPts val="800"/>
-              </a:spcAft>
-              <a:defRPr sz="1800">
-                <a:solidFill>
-                  <a:srgbClr val="111827"/>
-                </a:solidFill>
-              </a:defRPr>
-            </a:pPr>
-            <a:r>
-              <a:t>• Documentation « comme du code » : rapports, cartographies, guide des processus, ce support.</a:t>
-            </a:r>
-          </a:p>
-        </p:txBody>
-      </p:sp>
-      <p:sp>
-        <p:nvSpPr>
-          <p:cNvPr id="5" name="TextBox 4"/>
-          <p:cNvSpPr txBox="1"/>
-          <p:nvPr/>
-        </p:nvSpPr>
-        <p:spPr>
-          <a:xfrm>
-            <a:off x="822960" y="4480560"/>
-            <a:ext cx="10607040" cy="1828800"/>
-          </a:xfrm>
-          <a:prstGeom prst="rect">
-            <a:avLst/>
-          </a:prstGeom>
-          <a:noFill/>
-        </p:spPr>
-        <p:txBody>
-          <a:bodyPr wrap="square" lIns="45720" tIns="27432">
-            <a:spAutoFit/>
-          </a:bodyPr>
-          <a:lstStyle/>
-          <a:p>
-            <a:pPr>
-              <a:spcAft>
-                <a:spcPts val="400"/>
-              </a:spcAft>
-              <a:defRPr sz="1700">
-                <a:solidFill>
-                  <a:srgbClr val="111827"/>
-                </a:solidFill>
-              </a:defRPr>
-            </a:pPr>
-            <a:r>
-              <a:t>• Court terme : suite de tests automatisés, automatisation du questionnaire, frontend newsletter.</a:t>
-            </a:r>
-          </a:p>
-          <a:p>
-            <a:pPr>
-              <a:spcAft>
-                <a:spcPts val="400"/>
-              </a:spcAft>
-              <a:defRPr sz="1700">
-                <a:solidFill>
-                  <a:srgbClr val="111827"/>
-                </a:solidFill>
-              </a:defRPr>
-            </a:pPr>
-            <a:r>
-              <a:t>• Moyen terme : module de mentorat, chiffrement applicatif, route de mise à jour d'une expérience.</a:t>
-            </a:r>
-          </a:p>
-          <a:p>
-            <a:pPr>
-              <a:spcAft>
-                <a:spcPts val="400"/>
-              </a:spcAft>
-              <a:defRPr sz="1700">
-                <a:solidFill>
-                  <a:srgbClr val="111827"/>
-                </a:solidFill>
-              </a:defRPr>
-            </a:pPr>
-            <a:r>
-              <a:t>• Long terme : application mobile, PWA, notification de violation (art. 33 RGPD).</a:t>
-            </a:r>
-          </a:p>
-        </p:txBody>
-      </p:sp>
-      <p:sp>
-        <p:nvSpPr>
-          <p:cNvPr id="6" name="TextBox 5"/>
-          <p:cNvSpPr txBox="1"/>
-          <p:nvPr/>
-        </p:nvSpPr>
-        <p:spPr>
-          <a:xfrm>
-            <a:off x="365760" y="6446520"/>
-            <a:ext cx="11430000" cy="365760"/>
-          </a:xfrm>
-          <a:prstGeom prst="rect">
-            <a:avLst/>
-          </a:prstGeom>
-          <a:noFill/>
-        </p:spPr>
-        <p:txBody>
-          <a:bodyPr wrap="none">
-            <a:spAutoFit/>
-          </a:bodyPr>
-          <a:lstStyle/>
-          <a:p>
-            <a:pPr>
-              <a:defRPr sz="1100">
-                <a:solidFill>
-                  <a:srgbClr val="6B7280"/>
-                </a:solidFill>
-              </a:defRPr>
-            </a:pPr>
-            <a:r>
-              <a:t>Alumni CRM — Stage PreMSc 2026 — IONIS-STM        14</a:t>
-            </a:r>
-          </a:p>
-        </p:txBody>
-      </p:sp>
-    </p:spTree>
-  </p:cSld>
-  <p:clrMapOvr>
-    <a:masterClrMapping/>
-  </p:clrMapOvr>
-</p:sld>
-</file>
-
-<file path=ppt/slides/slide15.xml><?xml version="1.0" encoding="utf-8"?>
-<p:sld xmlns:a="http://schemas.openxmlformats.org/drawingml/2006/main" xmlns:p="http://schemas.openxmlformats.org/presentationml/2006/main" xmlns:r="http://schemas.openxmlformats.org/officeDocument/2006/relationships">
-  <p:cSld>
-    <p:bg>
-      <p:bgPr>
-        <a:solidFill>
-          <a:srgbClr val="FFFFFF"/>
-        </a:solidFill>
-        <a:effectLst/>
-      </p:bgPr>
-    </p:bg>
-    <p:spTree>
-      <p:nvGrpSpPr>
-        <p:cNvPr id="1" name=""/>
-        <p:cNvGrpSpPr/>
-        <p:nvPr/>
-      </p:nvGrpSpPr>
-      <p:grpSpPr/>
-      <p:sp>
-        <p:nvSpPr>
-          <p:cNvPr id="2" name="Rectangle 1"/>
-          <p:cNvSpPr/>
-          <p:nvPr/>
-        </p:nvSpPr>
-        <p:spPr>
-          <a:xfrm>
-            <a:off x="0" y="0"/>
             <a:ext cx="12191695" cy="164592"/>
           </a:xfrm>
           <a:prstGeom prst="rect">
@@ -5147,7 +4125,7 @@
               </a:defRPr>
             </a:pPr>
             <a:r>
-              <a:t>Contexte, objectifs et problématique</a:t>
+              <a:t>Contexte, objectifs</a:t>
             </a:r>
           </a:p>
         </p:txBody>
@@ -5238,7 +4216,7 @@
               </a:defRPr>
             </a:pPr>
             <a:r>
-              <a:t>Méthodologie et choix technologiques</a:t>
+              <a:t>Méthodologie et architecture</a:t>
             </a:r>
           </a:p>
         </p:txBody>
@@ -5329,7 +4307,7 @@
               </a:defRPr>
             </a:pPr>
             <a:r>
-              <a:t>Développement technique (architecture, données, sécurité)</a:t>
+              <a:t>Modèle de données et RGPD</a:t>
             </a:r>
           </a:p>
         </p:txBody>
@@ -5511,7 +4489,7 @@
               </a:defRPr>
             </a:pPr>
             <a:r>
-              <a:t>Indicateurs d'insertion et conformité RGPD</a:t>
+              <a:t>Indicateurs d'insertion</a:t>
             </a:r>
           </a:p>
         </p:txBody>
@@ -5602,7 +4580,7 @@
               </a:defRPr>
             </a:pPr>
             <a:r>
-              <a:t>Difficultés, bilan et perspectives</a:t>
+              <a:t>Bilan et perspectives</a:t>
             </a:r>
           </a:p>
         </p:txBody>
@@ -5715,7 +4693,7 @@
               </a:defRPr>
             </a:pPr>
             <a:r>
-              <a:t>Contexte et enjeux</a:t>
+              <a:t>Contexte, enjeux et objectifs</a:t>
             </a:r>
           </a:p>
         </p:txBody>
@@ -5771,8 +4749,8 @@
         </p:nvSpPr>
         <p:spPr>
           <a:xfrm>
-            <a:off x="822960" y="1371600"/>
-            <a:ext cx="10607040" cy="4206240"/>
+            <a:off x="822960" y="1234440"/>
+            <a:ext cx="10607040" cy="1554480"/>
           </a:xfrm>
           <a:prstGeom prst="rect">
             <a:avLst/>
@@ -5789,14 +4767,14 @@
               <a:spcAft>
                 <a:spcPts val="800"/>
               </a:spcAft>
-              <a:defRPr sz="1900">
+              <a:defRPr sz="1700">
                 <a:solidFill>
                   <a:srgbClr val="111827"/>
                 </a:solidFill>
               </a:defRPr>
             </a:pPr>
             <a:r>
-              <a:t>• IONIS Education Group : premier groupe d'enseignement supérieur privé en France, multi-écoles (EPITECH, ESGI, IIM, ESM, ISA…).</a:t>
+              <a:t>• Le suivi de l'insertion des diplômés est stratégique : pilotage de la formation, animation du réseau, obligations réglementaires (RGPD).</a:t>
             </a:r>
           </a:p>
           <a:p>
@@ -5804,44 +4782,14 @@
               <a:spcAft>
                 <a:spcPts val="800"/>
               </a:spcAft>
-              <a:defRPr sz="1900">
+              <a:defRPr sz="1700">
                 <a:solidFill>
                   <a:srgbClr val="111827"/>
                 </a:solidFill>
               </a:defRPr>
             </a:pPr>
             <a:r>
-              <a:t>• Le suivi de l'insertion des diplômés est un enjeu stratégique : pilotage de la formation, animation du réseau, obligations réglementaires.</a:t>
-            </a:r>
-          </a:p>
-          <a:p>
-            <a:pPr>
-              <a:spcAft>
-                <a:spcPts val="800"/>
-              </a:spcAft>
-              <a:defRPr sz="1900">
-                <a:solidFill>
-                  <a:srgbClr val="111827"/>
-                </a:solidFill>
-              </a:defRPr>
-            </a:pPr>
-            <a:r>
-              <a:t>• Sans système centralisé, les données d'insertion périment vite et la collecte est manuelle.</a:t>
-            </a:r>
-          </a:p>
-          <a:p>
-            <a:pPr>
-              <a:spcAft>
-                <a:spcPts val="800"/>
-              </a:spcAft>
-              <a:defRPr sz="1900">
-                <a:solidFill>
-                  <a:srgbClr val="111827"/>
-                </a:solidFill>
-              </a:defRPr>
-            </a:pPr>
-            <a:r>
-              <a:t>• Un chantier prioritaire : disposer d'un dispositif de suivi alumni scalable et conforme au RGPD.</a:t>
+              <a:t>• Sans système centralisé, les données périment vite et la collecte est manuelle.</a:t>
             </a:r>
           </a:p>
         </p:txBody>
@@ -5854,8 +4802,8 @@
         </p:nvSpPr>
         <p:spPr>
           <a:xfrm>
-            <a:off x="822960" y="5120640"/>
-            <a:ext cx="10607040" cy="1005840"/>
+            <a:off x="822960" y="2743200"/>
+            <a:ext cx="10607040" cy="822960"/>
           </a:xfrm>
           <a:prstGeom prst="roundRect">
             <a:avLst/>
@@ -5898,8 +4846,99 @@
         </p:nvSpPr>
         <p:spPr>
           <a:xfrm>
-            <a:off x="1097280" y="5257800"/>
-            <a:ext cx="10058400" cy="731520"/>
+            <a:off x="1097280" y="2852928"/>
+            <a:ext cx="10058400" cy="640080"/>
+          </a:xfrm>
+          <a:prstGeom prst="rect">
+            <a:avLst/>
+          </a:prstGeom>
+          <a:noFill/>
+        </p:spPr>
+        <p:txBody>
+          <a:bodyPr wrap="square" lIns="45720" rIns="45720" tIns="27432" bIns="27432">
+            <a:spAutoFit/>
+          </a:bodyPr>
+          <a:lstStyle/>
+          <a:p>
+            <a:pPr algn="l">
+              <a:spcAft>
+                <a:spcPts val="200"/>
+              </a:spcAft>
+              <a:defRPr sz="1600" b="1">
+                <a:solidFill>
+                  <a:srgbClr val="1E40AF"/>
+                </a:solidFill>
+              </a:defRPr>
+            </a:pPr>
+            <a:r>
+              <a:t>Problématique : structurer la donnée alumni, piloter l'insertion par des indicateurs fiables, et animer le réseau dans le respect du RGPD.</a:t>
+            </a:r>
+          </a:p>
+        </p:txBody>
+      </p:sp>
+      <p:sp>
+        <p:nvSpPr>
+          <p:cNvPr id="7" name="Rounded Rectangle 6"/>
+          <p:cNvSpPr/>
+          <p:nvPr/>
+        </p:nvSpPr>
+        <p:spPr>
+          <a:xfrm>
+            <a:off x="822960" y="3657600"/>
+            <a:ext cx="914400" cy="777240"/>
+          </a:xfrm>
+          <a:prstGeom prst="roundRect">
+            <a:avLst/>
+          </a:prstGeom>
+          <a:solidFill>
+            <a:srgbClr val="10B981"/>
+          </a:solidFill>
+          <a:ln>
+            <a:noFill/>
+          </a:ln>
+          <a:effectLst/>
+        </p:spPr>
+        <p:style>
+          <a:lnRef idx="1">
+            <a:schemeClr val="accent1"/>
+          </a:lnRef>
+          <a:fillRef idx="3">
+            <a:schemeClr val="accent1"/>
+          </a:fillRef>
+          <a:effectRef idx="2">
+            <a:schemeClr val="accent1"/>
+          </a:effectRef>
+          <a:fontRef idx="minor">
+            <a:schemeClr val="lt1"/>
+          </a:fontRef>
+        </p:style>
+        <p:txBody>
+          <a:bodyPr rtlCol="0" anchor="ctr" wrap="square"/>
+          <a:lstStyle/>
+          <a:p>
+            <a:pPr algn="ctr">
+              <a:defRPr sz="2000" b="1">
+                <a:solidFill>
+                  <a:srgbClr val="FFFFFF"/>
+                </a:solidFill>
+              </a:defRPr>
+            </a:pPr>
+            <a:r>
+              <a:t>O1</a:t>
+            </a:r>
+          </a:p>
+        </p:txBody>
+      </p:sp>
+      <p:sp>
+        <p:nvSpPr>
+          <p:cNvPr id="8" name="TextBox 7"/>
+          <p:cNvSpPr txBox="1"/>
+          <p:nvPr/>
+        </p:nvSpPr>
+        <p:spPr>
+          <a:xfrm>
+            <a:off x="1965960" y="3794760"/>
+            <a:ext cx="9418320" cy="548640"/>
           </a:xfrm>
           <a:prstGeom prst="rect">
             <a:avLst/>
@@ -5918,19 +4957,383 @@
               </a:spcAft>
               <a:defRPr sz="1700" b="1">
                 <a:solidFill>
-                  <a:srgbClr val="1E40AF"/>
-                </a:solidFill>
-              </a:defRPr>
-            </a:pPr>
-            <a:r>
-              <a:t>Problématique : comment structurer la donnée alumni, piloter l'insertion par des indicateurs fiables, et animer le réseau dans le respect du RGPD ?</a:t>
-            </a:r>
-          </a:p>
-        </p:txBody>
-      </p:sp>
-      <p:sp>
-        <p:nvSpPr>
-          <p:cNvPr id="7" name="TextBox 6"/>
+                  <a:srgbClr val="111827"/>
+                </a:solidFill>
+              </a:defRPr>
+            </a:pPr>
+            <a:r>
+              <a:t>Un CRM complet : espace admin + espace alumni</a:t>
+            </a:r>
+          </a:p>
+        </p:txBody>
+      </p:sp>
+      <p:sp>
+        <p:nvSpPr>
+          <p:cNvPr id="9" name="Rounded Rectangle 8"/>
+          <p:cNvSpPr/>
+          <p:nvPr/>
+        </p:nvSpPr>
+        <p:spPr>
+          <a:xfrm>
+            <a:off x="822960" y="4480560"/>
+            <a:ext cx="914400" cy="777240"/>
+          </a:xfrm>
+          <a:prstGeom prst="roundRect">
+            <a:avLst/>
+          </a:prstGeom>
+          <a:solidFill>
+            <a:srgbClr val="10B981"/>
+          </a:solidFill>
+          <a:ln>
+            <a:noFill/>
+          </a:ln>
+          <a:effectLst/>
+        </p:spPr>
+        <p:style>
+          <a:lnRef idx="1">
+            <a:schemeClr val="accent1"/>
+          </a:lnRef>
+          <a:fillRef idx="3">
+            <a:schemeClr val="accent1"/>
+          </a:fillRef>
+          <a:effectRef idx="2">
+            <a:schemeClr val="accent1"/>
+          </a:effectRef>
+          <a:fontRef idx="minor">
+            <a:schemeClr val="lt1"/>
+          </a:fontRef>
+        </p:style>
+        <p:txBody>
+          <a:bodyPr rtlCol="0" anchor="ctr" wrap="square"/>
+          <a:lstStyle/>
+          <a:p>
+            <a:pPr algn="ctr">
+              <a:defRPr sz="2000" b="1">
+                <a:solidFill>
+                  <a:srgbClr val="FFFFFF"/>
+                </a:solidFill>
+              </a:defRPr>
+            </a:pPr>
+            <a:r>
+              <a:t>O2</a:t>
+            </a:r>
+          </a:p>
+        </p:txBody>
+      </p:sp>
+      <p:sp>
+        <p:nvSpPr>
+          <p:cNvPr id="10" name="TextBox 9"/>
+          <p:cNvSpPr txBox="1"/>
+          <p:nvPr/>
+        </p:nvSpPr>
+        <p:spPr>
+          <a:xfrm>
+            <a:off x="1965960" y="4617720"/>
+            <a:ext cx="9418320" cy="548640"/>
+          </a:xfrm>
+          <a:prstGeom prst="rect">
+            <a:avLst/>
+          </a:prstGeom>
+          <a:noFill/>
+        </p:spPr>
+        <p:txBody>
+          <a:bodyPr wrap="square" lIns="45720" rIns="45720" tIns="27432" bIns="27432">
+            <a:spAutoFit/>
+          </a:bodyPr>
+          <a:lstStyle/>
+          <a:p>
+            <a:pPr algn="l">
+              <a:spcAft>
+                <a:spcPts val="200"/>
+              </a:spcAft>
+              <a:defRPr sz="1700" b="1">
+                <a:solidFill>
+                  <a:srgbClr val="111827"/>
+                </a:solidFill>
+              </a:defRPr>
+            </a:pPr>
+            <a:r>
+              <a:t>Une base relationnelle SQL modélisée (MCD/MLD)</a:t>
+            </a:r>
+          </a:p>
+        </p:txBody>
+      </p:sp>
+      <p:sp>
+        <p:nvSpPr>
+          <p:cNvPr id="11" name="Rounded Rectangle 10"/>
+          <p:cNvSpPr/>
+          <p:nvPr/>
+        </p:nvSpPr>
+        <p:spPr>
+          <a:xfrm>
+            <a:off x="822960" y="5303520"/>
+            <a:ext cx="914400" cy="777240"/>
+          </a:xfrm>
+          <a:prstGeom prst="roundRect">
+            <a:avLst/>
+          </a:prstGeom>
+          <a:solidFill>
+            <a:srgbClr val="10B981"/>
+          </a:solidFill>
+          <a:ln>
+            <a:noFill/>
+          </a:ln>
+          <a:effectLst/>
+        </p:spPr>
+        <p:style>
+          <a:lnRef idx="1">
+            <a:schemeClr val="accent1"/>
+          </a:lnRef>
+          <a:fillRef idx="3">
+            <a:schemeClr val="accent1"/>
+          </a:fillRef>
+          <a:effectRef idx="2">
+            <a:schemeClr val="accent1"/>
+          </a:effectRef>
+          <a:fontRef idx="minor">
+            <a:schemeClr val="lt1"/>
+          </a:fontRef>
+        </p:style>
+        <p:txBody>
+          <a:bodyPr rtlCol="0" anchor="ctr" wrap="square"/>
+          <a:lstStyle/>
+          <a:p>
+            <a:pPr algn="ctr">
+              <a:defRPr sz="2000" b="1">
+                <a:solidFill>
+                  <a:srgbClr val="FFFFFF"/>
+                </a:solidFill>
+              </a:defRPr>
+            </a:pPr>
+            <a:r>
+              <a:t>O3</a:t>
+            </a:r>
+          </a:p>
+        </p:txBody>
+      </p:sp>
+      <p:sp>
+        <p:nvSpPr>
+          <p:cNvPr id="12" name="TextBox 11"/>
+          <p:cNvSpPr txBox="1"/>
+          <p:nvPr/>
+        </p:nvSpPr>
+        <p:spPr>
+          <a:xfrm>
+            <a:off x="1965960" y="5440680"/>
+            <a:ext cx="9418320" cy="548640"/>
+          </a:xfrm>
+          <a:prstGeom prst="rect">
+            <a:avLst/>
+          </a:prstGeom>
+          <a:noFill/>
+        </p:spPr>
+        <p:txBody>
+          <a:bodyPr wrap="square" lIns="45720" rIns="45720" tIns="27432" bIns="27432">
+            <a:spAutoFit/>
+          </a:bodyPr>
+          <a:lstStyle/>
+          <a:p>
+            <a:pPr algn="l">
+              <a:spcAft>
+                <a:spcPts val="200"/>
+              </a:spcAft>
+              <a:defRPr sz="1700" b="1">
+                <a:solidFill>
+                  <a:srgbClr val="111827"/>
+                </a:solidFill>
+              </a:defRPr>
+            </a:pPr>
+            <a:r>
+              <a:t>Un tableau de bord avec indicateurs d'insertion</a:t>
+            </a:r>
+          </a:p>
+        </p:txBody>
+      </p:sp>
+      <p:sp>
+        <p:nvSpPr>
+          <p:cNvPr id="13" name="Rounded Rectangle 12"/>
+          <p:cNvSpPr/>
+          <p:nvPr/>
+        </p:nvSpPr>
+        <p:spPr>
+          <a:xfrm>
+            <a:off x="822960" y="6126480"/>
+            <a:ext cx="914400" cy="777240"/>
+          </a:xfrm>
+          <a:prstGeom prst="roundRect">
+            <a:avLst/>
+          </a:prstGeom>
+          <a:solidFill>
+            <a:srgbClr val="10B981"/>
+          </a:solidFill>
+          <a:ln>
+            <a:noFill/>
+          </a:ln>
+          <a:effectLst/>
+        </p:spPr>
+        <p:style>
+          <a:lnRef idx="1">
+            <a:schemeClr val="accent1"/>
+          </a:lnRef>
+          <a:fillRef idx="3">
+            <a:schemeClr val="accent1"/>
+          </a:fillRef>
+          <a:effectRef idx="2">
+            <a:schemeClr val="accent1"/>
+          </a:effectRef>
+          <a:fontRef idx="minor">
+            <a:schemeClr val="lt1"/>
+          </a:fontRef>
+        </p:style>
+        <p:txBody>
+          <a:bodyPr rtlCol="0" anchor="ctr" wrap="square"/>
+          <a:lstStyle/>
+          <a:p>
+            <a:pPr algn="ctr">
+              <a:defRPr sz="2000" b="1">
+                <a:solidFill>
+                  <a:srgbClr val="FFFFFF"/>
+                </a:solidFill>
+              </a:defRPr>
+            </a:pPr>
+            <a:r>
+              <a:t>O4</a:t>
+            </a:r>
+          </a:p>
+        </p:txBody>
+      </p:sp>
+      <p:sp>
+        <p:nvSpPr>
+          <p:cNvPr id="14" name="TextBox 13"/>
+          <p:cNvSpPr txBox="1"/>
+          <p:nvPr/>
+        </p:nvSpPr>
+        <p:spPr>
+          <a:xfrm>
+            <a:off x="1965960" y="6263640"/>
+            <a:ext cx="9418320" cy="548640"/>
+          </a:xfrm>
+          <a:prstGeom prst="rect">
+            <a:avLst/>
+          </a:prstGeom>
+          <a:noFill/>
+        </p:spPr>
+        <p:txBody>
+          <a:bodyPr wrap="square" lIns="45720" rIns="45720" tIns="27432" bIns="27432">
+            <a:spAutoFit/>
+          </a:bodyPr>
+          <a:lstStyle/>
+          <a:p>
+            <a:pPr algn="l">
+              <a:spcAft>
+                <a:spcPts val="200"/>
+              </a:spcAft>
+              <a:defRPr sz="1700" b="1">
+                <a:solidFill>
+                  <a:srgbClr val="111827"/>
+                </a:solidFill>
+              </a:defRPr>
+            </a:pPr>
+            <a:r>
+              <a:t>Une conformité RGPD réelle (consentement, export, suppression, audit)</a:t>
+            </a:r>
+          </a:p>
+        </p:txBody>
+      </p:sp>
+      <p:sp>
+        <p:nvSpPr>
+          <p:cNvPr id="15" name="Rounded Rectangle 14"/>
+          <p:cNvSpPr/>
+          <p:nvPr/>
+        </p:nvSpPr>
+        <p:spPr>
+          <a:xfrm>
+            <a:off x="822960" y="6949440"/>
+            <a:ext cx="914400" cy="777240"/>
+          </a:xfrm>
+          <a:prstGeom prst="roundRect">
+            <a:avLst/>
+          </a:prstGeom>
+          <a:solidFill>
+            <a:srgbClr val="10B981"/>
+          </a:solidFill>
+          <a:ln>
+            <a:noFill/>
+          </a:ln>
+          <a:effectLst/>
+        </p:spPr>
+        <p:style>
+          <a:lnRef idx="1">
+            <a:schemeClr val="accent1"/>
+          </a:lnRef>
+          <a:fillRef idx="3">
+            <a:schemeClr val="accent1"/>
+          </a:fillRef>
+          <a:effectRef idx="2">
+            <a:schemeClr val="accent1"/>
+          </a:effectRef>
+          <a:fontRef idx="minor">
+            <a:schemeClr val="lt1"/>
+          </a:fontRef>
+        </p:style>
+        <p:txBody>
+          <a:bodyPr rtlCol="0" anchor="ctr" wrap="square"/>
+          <a:lstStyle/>
+          <a:p>
+            <a:pPr algn="ctr">
+              <a:defRPr sz="2000" b="1">
+                <a:solidFill>
+                  <a:srgbClr val="FFFFFF"/>
+                </a:solidFill>
+              </a:defRPr>
+            </a:pPr>
+            <a:r>
+              <a:t>O5</a:t>
+            </a:r>
+          </a:p>
+        </p:txBody>
+      </p:sp>
+      <p:sp>
+        <p:nvSpPr>
+          <p:cNvPr id="16" name="TextBox 15"/>
+          <p:cNvSpPr txBox="1"/>
+          <p:nvPr/>
+        </p:nvSpPr>
+        <p:spPr>
+          <a:xfrm>
+            <a:off x="1965960" y="7086600"/>
+            <a:ext cx="9418320" cy="548640"/>
+          </a:xfrm>
+          <a:prstGeom prst="rect">
+            <a:avLst/>
+          </a:prstGeom>
+          <a:noFill/>
+        </p:spPr>
+        <p:txBody>
+          <a:bodyPr wrap="square" lIns="45720" rIns="45720" tIns="27432" bIns="27432">
+            <a:spAutoFit/>
+          </a:bodyPr>
+          <a:lstStyle/>
+          <a:p>
+            <a:pPr algn="l">
+              <a:spcAft>
+                <a:spcPts val="200"/>
+              </a:spcAft>
+              <a:defRPr sz="1700" b="1">
+                <a:solidFill>
+                  <a:srgbClr val="111827"/>
+                </a:solidFill>
+              </a:defRPr>
+            </a:pPr>
+            <a:r>
+              <a:t>L'import/export automatisé (Excel / CSV)</a:t>
+            </a:r>
+          </a:p>
+        </p:txBody>
+      </p:sp>
+      <p:sp>
+        <p:nvSpPr>
+          <p:cNvPr id="17" name="TextBox 16"/>
           <p:cNvSpPr txBox="1"/>
           <p:nvPr/>
         </p:nvSpPr>
@@ -6036,7 +5439,7 @@
               </a:defRPr>
             </a:pPr>
             <a:r>
-              <a:t>Objectifs du stage</a:t>
+              <a:t>Méthodologie et architecture 3-tiers</a:t>
             </a:r>
           </a:p>
         </p:txBody>
@@ -6086,14 +5489,213 @@
       </p:sp>
       <p:sp>
         <p:nvSpPr>
-          <p:cNvPr id="4" name="Rounded Rectangle 3"/>
+          <p:cNvPr id="4" name="TextBox 3"/>
+          <p:cNvSpPr txBox="1"/>
+          <p:nvPr/>
+        </p:nvSpPr>
+        <p:spPr>
+          <a:xfrm>
+            <a:off x="822960" y="1234440"/>
+            <a:ext cx="5394960" cy="4389120"/>
+          </a:xfrm>
+          <a:prstGeom prst="rect">
+            <a:avLst/>
+          </a:prstGeom>
+          <a:noFill/>
+        </p:spPr>
+        <p:txBody>
+          <a:bodyPr wrap="square" lIns="45720" tIns="27432">
+            <a:spAutoFit/>
+          </a:bodyPr>
+          <a:lstStyle/>
+          <a:p>
+            <a:pPr>
+              <a:spcAft>
+                <a:spcPts val="1000"/>
+              </a:spcAft>
+              <a:defRPr sz="1700">
+                <a:solidFill>
+                  <a:srgbClr val="111827"/>
+                </a:solidFill>
+              </a:defRPr>
+            </a:pPr>
+            <a:r>
+              <a:t>• Phases : analyse → conception (MCD/MLD) → développement → consolidation.</a:t>
+            </a:r>
+          </a:p>
+          <a:p>
+            <a:pPr>
+              <a:spcAft>
+                <a:spcPts val="1000"/>
+              </a:spcAft>
+              <a:defRPr sz="1700">
+                <a:solidFill>
+                  <a:srgbClr val="111827"/>
+                </a:solidFill>
+              </a:defRPr>
+            </a:pPr>
+            <a:r>
+              <a:t>• Démarche itérative en solo : audit SQL, rejeu des migrations, tests manuels.</a:t>
+            </a:r>
+          </a:p>
+          <a:p>
+            <a:pPr>
+              <a:spcAft>
+                <a:spcPts val="1000"/>
+              </a:spcAft>
+              <a:defRPr sz="1700">
+                <a:solidFill>
+                  <a:srgbClr val="111827"/>
+                </a:solidFill>
+              </a:defRPr>
+            </a:pPr>
+            <a:r>
+              <a:t>• Failles sécurité identifiées (IDOR, upload, secrets) → correctifs documentés.</a:t>
+            </a:r>
+          </a:p>
+          <a:p>
+            <a:pPr>
+              <a:spcAft>
+                <a:spcPts val="1000"/>
+              </a:spcAft>
+              <a:defRPr sz="1700">
+                <a:solidFill>
+                  <a:srgbClr val="111827"/>
+                </a:solidFill>
+              </a:defRPr>
+            </a:pPr>
+            <a:r>
+              <a:t>• Documentation « comme du code » : tous les livrables générés par script.</a:t>
+            </a:r>
+          </a:p>
+        </p:txBody>
+      </p:sp>
+      <p:sp>
+        <p:nvSpPr>
+          <p:cNvPr id="5" name="Rounded Rectangle 4"/>
           <p:cNvSpPr/>
           <p:nvPr/>
         </p:nvSpPr>
         <p:spPr>
           <a:xfrm>
-            <a:off x="822960" y="1325880"/>
-            <a:ext cx="914400" cy="777240"/>
+            <a:off x="6400800" y="1463040"/>
+            <a:ext cx="1828800" cy="4480560"/>
+          </a:xfrm>
+          <a:prstGeom prst="roundRect">
+            <a:avLst/>
+          </a:prstGeom>
+          <a:solidFill>
+            <a:srgbClr val="1E40AF"/>
+          </a:solidFill>
+          <a:ln>
+            <a:noFill/>
+          </a:ln>
+          <a:effectLst/>
+        </p:spPr>
+        <p:style>
+          <a:lnRef idx="1">
+            <a:schemeClr val="accent1"/>
+          </a:lnRef>
+          <a:fillRef idx="3">
+            <a:schemeClr val="accent1"/>
+          </a:fillRef>
+          <a:effectRef idx="2">
+            <a:schemeClr val="accent1"/>
+          </a:effectRef>
+          <a:fontRef idx="minor">
+            <a:schemeClr val="lt1"/>
+          </a:fontRef>
+        </p:style>
+        <p:txBody>
+          <a:bodyPr rtlCol="0" anchor="ctr" wrap="square"/>
+          <a:lstStyle/>
+          <a:p>
+            <a:pPr algn="ctr">
+              <a:defRPr sz="1700" b="1">
+                <a:solidFill>
+                  <a:srgbClr val="FFFFFF"/>
+                </a:solidFill>
+              </a:defRPr>
+            </a:pPr>
+            <a:r>
+              <a:t>FRONTEND</a:t>
+            </a:r>
+          </a:p>
+          <a:p>
+            <a:pPr>
+              <a:defRPr sz="1300">
+                <a:solidFill>
+                  <a:srgbClr val="FFFFFF"/>
+                </a:solidFill>
+              </a:defRPr>
+            </a:pPr>
+            <a:r>
+              <a:t>React + Vite (SPA)</a:t>
+            </a:r>
+            <a:br/>
+            <a:r>
+              <a:t>Admin / Alumni</a:t>
+            </a:r>
+            <a:br/>
+            <a:r>
+              <a:t>proxy /api → 8000</a:t>
+            </a:r>
+          </a:p>
+        </p:txBody>
+      </p:sp>
+      <p:sp>
+        <p:nvSpPr>
+          <p:cNvPr id="6" name="Right Arrow 5"/>
+          <p:cNvSpPr/>
+          <p:nvPr/>
+        </p:nvSpPr>
+        <p:spPr>
+          <a:xfrm>
+            <a:off x="8202168" y="3474720"/>
+            <a:ext cx="219456" cy="365760"/>
+          </a:xfrm>
+          <a:prstGeom prst="rightArrow">
+            <a:avLst/>
+          </a:prstGeom>
+          <a:solidFill>
+            <a:srgbClr val="6B7280"/>
+          </a:solidFill>
+          <a:ln>
+            <a:noFill/>
+          </a:ln>
+        </p:spPr>
+        <p:style>
+          <a:lnRef idx="1">
+            <a:schemeClr val="accent1"/>
+          </a:lnRef>
+          <a:fillRef idx="3">
+            <a:schemeClr val="accent1"/>
+          </a:fillRef>
+          <a:effectRef idx="2">
+            <a:schemeClr val="accent1"/>
+          </a:effectRef>
+          <a:fontRef idx="minor">
+            <a:schemeClr val="lt1"/>
+          </a:fontRef>
+        </p:style>
+        <p:txBody>
+          <a:bodyPr rtlCol="0" anchor="ctr"/>
+          <a:lstStyle/>
+          <a:p>
+            <a:pPr algn="ctr"/>
+          </a:p>
+        </p:txBody>
+      </p:sp>
+      <p:sp>
+        <p:nvSpPr>
+          <p:cNvPr id="7" name="Rounded Rectangle 6"/>
+          <p:cNvSpPr/>
+          <p:nvPr/>
+        </p:nvSpPr>
+        <p:spPr>
+          <a:xfrm>
+            <a:off x="8485631" y="1463040"/>
+            <a:ext cx="1828800" cy="4480560"/>
           </a:xfrm>
           <a:prstGeom prst="roundRect">
             <a:avLst/>
@@ -6125,72 +5727,97 @@
           <a:lstStyle/>
           <a:p>
             <a:pPr algn="ctr">
-              <a:defRPr sz="2000" b="1">
+              <a:defRPr sz="1700" b="1">
                 <a:solidFill>
                   <a:srgbClr val="FFFFFF"/>
                 </a:solidFill>
               </a:defRPr>
             </a:pPr>
             <a:r>
-              <a:t>O1</a:t>
-            </a:r>
-          </a:p>
-        </p:txBody>
-      </p:sp>
-      <p:sp>
-        <p:nvSpPr>
-          <p:cNvPr id="5" name="TextBox 4"/>
-          <p:cNvSpPr txBox="1"/>
-          <p:nvPr/>
-        </p:nvSpPr>
-        <p:spPr>
-          <a:xfrm>
-            <a:off x="1965960" y="1463040"/>
-            <a:ext cx="9418320" cy="548640"/>
-          </a:xfrm>
-          <a:prstGeom prst="rect">
-            <a:avLst/>
-          </a:prstGeom>
-          <a:noFill/>
-        </p:spPr>
-        <p:txBody>
-          <a:bodyPr wrap="square" lIns="45720" rIns="45720" tIns="27432" bIns="27432">
-            <a:spAutoFit/>
-          </a:bodyPr>
-          <a:lstStyle/>
-          <a:p>
-            <a:pPr algn="l">
-              <a:spcAft>
-                <a:spcPts val="200"/>
-              </a:spcAft>
-              <a:defRPr sz="1800" b="0">
-                <a:solidFill>
-                  <a:srgbClr val="111827"/>
-                </a:solidFill>
-              </a:defRPr>
-            </a:pPr>
-            <a:r>
-              <a:t>Créer un CRM alumni complet (espace admin + espace alumni)</a:t>
-            </a:r>
-          </a:p>
-        </p:txBody>
-      </p:sp>
-      <p:sp>
-        <p:nvSpPr>
-          <p:cNvPr id="6" name="Rounded Rectangle 5"/>
+              <a:t>BACKEND</a:t>
+            </a:r>
+          </a:p>
+          <a:p>
+            <a:pPr>
+              <a:defRPr sz="1300">
+                <a:solidFill>
+                  <a:srgbClr val="FFFFFF"/>
+                </a:solidFill>
+              </a:defRPr>
+            </a:pPr>
+            <a:r>
+              <a:t>FastAPI</a:t>
+            </a:r>
+            <a:br/>
+            <a:r>
+              <a:t>82 endpoints, 16 routeurs</a:t>
+            </a:r>
+            <a:br/>
+            <a:r>
+              <a:t>auth OTP + JWT, clé API, RGPD</a:t>
+            </a:r>
+          </a:p>
+        </p:txBody>
+      </p:sp>
+      <p:sp>
+        <p:nvSpPr>
+          <p:cNvPr id="8" name="Right Arrow 7"/>
           <p:cNvSpPr/>
           <p:nvPr/>
         </p:nvSpPr>
         <p:spPr>
           <a:xfrm>
-            <a:off x="822960" y="2176272"/>
-            <a:ext cx="914400" cy="777240"/>
+            <a:off x="10286999" y="3474720"/>
+            <a:ext cx="219456" cy="365760"/>
+          </a:xfrm>
+          <a:prstGeom prst="rightArrow">
+            <a:avLst/>
+          </a:prstGeom>
+          <a:solidFill>
+            <a:srgbClr val="6B7280"/>
+          </a:solidFill>
+          <a:ln>
+            <a:noFill/>
+          </a:ln>
+        </p:spPr>
+        <p:style>
+          <a:lnRef idx="1">
+            <a:schemeClr val="accent1"/>
+          </a:lnRef>
+          <a:fillRef idx="3">
+            <a:schemeClr val="accent1"/>
+          </a:fillRef>
+          <a:effectRef idx="2">
+            <a:schemeClr val="accent1"/>
+          </a:effectRef>
+          <a:fontRef idx="minor">
+            <a:schemeClr val="lt1"/>
+          </a:fontRef>
+        </p:style>
+        <p:txBody>
+          <a:bodyPr rtlCol="0" anchor="ctr"/>
+          <a:lstStyle/>
+          <a:p>
+            <a:pPr algn="ctr"/>
+          </a:p>
+        </p:txBody>
+      </p:sp>
+      <p:sp>
+        <p:nvSpPr>
+          <p:cNvPr id="9" name="Rounded Rectangle 8"/>
+          <p:cNvSpPr/>
+          <p:nvPr/>
+        </p:nvSpPr>
+        <p:spPr>
+          <a:xfrm>
+            <a:off x="10570462" y="1463040"/>
+            <a:ext cx="1828800" cy="4480560"/>
           </a:xfrm>
           <a:prstGeom prst="roundRect">
             <a:avLst/>
           </a:prstGeom>
           <a:solidFill>
-            <a:srgbClr val="10B981"/>
+            <a:srgbClr val="111827"/>
           </a:solidFill>
           <a:ln>
             <a:noFill/>
@@ -6216,423 +5843,37 @@
           <a:lstStyle/>
           <a:p>
             <a:pPr algn="ctr">
-              <a:defRPr sz="2000" b="1">
+              <a:defRPr sz="1700" b="1">
                 <a:solidFill>
                   <a:srgbClr val="FFFFFF"/>
                 </a:solidFill>
               </a:defRPr>
             </a:pPr>
             <a:r>
-              <a:t>O2</a:t>
-            </a:r>
-          </a:p>
-        </p:txBody>
-      </p:sp>
-      <p:sp>
-        <p:nvSpPr>
-          <p:cNvPr id="7" name="TextBox 6"/>
-          <p:cNvSpPr txBox="1"/>
-          <p:nvPr/>
-        </p:nvSpPr>
-        <p:spPr>
-          <a:xfrm>
-            <a:off x="1965960" y="2313432"/>
-            <a:ext cx="9418320" cy="548640"/>
-          </a:xfrm>
-          <a:prstGeom prst="rect">
-            <a:avLst/>
-          </a:prstGeom>
-          <a:noFill/>
-        </p:spPr>
-        <p:txBody>
-          <a:bodyPr wrap="square" lIns="45720" rIns="45720" tIns="27432" bIns="27432">
-            <a:spAutoFit/>
-          </a:bodyPr>
-          <a:lstStyle/>
-          <a:p>
-            <a:pPr algn="l">
-              <a:spcAft>
-                <a:spcPts val="200"/>
-              </a:spcAft>
-              <a:defRPr sz="1800" b="0">
-                <a:solidFill>
-                  <a:srgbClr val="111827"/>
-                </a:solidFill>
-              </a:defRPr>
-            </a:pPr>
-            <a:r>
-              <a:t>Modéliser et implémenter une base relationnelle SQL (14 tables)</a:t>
-            </a:r>
-          </a:p>
-        </p:txBody>
-      </p:sp>
-      <p:sp>
-        <p:nvSpPr>
-          <p:cNvPr id="8" name="Rounded Rectangle 7"/>
-          <p:cNvSpPr/>
-          <p:nvPr/>
-        </p:nvSpPr>
-        <p:spPr>
-          <a:xfrm>
-            <a:off x="822960" y="3026664"/>
-            <a:ext cx="914400" cy="777240"/>
-          </a:xfrm>
-          <a:prstGeom prst="roundRect">
-            <a:avLst/>
-          </a:prstGeom>
-          <a:solidFill>
-            <a:srgbClr val="10B981"/>
-          </a:solidFill>
-          <a:ln>
-            <a:noFill/>
-          </a:ln>
-          <a:effectLst/>
-        </p:spPr>
-        <p:style>
-          <a:lnRef idx="1">
-            <a:schemeClr val="accent1"/>
-          </a:lnRef>
-          <a:fillRef idx="3">
-            <a:schemeClr val="accent1"/>
-          </a:fillRef>
-          <a:effectRef idx="2">
-            <a:schemeClr val="accent1"/>
-          </a:effectRef>
-          <a:fontRef idx="minor">
-            <a:schemeClr val="lt1"/>
-          </a:fontRef>
-        </p:style>
-        <p:txBody>
-          <a:bodyPr rtlCol="0" anchor="ctr" wrap="square"/>
-          <a:lstStyle/>
-          <a:p>
-            <a:pPr algn="ctr">
-              <a:defRPr sz="2000" b="1">
+              <a:t>BASE DE DONNÉES</a:t>
+            </a:r>
+          </a:p>
+          <a:p>
+            <a:pPr>
+              <a:defRPr sz="1300">
                 <a:solidFill>
                   <a:srgbClr val="FFFFFF"/>
                 </a:solidFill>
               </a:defRPr>
             </a:pPr>
             <a:r>
-              <a:t>O3</a:t>
-            </a:r>
-          </a:p>
-        </p:txBody>
-      </p:sp>
-      <p:sp>
-        <p:nvSpPr>
-          <p:cNvPr id="9" name="TextBox 8"/>
-          <p:cNvSpPr txBox="1"/>
-          <p:nvPr/>
-        </p:nvSpPr>
-        <p:spPr>
-          <a:xfrm>
-            <a:off x="1965960" y="3163824"/>
-            <a:ext cx="9418320" cy="548640"/>
-          </a:xfrm>
-          <a:prstGeom prst="rect">
-            <a:avLst/>
-          </a:prstGeom>
-          <a:noFill/>
-        </p:spPr>
-        <p:txBody>
-          <a:bodyPr wrap="square" lIns="45720" rIns="45720" tIns="27432" bIns="27432">
-            <a:spAutoFit/>
-          </a:bodyPr>
-          <a:lstStyle/>
-          <a:p>
-            <a:pPr algn="l">
-              <a:spcAft>
-                <a:spcPts val="200"/>
-              </a:spcAft>
-              <a:defRPr sz="1800" b="0">
-                <a:solidFill>
-                  <a:srgbClr val="111827"/>
-                </a:solidFill>
-              </a:defRPr>
-            </a:pPr>
-            <a:r>
-              <a:t>Développer un tableau de bord admin avec indicateurs d'insertion</a:t>
-            </a:r>
-          </a:p>
-        </p:txBody>
-      </p:sp>
-      <p:sp>
-        <p:nvSpPr>
-          <p:cNvPr id="10" name="Rounded Rectangle 9"/>
-          <p:cNvSpPr/>
-          <p:nvPr/>
-        </p:nvSpPr>
-        <p:spPr>
-          <a:xfrm>
-            <a:off x="822960" y="3877056"/>
-            <a:ext cx="914400" cy="777240"/>
-          </a:xfrm>
-          <a:prstGeom prst="roundRect">
-            <a:avLst/>
-          </a:prstGeom>
-          <a:solidFill>
-            <a:srgbClr val="10B981"/>
-          </a:solidFill>
-          <a:ln>
-            <a:noFill/>
-          </a:ln>
-          <a:effectLst/>
-        </p:spPr>
-        <p:style>
-          <a:lnRef idx="1">
-            <a:schemeClr val="accent1"/>
-          </a:lnRef>
-          <a:fillRef idx="3">
-            <a:schemeClr val="accent1"/>
-          </a:fillRef>
-          <a:effectRef idx="2">
-            <a:schemeClr val="accent1"/>
-          </a:effectRef>
-          <a:fontRef idx="minor">
-            <a:schemeClr val="lt1"/>
-          </a:fontRef>
-        </p:style>
-        <p:txBody>
-          <a:bodyPr rtlCol="0" anchor="ctr" wrap="square"/>
-          <a:lstStyle/>
-          <a:p>
-            <a:pPr algn="ctr">
-              <a:defRPr sz="2000" b="1">
-                <a:solidFill>
-                  <a:srgbClr val="FFFFFF"/>
-                </a:solidFill>
-              </a:defRPr>
-            </a:pPr>
-            <a:r>
-              <a:t>O4</a:t>
-            </a:r>
-          </a:p>
-        </p:txBody>
-      </p:sp>
-      <p:sp>
-        <p:nvSpPr>
-          <p:cNvPr id="11" name="TextBox 10"/>
-          <p:cNvSpPr txBox="1"/>
-          <p:nvPr/>
-        </p:nvSpPr>
-        <p:spPr>
-          <a:xfrm>
-            <a:off x="1965960" y="4014216"/>
-            <a:ext cx="9418320" cy="548640"/>
-          </a:xfrm>
-          <a:prstGeom prst="rect">
-            <a:avLst/>
-          </a:prstGeom>
-          <a:noFill/>
-        </p:spPr>
-        <p:txBody>
-          <a:bodyPr wrap="square" lIns="45720" rIns="45720" tIns="27432" bIns="27432">
-            <a:spAutoFit/>
-          </a:bodyPr>
-          <a:lstStyle/>
-          <a:p>
-            <a:pPr algn="l">
-              <a:spcAft>
-                <a:spcPts val="200"/>
-              </a:spcAft>
-              <a:defRPr sz="1800" b="0">
-                <a:solidFill>
-                  <a:srgbClr val="111827"/>
-                </a:solidFill>
-              </a:defRPr>
-            </a:pPr>
-            <a:r>
-              <a:t>Implémenter la conformité RGPD (consentement, export, suppression, audit)</a:t>
-            </a:r>
-          </a:p>
-        </p:txBody>
-      </p:sp>
-      <p:sp>
-        <p:nvSpPr>
-          <p:cNvPr id="12" name="Rounded Rectangle 11"/>
-          <p:cNvSpPr/>
-          <p:nvPr/>
-        </p:nvSpPr>
-        <p:spPr>
-          <a:xfrm>
-            <a:off x="822960" y="4727448"/>
-            <a:ext cx="914400" cy="777240"/>
-          </a:xfrm>
-          <a:prstGeom prst="roundRect">
-            <a:avLst/>
-          </a:prstGeom>
-          <a:solidFill>
-            <a:srgbClr val="10B981"/>
-          </a:solidFill>
-          <a:ln>
-            <a:noFill/>
-          </a:ln>
-          <a:effectLst/>
-        </p:spPr>
-        <p:style>
-          <a:lnRef idx="1">
-            <a:schemeClr val="accent1"/>
-          </a:lnRef>
-          <a:fillRef idx="3">
-            <a:schemeClr val="accent1"/>
-          </a:fillRef>
-          <a:effectRef idx="2">
-            <a:schemeClr val="accent1"/>
-          </a:effectRef>
-          <a:fontRef idx="minor">
-            <a:schemeClr val="lt1"/>
-          </a:fontRef>
-        </p:style>
-        <p:txBody>
-          <a:bodyPr rtlCol="0" anchor="ctr" wrap="square"/>
-          <a:lstStyle/>
-          <a:p>
-            <a:pPr algn="ctr">
-              <a:defRPr sz="2000" b="1">
-                <a:solidFill>
-                  <a:srgbClr val="FFFFFF"/>
-                </a:solidFill>
-              </a:defRPr>
-            </a:pPr>
-            <a:r>
-              <a:t>O5</a:t>
-            </a:r>
-          </a:p>
-        </p:txBody>
-      </p:sp>
-      <p:sp>
-        <p:nvSpPr>
-          <p:cNvPr id="13" name="TextBox 12"/>
-          <p:cNvSpPr txBox="1"/>
-          <p:nvPr/>
-        </p:nvSpPr>
-        <p:spPr>
-          <a:xfrm>
-            <a:off x="1965960" y="4864608"/>
-            <a:ext cx="9418320" cy="548640"/>
-          </a:xfrm>
-          <a:prstGeom prst="rect">
-            <a:avLst/>
-          </a:prstGeom>
-          <a:noFill/>
-        </p:spPr>
-        <p:txBody>
-          <a:bodyPr wrap="square" lIns="45720" rIns="45720" tIns="27432" bIns="27432">
-            <a:spAutoFit/>
-          </a:bodyPr>
-          <a:lstStyle/>
-          <a:p>
-            <a:pPr algn="l">
-              <a:spcAft>
-                <a:spcPts val="200"/>
-              </a:spcAft>
-              <a:defRPr sz="1800" b="0">
-                <a:solidFill>
-                  <a:srgbClr val="111827"/>
-                </a:solidFill>
-              </a:defRPr>
-            </a:pPr>
-            <a:r>
-              <a:t>Automatiser l'import/export des données (Excel / CSV)</a:t>
-            </a:r>
-          </a:p>
-        </p:txBody>
-      </p:sp>
-      <p:sp>
-        <p:nvSpPr>
-          <p:cNvPr id="14" name="Rounded Rectangle 13"/>
-          <p:cNvSpPr/>
-          <p:nvPr/>
-        </p:nvSpPr>
-        <p:spPr>
-          <a:xfrm>
-            <a:off x="822960" y="5577840"/>
-            <a:ext cx="914400" cy="777240"/>
-          </a:xfrm>
-          <a:prstGeom prst="roundRect">
-            <a:avLst/>
-          </a:prstGeom>
-          <a:solidFill>
-            <a:srgbClr val="10B981"/>
-          </a:solidFill>
-          <a:ln>
-            <a:noFill/>
-          </a:ln>
-          <a:effectLst/>
-        </p:spPr>
-        <p:style>
-          <a:lnRef idx="1">
-            <a:schemeClr val="accent1"/>
-          </a:lnRef>
-          <a:fillRef idx="3">
-            <a:schemeClr val="accent1"/>
-          </a:fillRef>
-          <a:effectRef idx="2">
-            <a:schemeClr val="accent1"/>
-          </a:effectRef>
-          <a:fontRef idx="minor">
-            <a:schemeClr val="lt1"/>
-          </a:fontRef>
-        </p:style>
-        <p:txBody>
-          <a:bodyPr rtlCol="0" anchor="ctr" wrap="square"/>
-          <a:lstStyle/>
-          <a:p>
-            <a:pPr algn="ctr">
-              <a:defRPr sz="2000" b="1">
-                <a:solidFill>
-                  <a:srgbClr val="FFFFFF"/>
-                </a:solidFill>
-              </a:defRPr>
-            </a:pPr>
-            <a:r>
-              <a:t>O6</a:t>
-            </a:r>
-          </a:p>
-        </p:txBody>
-      </p:sp>
-      <p:sp>
-        <p:nvSpPr>
-          <p:cNvPr id="15" name="TextBox 14"/>
-          <p:cNvSpPr txBox="1"/>
-          <p:nvPr/>
-        </p:nvSpPr>
-        <p:spPr>
-          <a:xfrm>
-            <a:off x="1965960" y="5715000"/>
-            <a:ext cx="9418320" cy="548640"/>
-          </a:xfrm>
-          <a:prstGeom prst="rect">
-            <a:avLst/>
-          </a:prstGeom>
-          <a:noFill/>
-        </p:spPr>
-        <p:txBody>
-          <a:bodyPr wrap="square" lIns="45720" rIns="45720" tIns="27432" bIns="27432">
-            <a:spAutoFit/>
-          </a:bodyPr>
-          <a:lstStyle/>
-          <a:p>
-            <a:pPr algn="l">
-              <a:spcAft>
-                <a:spcPts val="200"/>
-              </a:spcAft>
-              <a:defRPr sz="1800" b="0">
-                <a:solidFill>
-                  <a:srgbClr val="111827"/>
-                </a:solidFill>
-              </a:defRPr>
-            </a:pPr>
-            <a:r>
-              <a:t>Documenter les processus managériaux (gouvernance, newsletter, questionnaire)</a:t>
-            </a:r>
-          </a:p>
-        </p:txBody>
-      </p:sp>
-      <p:sp>
-        <p:nvSpPr>
-          <p:cNvPr id="16" name="TextBox 15"/>
+              <a:t>PostgreSQL</a:t>
+            </a:r>
+            <a:br/>
+            <a:r>
+              <a:t>14 tables, 16 migrations, JSONB</a:t>
+            </a:r>
+          </a:p>
+        </p:txBody>
+      </p:sp>
+      <p:sp>
+        <p:nvSpPr>
+          <p:cNvPr id="10" name="TextBox 9"/>
           <p:cNvSpPr txBox="1"/>
           <p:nvPr/>
         </p:nvSpPr>
@@ -6738,7 +5979,7 @@
               </a:defRPr>
             </a:pPr>
             <a:r>
-              <a:t>Méthodologie et déroulement</a:t>
+              <a:t>Modèle de données (MCD/MLD)</a:t>
             </a:r>
           </a:p>
         </p:txBody>
@@ -6795,7 +6036,7 @@
         <p:spPr>
           <a:xfrm>
             <a:off x="822960" y="1371600"/>
-            <a:ext cx="10607040" cy="2743200"/>
+            <a:ext cx="10607040" cy="4754880"/>
           </a:xfrm>
           <a:prstGeom prst="rect">
             <a:avLst/>
@@ -6810,90 +6051,67 @@
           <a:p>
             <a:pPr>
               <a:spcAft>
-                <a:spcPts val="800"/>
+                <a:spcPts val="1200"/>
               </a:spcAft>
-              <a:defRPr sz="1900">
+              <a:defRPr sz="1800">
                 <a:solidFill>
                   <a:srgbClr val="111827"/>
                 </a:solidFill>
               </a:defRPr>
             </a:pPr>
             <a:r>
-              <a:t>• Phase d'analyse : cahier des charges, étude des solutions existantes, choix de la stack.</a:t>
+              <a:t>• 5 domaines, 14 tables.</a:t>
             </a:r>
           </a:p>
           <a:p>
             <a:pPr>
               <a:spcAft>
-                <a:spcPts val="800"/>
+                <a:spcPts val="1200"/>
               </a:spcAft>
-              <a:defRPr sz="1900">
+              <a:defRPr sz="1800">
                 <a:solidFill>
                   <a:srgbClr val="111827"/>
                 </a:solidFill>
               </a:defRPr>
             </a:pPr>
             <a:r>
-              <a:t>• Phase de conception : MCD/MLD, règle d'intégrité, schéma d'API.</a:t>
+              <a:t>• Étudiants : ETUDIANT, PROMOTION (N:1).</a:t>
             </a:r>
           </a:p>
           <a:p>
             <a:pPr>
               <a:spcAft>
-                <a:spcPts val="800"/>
+                <a:spcPts val="1200"/>
               </a:spcAft>
-              <a:defRPr sz="1900">
+              <a:defRPr sz="1800">
                 <a:solidFill>
                   <a:srgbClr val="111827"/>
                 </a:solidFill>
               </a:defRPr>
             </a:pPr>
             <a:r>
-              <a:t>• Phase de développement : backend FastAPI, frontend React, conformité RGPD.</a:t>
+              <a:t>• Parcours pro : ENTREPRISE, EXPERIENCE_PRO, CERTIFICATION, OBTIENT (N:M).</a:t>
             </a:r>
           </a:p>
           <a:p>
             <a:pPr>
               <a:spcAft>
-                <a:spcPts val="800"/>
+                <a:spcPts val="1200"/>
               </a:spcAft>
-              <a:defRPr sz="1900">
+              <a:defRPr sz="1800">
                 <a:solidFill>
                   <a:srgbClr val="111827"/>
                 </a:solidFill>
               </a:defRPr>
             </a:pPr>
             <a:r>
-              <a:t>• Phase de consolidation : revue de conformité, documentation des livrables, préparation du guide des processus.</a:t>
-            </a:r>
-          </a:p>
-        </p:txBody>
-      </p:sp>
-      <p:sp>
-        <p:nvSpPr>
-          <p:cNvPr id="5" name="TextBox 4"/>
-          <p:cNvSpPr txBox="1"/>
-          <p:nvPr/>
-        </p:nvSpPr>
-        <p:spPr>
-          <a:xfrm>
-            <a:off x="822960" y="4206240"/>
-            <a:ext cx="10607040" cy="1828800"/>
-          </a:xfrm>
-          <a:prstGeom prst="rect">
-            <a:avLst/>
-          </a:prstGeom>
-          <a:noFill/>
-        </p:spPr>
-        <p:txBody>
-          <a:bodyPr wrap="square" lIns="45720" tIns="27432">
-            <a:spAutoFit/>
-          </a:bodyPr>
-          <a:lstStyle/>
+              <a:t>• RGPD : CONSENTEMENT_RGPD, DEMANDE_RGPD, AUDIT_LOG.</a:t>
+            </a:r>
+          </a:p>
           <a:p>
             <a:pPr>
               <a:spcAft>
-                <a:spcPts val="800"/>
+                <a:spcPts val="1200"/>
               </a:spcAft>
               <a:defRPr sz="1800">
                 <a:solidFill>
@@ -6902,13 +6120,13 @@
               </a:defRPr>
             </a:pPr>
             <a:r>
-              <a:t>• Démarche itérative en solo : audit de cohérence par introspection SQL, rejeu des migrations, tests manuels des parcours.</a:t>
+              <a:t>• Questionnaires : QUESTIONNAIRE, QUESTION, REPONSE_QUESTIONNAIRE (JSON).</a:t>
             </a:r>
           </a:p>
           <a:p>
             <a:pPr>
               <a:spcAft>
-                <a:spcPts val="800"/>
+                <a:spcPts val="1200"/>
               </a:spcAft>
               <a:defRPr sz="1800">
                 <a:solidFill>
@@ -6917,14 +6135,14 @@
               </a:defRPr>
             </a:pPr>
             <a:r>
-              <a:t>• Documentation « comme du code » : tous les livrables générés par script (PDF, DOCX, PPTX).</a:t>
-            </a:r>
-          </a:p>
-        </p:txBody>
-      </p:sp>
-      <p:sp>
-        <p:nvSpPr>
-          <p:cNvPr id="6" name="TextBox 5"/>
+              <a:t>• Cascade et contraintes d'unicité garantissent la cohérence.</a:t>
+            </a:r>
+          </a:p>
+        </p:txBody>
+      </p:sp>
+      <p:sp>
+        <p:nvSpPr>
+          <p:cNvPr id="5" name="TextBox 4"/>
           <p:cNvSpPr txBox="1"/>
           <p:nvPr/>
         </p:nvSpPr>
@@ -7030,7 +6248,7 @@
               </a:defRPr>
             </a:pPr>
             <a:r>
-              <a:t>Choix technologiques et arbitrages</a:t>
+              <a:t>Conformité RGPD</a:t>
             </a:r>
           </a:p>
         </p:txBody>
@@ -7080,58 +6298,14 @@
       </p:sp>
       <p:sp>
         <p:nvSpPr>
-          <p:cNvPr id="4" name="Rounded Rectangle 3"/>
-          <p:cNvSpPr/>
-          <p:nvPr/>
-        </p:nvSpPr>
-        <p:spPr>
-          <a:xfrm>
-            <a:off x="822960" y="1371600"/>
-            <a:ext cx="10607040" cy="1097280"/>
-          </a:xfrm>
-          <a:prstGeom prst="roundRect">
-            <a:avLst/>
-          </a:prstGeom>
-          <a:solidFill>
-            <a:srgbClr val="EFF6FF"/>
-          </a:solidFill>
-          <a:ln>
-            <a:noFill/>
-          </a:ln>
-          <a:effectLst/>
-        </p:spPr>
-        <p:style>
-          <a:lnRef idx="1">
-            <a:schemeClr val="accent1"/>
-          </a:lnRef>
-          <a:fillRef idx="3">
-            <a:schemeClr val="accent1"/>
-          </a:fillRef>
-          <a:effectRef idx="2">
-            <a:schemeClr val="accent1"/>
-          </a:effectRef>
-          <a:fontRef idx="minor">
-            <a:schemeClr val="lt1"/>
-          </a:fontRef>
-        </p:style>
-        <p:txBody>
-          <a:bodyPr rtlCol="0" anchor="ctr"/>
-          <a:lstStyle/>
-          <a:p>
-            <a:pPr algn="ctr"/>
-          </a:p>
-        </p:txBody>
-      </p:sp>
-      <p:sp>
-        <p:nvSpPr>
-          <p:cNvPr id="5" name="TextBox 4"/>
+          <p:cNvPr id="4" name="TextBox 3"/>
           <p:cNvSpPr txBox="1"/>
           <p:nvPr/>
         </p:nvSpPr>
         <p:spPr>
           <a:xfrm>
-            <a:off x="1097280" y="1463040"/>
-            <a:ext cx="2926080" cy="457200"/>
+            <a:off x="822960" y="1280160"/>
+            <a:ext cx="5394960" cy="2377440"/>
           </a:xfrm>
           <a:prstGeom prst="rect">
             <a:avLst/>
@@ -7139,580 +6313,108 @@
           <a:noFill/>
         </p:spPr>
         <p:txBody>
-          <a:bodyPr wrap="square" lIns="45720" rIns="45720" tIns="27432" bIns="27432">
+          <a:bodyPr wrap="square" lIns="45720" tIns="27432">
             <a:spAutoFit/>
           </a:bodyPr>
           <a:lstStyle/>
           <a:p>
-            <a:pPr algn="l">
+            <a:pPr>
               <a:spcAft>
-                <a:spcPts val="200"/>
+                <a:spcPts val="800"/>
               </a:spcAft>
-              <a:defRPr sz="2000" b="1">
-                <a:solidFill>
-                  <a:srgbClr val="1E40AF"/>
-                </a:solidFill>
-              </a:defRPr>
-            </a:pPr>
-            <a:r>
-              <a:t>Backend</a:t>
-            </a:r>
-          </a:p>
-        </p:txBody>
-      </p:sp>
-      <p:sp>
-        <p:nvSpPr>
-          <p:cNvPr id="6" name="TextBox 5"/>
-          <p:cNvSpPr txBox="1"/>
-          <p:nvPr/>
-        </p:nvSpPr>
-        <p:spPr>
-          <a:xfrm>
-            <a:off x="1097280" y="1874520"/>
-            <a:ext cx="7498079" cy="640080"/>
+              <a:defRPr sz="1600">
+                <a:solidFill>
+                  <a:srgbClr val="111827"/>
+                </a:solidFill>
+              </a:defRPr>
+            </a:pPr>
+            <a:r>
+              <a:t>• Consentement explicite : 4 types, horodaté et réellement consommé.</a:t>
+            </a:r>
+          </a:p>
+          <a:p>
+            <a:pPr>
+              <a:spcAft>
+                <a:spcPts val="800"/>
+              </a:spcAft>
+              <a:defRPr sz="1600">
+                <a:solidFill>
+                  <a:srgbClr val="111827"/>
+                </a:solidFill>
+              </a:defRPr>
+            </a:pPr>
+            <a:r>
+              <a:t>• Droits : export en auto-service (JSON/Excel/CSV), suppression avec workflow verrouillé.</a:t>
+            </a:r>
+          </a:p>
+          <a:p>
+            <a:pPr>
+              <a:spcAft>
+                <a:spcPts val="800"/>
+              </a:spcAft>
+              <a:defRPr sz="1600">
+                <a:solidFill>
+                  <a:srgbClr val="111827"/>
+                </a:solidFill>
+              </a:defRPr>
+            </a:pPr>
+            <a:r>
+              <a:t>• Anonymisation vs suppression ; journal d'audit ; purge différée.</a:t>
+            </a:r>
+          </a:p>
+        </p:txBody>
+      </p:sp>
+      <p:pic>
+        <p:nvPicPr>
+          <p:cNvPr id="5" name="Picture 4" descr="anC_consentement_light.png"/>
+          <p:cNvPicPr>
+            <a:picLocks noChangeAspect="1"/>
+          </p:cNvPicPr>
+          <p:nvPr/>
+        </p:nvPicPr>
+        <p:blipFill>
+          <a:blip r:embed="rId2"/>
+          <a:stretch>
+            <a:fillRect/>
+          </a:stretch>
+        </p:blipFill>
+        <p:spPr>
+          <a:xfrm>
+            <a:off x="822960" y="3657600"/>
+            <a:ext cx="5394960" cy="3371850"/>
           </a:xfrm>
           <a:prstGeom prst="rect">
             <a:avLst/>
           </a:prstGeom>
-          <a:noFill/>
-        </p:spPr>
-        <p:txBody>
-          <a:bodyPr wrap="square" lIns="45720" rIns="45720" tIns="27432" bIns="27432">
-            <a:spAutoFit/>
-          </a:bodyPr>
-          <a:lstStyle/>
-          <a:p>
-            <a:pPr algn="l">
-              <a:spcAft>
-                <a:spcPts val="200"/>
-              </a:spcAft>
-              <a:defRPr sz="1600" b="0">
-                <a:solidFill>
-                  <a:srgbClr val="111827"/>
-                </a:solidFill>
-              </a:defRPr>
-            </a:pPr>
-            <a:r>
-              <a:t>FastAPI (Python) + Pydantic : validation, docs Swagger automatiques</a:t>
-            </a:r>
-          </a:p>
-        </p:txBody>
-      </p:sp>
+        </p:spPr>
+      </p:pic>
+      <p:pic>
+        <p:nvPicPr>
+          <p:cNvPr id="6" name="Picture 5" descr="anB_demandes_rgpd_light.png"/>
+          <p:cNvPicPr>
+            <a:picLocks noChangeAspect="1"/>
+          </p:cNvPicPr>
+          <p:nvPr/>
+        </p:nvPicPr>
+        <p:blipFill>
+          <a:blip r:embed="rId3"/>
+          <a:stretch>
+            <a:fillRect/>
+          </a:stretch>
+        </p:blipFill>
+        <p:spPr>
+          <a:xfrm>
+            <a:off x="6400800" y="1280160"/>
+            <a:ext cx="5394960" cy="3371850"/>
+          </a:xfrm>
+          <a:prstGeom prst="rect">
+            <a:avLst/>
+          </a:prstGeom>
+        </p:spPr>
+      </p:pic>
       <p:sp>
         <p:nvSpPr>
           <p:cNvPr id="7" name="TextBox 6"/>
-          <p:cNvSpPr txBox="1"/>
-          <p:nvPr/>
-        </p:nvSpPr>
-        <p:spPr>
-          <a:xfrm>
-            <a:off x="8778240" y="1828800"/>
-            <a:ext cx="2377440" cy="457200"/>
-          </a:xfrm>
-          <a:prstGeom prst="rect">
-            <a:avLst/>
-          </a:prstGeom>
-          <a:noFill/>
-        </p:spPr>
-        <p:txBody>
-          <a:bodyPr wrap="square" lIns="45720" rIns="45720" tIns="27432" bIns="27432">
-            <a:spAutoFit/>
-          </a:bodyPr>
-          <a:lstStyle/>
-          <a:p>
-            <a:pPr algn="r">
-              <a:spcAft>
-                <a:spcPts val="200"/>
-              </a:spcAft>
-              <a:defRPr sz="1400" b="1">
-                <a:solidFill>
-                  <a:srgbClr val="10B981"/>
-                </a:solidFill>
-              </a:defRPr>
-            </a:pPr>
-            <a:r>
-              <a:t>82 endpoints REST</a:t>
-            </a:r>
-          </a:p>
-        </p:txBody>
-      </p:sp>
-      <p:sp>
-        <p:nvSpPr>
-          <p:cNvPr id="8" name="Rounded Rectangle 7"/>
-          <p:cNvSpPr/>
-          <p:nvPr/>
-        </p:nvSpPr>
-        <p:spPr>
-          <a:xfrm>
-            <a:off x="822960" y="2606040"/>
-            <a:ext cx="10607040" cy="1097280"/>
-          </a:xfrm>
-          <a:prstGeom prst="roundRect">
-            <a:avLst/>
-          </a:prstGeom>
-          <a:solidFill>
-            <a:srgbClr val="EFF6FF"/>
-          </a:solidFill>
-          <a:ln>
-            <a:noFill/>
-          </a:ln>
-          <a:effectLst/>
-        </p:spPr>
-        <p:style>
-          <a:lnRef idx="1">
-            <a:schemeClr val="accent1"/>
-          </a:lnRef>
-          <a:fillRef idx="3">
-            <a:schemeClr val="accent1"/>
-          </a:fillRef>
-          <a:effectRef idx="2">
-            <a:schemeClr val="accent1"/>
-          </a:effectRef>
-          <a:fontRef idx="minor">
-            <a:schemeClr val="lt1"/>
-          </a:fontRef>
-        </p:style>
-        <p:txBody>
-          <a:bodyPr rtlCol="0" anchor="ctr"/>
-          <a:lstStyle/>
-          <a:p>
-            <a:pPr algn="ctr"/>
-          </a:p>
-        </p:txBody>
-      </p:sp>
-      <p:sp>
-        <p:nvSpPr>
-          <p:cNvPr id="9" name="TextBox 8"/>
-          <p:cNvSpPr txBox="1"/>
-          <p:nvPr/>
-        </p:nvSpPr>
-        <p:spPr>
-          <a:xfrm>
-            <a:off x="1097280" y="2697480"/>
-            <a:ext cx="2926080" cy="457200"/>
-          </a:xfrm>
-          <a:prstGeom prst="rect">
-            <a:avLst/>
-          </a:prstGeom>
-          <a:noFill/>
-        </p:spPr>
-        <p:txBody>
-          <a:bodyPr wrap="square" lIns="45720" rIns="45720" tIns="27432" bIns="27432">
-            <a:spAutoFit/>
-          </a:bodyPr>
-          <a:lstStyle/>
-          <a:p>
-            <a:pPr algn="l">
-              <a:spcAft>
-                <a:spcPts val="200"/>
-              </a:spcAft>
-              <a:defRPr sz="2000" b="1">
-                <a:solidFill>
-                  <a:srgbClr val="1E40AF"/>
-                </a:solidFill>
-              </a:defRPr>
-            </a:pPr>
-            <a:r>
-              <a:t>Frontend</a:t>
-            </a:r>
-          </a:p>
-        </p:txBody>
-      </p:sp>
-      <p:sp>
-        <p:nvSpPr>
-          <p:cNvPr id="10" name="TextBox 9"/>
-          <p:cNvSpPr txBox="1"/>
-          <p:nvPr/>
-        </p:nvSpPr>
-        <p:spPr>
-          <a:xfrm>
-            <a:off x="1097280" y="3108960"/>
-            <a:ext cx="7498079" cy="640080"/>
-          </a:xfrm>
-          <a:prstGeom prst="rect">
-            <a:avLst/>
-          </a:prstGeom>
-          <a:noFill/>
-        </p:spPr>
-        <p:txBody>
-          <a:bodyPr wrap="square" lIns="45720" rIns="45720" tIns="27432" bIns="27432">
-            <a:spAutoFit/>
-          </a:bodyPr>
-          <a:lstStyle/>
-          <a:p>
-            <a:pPr algn="l">
-              <a:spcAft>
-                <a:spcPts val="200"/>
-              </a:spcAft>
-              <a:defRPr sz="1600" b="0">
-                <a:solidFill>
-                  <a:srgbClr val="111827"/>
-                </a:solidFill>
-              </a:defRPr>
-            </a:pPr>
-            <a:r>
-              <a:t>React + Vite : SPA fluide, composants partagés, garde de routes par rôle</a:t>
-            </a:r>
-          </a:p>
-        </p:txBody>
-      </p:sp>
-      <p:sp>
-        <p:nvSpPr>
-          <p:cNvPr id="11" name="TextBox 10"/>
-          <p:cNvSpPr txBox="1"/>
-          <p:nvPr/>
-        </p:nvSpPr>
-        <p:spPr>
-          <a:xfrm>
-            <a:off x="8778240" y="3063240"/>
-            <a:ext cx="2377440" cy="457200"/>
-          </a:xfrm>
-          <a:prstGeom prst="rect">
-            <a:avLst/>
-          </a:prstGeom>
-          <a:noFill/>
-        </p:spPr>
-        <p:txBody>
-          <a:bodyPr wrap="square" lIns="45720" rIns="45720" tIns="27432" bIns="27432">
-            <a:spAutoFit/>
-          </a:bodyPr>
-          <a:lstStyle/>
-          <a:p>
-            <a:pPr algn="r">
-              <a:spcAft>
-                <a:spcPts val="200"/>
-              </a:spcAft>
-              <a:defRPr sz="1400" b="1">
-                <a:solidFill>
-                  <a:srgbClr val="10B981"/>
-                </a:solidFill>
-              </a:defRPr>
-            </a:pPr>
-            <a:r>
-              <a:t>14 pages</a:t>
-            </a:r>
-          </a:p>
-        </p:txBody>
-      </p:sp>
-      <p:sp>
-        <p:nvSpPr>
-          <p:cNvPr id="12" name="Rounded Rectangle 11"/>
-          <p:cNvSpPr/>
-          <p:nvPr/>
-        </p:nvSpPr>
-        <p:spPr>
-          <a:xfrm>
-            <a:off x="822960" y="3840480"/>
-            <a:ext cx="10607040" cy="1097280"/>
-          </a:xfrm>
-          <a:prstGeom prst="roundRect">
-            <a:avLst/>
-          </a:prstGeom>
-          <a:solidFill>
-            <a:srgbClr val="EFF6FF"/>
-          </a:solidFill>
-          <a:ln>
-            <a:noFill/>
-          </a:ln>
-          <a:effectLst/>
-        </p:spPr>
-        <p:style>
-          <a:lnRef idx="1">
-            <a:schemeClr val="accent1"/>
-          </a:lnRef>
-          <a:fillRef idx="3">
-            <a:schemeClr val="accent1"/>
-          </a:fillRef>
-          <a:effectRef idx="2">
-            <a:schemeClr val="accent1"/>
-          </a:effectRef>
-          <a:fontRef idx="minor">
-            <a:schemeClr val="lt1"/>
-          </a:fontRef>
-        </p:style>
-        <p:txBody>
-          <a:bodyPr rtlCol="0" anchor="ctr"/>
-          <a:lstStyle/>
-          <a:p>
-            <a:pPr algn="ctr"/>
-          </a:p>
-        </p:txBody>
-      </p:sp>
-      <p:sp>
-        <p:nvSpPr>
-          <p:cNvPr id="13" name="TextBox 12"/>
-          <p:cNvSpPr txBox="1"/>
-          <p:nvPr/>
-        </p:nvSpPr>
-        <p:spPr>
-          <a:xfrm>
-            <a:off x="1097280" y="3931920"/>
-            <a:ext cx="2926080" cy="457200"/>
-          </a:xfrm>
-          <a:prstGeom prst="rect">
-            <a:avLst/>
-          </a:prstGeom>
-          <a:noFill/>
-        </p:spPr>
-        <p:txBody>
-          <a:bodyPr wrap="square" lIns="45720" rIns="45720" tIns="27432" bIns="27432">
-            <a:spAutoFit/>
-          </a:bodyPr>
-          <a:lstStyle/>
-          <a:p>
-            <a:pPr algn="l">
-              <a:spcAft>
-                <a:spcPts val="200"/>
-              </a:spcAft>
-              <a:defRPr sz="2000" b="1">
-                <a:solidFill>
-                  <a:srgbClr val="1E40AF"/>
-                </a:solidFill>
-              </a:defRPr>
-            </a:pPr>
-            <a:r>
-              <a:t>Base de données</a:t>
-            </a:r>
-          </a:p>
-        </p:txBody>
-      </p:sp>
-      <p:sp>
-        <p:nvSpPr>
-          <p:cNvPr id="14" name="TextBox 13"/>
-          <p:cNvSpPr txBox="1"/>
-          <p:nvPr/>
-        </p:nvSpPr>
-        <p:spPr>
-          <a:xfrm>
-            <a:off x="1097280" y="4343400"/>
-            <a:ext cx="7498079" cy="640080"/>
-          </a:xfrm>
-          <a:prstGeom prst="rect">
-            <a:avLst/>
-          </a:prstGeom>
-          <a:noFill/>
-        </p:spPr>
-        <p:txBody>
-          <a:bodyPr wrap="square" lIns="45720" rIns="45720" tIns="27432" bIns="27432">
-            <a:spAutoFit/>
-          </a:bodyPr>
-          <a:lstStyle/>
-          <a:p>
-            <a:pPr algn="l">
-              <a:spcAft>
-                <a:spcPts val="200"/>
-              </a:spcAft>
-              <a:defRPr sz="1600" b="0">
-                <a:solidFill>
-                  <a:srgbClr val="111827"/>
-                </a:solidFill>
-              </a:defRPr>
-            </a:pPr>
-            <a:r>
-              <a:t>PostgreSQL + driver pg8000 : relationnel, JSONB, intégrité</a:t>
-            </a:r>
-          </a:p>
-        </p:txBody>
-      </p:sp>
-      <p:sp>
-        <p:nvSpPr>
-          <p:cNvPr id="15" name="TextBox 14"/>
-          <p:cNvSpPr txBox="1"/>
-          <p:nvPr/>
-        </p:nvSpPr>
-        <p:spPr>
-          <a:xfrm>
-            <a:off x="8778240" y="4297680"/>
-            <a:ext cx="2377440" cy="457200"/>
-          </a:xfrm>
-          <a:prstGeom prst="rect">
-            <a:avLst/>
-          </a:prstGeom>
-          <a:noFill/>
-        </p:spPr>
-        <p:txBody>
-          <a:bodyPr wrap="square" lIns="45720" rIns="45720" tIns="27432" bIns="27432">
-            <a:spAutoFit/>
-          </a:bodyPr>
-          <a:lstStyle/>
-          <a:p>
-            <a:pPr algn="r">
-              <a:spcAft>
-                <a:spcPts val="200"/>
-              </a:spcAft>
-              <a:defRPr sz="1400" b="1">
-                <a:solidFill>
-                  <a:srgbClr val="10B981"/>
-                </a:solidFill>
-              </a:defRPr>
-            </a:pPr>
-            <a:r>
-              <a:t>14 tables, 16 migrations</a:t>
-            </a:r>
-          </a:p>
-        </p:txBody>
-      </p:sp>
-      <p:sp>
-        <p:nvSpPr>
-          <p:cNvPr id="16" name="Rounded Rectangle 15"/>
-          <p:cNvSpPr/>
-          <p:nvPr/>
-        </p:nvSpPr>
-        <p:spPr>
-          <a:xfrm>
-            <a:off x="822960" y="5074920"/>
-            <a:ext cx="10607040" cy="1097280"/>
-          </a:xfrm>
-          <a:prstGeom prst="roundRect">
-            <a:avLst/>
-          </a:prstGeom>
-          <a:solidFill>
-            <a:srgbClr val="EFF6FF"/>
-          </a:solidFill>
-          <a:ln>
-            <a:noFill/>
-          </a:ln>
-          <a:effectLst/>
-        </p:spPr>
-        <p:style>
-          <a:lnRef idx="1">
-            <a:schemeClr val="accent1"/>
-          </a:lnRef>
-          <a:fillRef idx="3">
-            <a:schemeClr val="accent1"/>
-          </a:fillRef>
-          <a:effectRef idx="2">
-            <a:schemeClr val="accent1"/>
-          </a:effectRef>
-          <a:fontRef idx="minor">
-            <a:schemeClr val="lt1"/>
-          </a:fontRef>
-        </p:style>
-        <p:txBody>
-          <a:bodyPr rtlCol="0" anchor="ctr"/>
-          <a:lstStyle/>
-          <a:p>
-            <a:pPr algn="ctr"/>
-          </a:p>
-        </p:txBody>
-      </p:sp>
-      <p:sp>
-        <p:nvSpPr>
-          <p:cNvPr id="17" name="TextBox 16"/>
-          <p:cNvSpPr txBox="1"/>
-          <p:nvPr/>
-        </p:nvSpPr>
-        <p:spPr>
-          <a:xfrm>
-            <a:off x="1097280" y="5166360"/>
-            <a:ext cx="2926080" cy="457200"/>
-          </a:xfrm>
-          <a:prstGeom prst="rect">
-            <a:avLst/>
-          </a:prstGeom>
-          <a:noFill/>
-        </p:spPr>
-        <p:txBody>
-          <a:bodyPr wrap="square" lIns="45720" rIns="45720" tIns="27432" bIns="27432">
-            <a:spAutoFit/>
-          </a:bodyPr>
-          <a:lstStyle/>
-          <a:p>
-            <a:pPr algn="l">
-              <a:spcAft>
-                <a:spcPts val="200"/>
-              </a:spcAft>
-              <a:defRPr sz="2000" b="1">
-                <a:solidFill>
-                  <a:srgbClr val="1E40AF"/>
-                </a:solidFill>
-              </a:defRPr>
-            </a:pPr>
-            <a:r>
-              <a:t>Sécurité</a:t>
-            </a:r>
-          </a:p>
-        </p:txBody>
-      </p:sp>
-      <p:sp>
-        <p:nvSpPr>
-          <p:cNvPr id="18" name="TextBox 17"/>
-          <p:cNvSpPr txBox="1"/>
-          <p:nvPr/>
-        </p:nvSpPr>
-        <p:spPr>
-          <a:xfrm>
-            <a:off x="1097280" y="5577840"/>
-            <a:ext cx="7498079" cy="640080"/>
-          </a:xfrm>
-          <a:prstGeom prst="rect">
-            <a:avLst/>
-          </a:prstGeom>
-          <a:noFill/>
-        </p:spPr>
-        <p:txBody>
-          <a:bodyPr wrap="square" lIns="45720" rIns="45720" tIns="27432" bIns="27432">
-            <a:spAutoFit/>
-          </a:bodyPr>
-          <a:lstStyle/>
-          <a:p>
-            <a:pPr algn="l">
-              <a:spcAft>
-                <a:spcPts val="200"/>
-              </a:spcAft>
-              <a:defRPr sz="1600" b="0">
-                <a:solidFill>
-                  <a:srgbClr val="111827"/>
-                </a:solidFill>
-              </a:defRPr>
-            </a:pPr>
-            <a:r>
-              <a:t>OTP email, JWT, clé API admin, garde anti-IDOR, sanitisation des erreurs</a:t>
-            </a:r>
-          </a:p>
-        </p:txBody>
-      </p:sp>
-      <p:sp>
-        <p:nvSpPr>
-          <p:cNvPr id="19" name="TextBox 18"/>
-          <p:cNvSpPr txBox="1"/>
-          <p:nvPr/>
-        </p:nvSpPr>
-        <p:spPr>
-          <a:xfrm>
-            <a:off x="8778240" y="5532120"/>
-            <a:ext cx="2377440" cy="457200"/>
-          </a:xfrm>
-          <a:prstGeom prst="rect">
-            <a:avLst/>
-          </a:prstGeom>
-          <a:noFill/>
-        </p:spPr>
-        <p:txBody>
-          <a:bodyPr wrap="square" lIns="45720" rIns="45720" tIns="27432" bIns="27432">
-            <a:spAutoFit/>
-          </a:bodyPr>
-          <a:lstStyle/>
-          <a:p>
-            <a:pPr algn="r">
-              <a:spcAft>
-                <a:spcPts val="200"/>
-              </a:spcAft>
-              <a:defRPr sz="1400" b="1">
-                <a:solidFill>
-                  <a:srgbClr val="10B981"/>
-                </a:solidFill>
-              </a:defRPr>
-            </a:pPr>
-            <a:r>
-              <a:t>Conforme RGPD</a:t>
-            </a:r>
-          </a:p>
-        </p:txBody>
-      </p:sp>
-      <p:sp>
-        <p:nvSpPr>
-          <p:cNvPr id="20" name="TextBox 19"/>
           <p:cNvSpPr txBox="1"/>
           <p:nvPr/>
         </p:nvSpPr>
@@ -7818,7 +6520,19 @@
               </a:defRPr>
             </a:pPr>
             <a:r>
-              <a:t>Modèle de données (MCD/MLD)</a:t>
+              <a:t>Démonstration — Espace Administration</a:t>
+            </a:r>
+          </a:p>
+          <a:p>
+            <a:pPr>
+              <a:defRPr sz="1400">
+                <a:solidFill>
+                  <a:srgbClr val="EFF6FF"/>
+                </a:solidFill>
+              </a:defRPr>
+            </a:pPr>
+            <a:r>
+              <a:t>Tableau de bord, annuaire, RGPD</a:t>
             </a:r>
           </a:p>
         </p:txBody>
@@ -7866,339 +6580,33 @@
           </a:p>
         </p:txBody>
       </p:sp>
-      <p:sp>
-        <p:nvSpPr>
-          <p:cNvPr id="4" name="TextBox 3"/>
-          <p:cNvSpPr txBox="1"/>
-          <p:nvPr/>
-        </p:nvSpPr>
-        <p:spPr>
-          <a:xfrm>
-            <a:off x="822960" y="1371600"/>
-            <a:ext cx="5303520" cy="4754880"/>
+      <p:pic>
+        <p:nvPicPr>
+          <p:cNvPr id="4" name="Picture 3" descr="anB_dashboard_light.png"/>
+          <p:cNvPicPr>
+            <a:picLocks noChangeAspect="1"/>
+          </p:cNvPicPr>
+          <p:nvPr/>
+        </p:nvPicPr>
+        <p:blipFill>
+          <a:blip r:embed="rId2"/>
+          <a:stretch>
+            <a:fillRect/>
+          </a:stretch>
+        </p:blipFill>
+        <p:spPr>
+          <a:xfrm>
+            <a:off x="822960" y="1280160"/>
+            <a:ext cx="10607040" cy="6629400"/>
           </a:xfrm>
           <a:prstGeom prst="rect">
             <a:avLst/>
           </a:prstGeom>
-          <a:noFill/>
-        </p:spPr>
-        <p:txBody>
-          <a:bodyPr wrap="square" lIns="45720" tIns="27432">
-            <a:spAutoFit/>
-          </a:bodyPr>
-          <a:lstStyle/>
-          <a:p>
-            <a:pPr>
-              <a:spcAft>
-                <a:spcPts val="800"/>
-              </a:spcAft>
-              <a:defRPr sz="1700">
-                <a:solidFill>
-                  <a:srgbClr val="111827"/>
-                </a:solidFill>
-              </a:defRPr>
-            </a:pPr>
-            <a:r>
-              <a:t>• 5 domaines, 14 tables.</a:t>
-            </a:r>
-          </a:p>
-          <a:p>
-            <a:pPr>
-              <a:spcAft>
-                <a:spcPts val="800"/>
-              </a:spcAft>
-              <a:defRPr sz="1700">
-                <a:solidFill>
-                  <a:srgbClr val="111827"/>
-                </a:solidFill>
-              </a:defRPr>
-            </a:pPr>
-            <a:r>
-              <a:t>• Données étudiantes : ETUDIANT, PROMOTION (N:1).</a:t>
-            </a:r>
-          </a:p>
-          <a:p>
-            <a:pPr>
-              <a:spcAft>
-                <a:spcPts val="800"/>
-              </a:spcAft>
-              <a:defRPr sz="1700">
-                <a:solidFill>
-                  <a:srgbClr val="111827"/>
-                </a:solidFill>
-              </a:defRPr>
-            </a:pPr>
-            <a:r>
-              <a:t>• Parcours pro : ENTREPRISE, EXPERIENCE_PRO, CERTIFICATION, OBTIENT (N:M).</a:t>
-            </a:r>
-          </a:p>
-          <a:p>
-            <a:pPr>
-              <a:spcAft>
-                <a:spcPts val="800"/>
-              </a:spcAft>
-              <a:defRPr sz="1700">
-                <a:solidFill>
-                  <a:srgbClr val="111827"/>
-                </a:solidFill>
-              </a:defRPr>
-            </a:pPr>
-            <a:r>
-              <a:t>• RGPD : CONSENTEMENT_RGPD, DEMANDE_RGPD, AUDIT_LOG.</a:t>
-            </a:r>
-          </a:p>
-          <a:p>
-            <a:pPr>
-              <a:spcAft>
-                <a:spcPts val="800"/>
-              </a:spcAft>
-              <a:defRPr sz="1700">
-                <a:solidFill>
-                  <a:srgbClr val="111827"/>
-                </a:solidFill>
-              </a:defRPr>
-            </a:pPr>
-            <a:r>
-              <a:t>• Questionnaires : QUESTIONNAIRE, QUESTION, REPONSE_QUESTIONNAIRE (JSON).</a:t>
-            </a:r>
-          </a:p>
-          <a:p>
-            <a:pPr>
-              <a:spcAft>
-                <a:spcPts val="800"/>
-              </a:spcAft>
-              <a:defRPr sz="1700">
-                <a:solidFill>
-                  <a:srgbClr val="111827"/>
-                </a:solidFill>
-              </a:defRPr>
-            </a:pPr>
-            <a:r>
-              <a:t>• Infrastructure : otp_codes, schema_migrations.</a:t>
-            </a:r>
-          </a:p>
-          <a:p>
-            <a:pPr>
-              <a:spcAft>
-                <a:spcPts val="800"/>
-              </a:spcAft>
-              <a:defRPr sz="1700">
-                <a:solidFill>
-                  <a:srgbClr val="111827"/>
-                </a:solidFill>
-              </a:defRPr>
-            </a:pPr>
-            <a:r>
-              <a:t>• Règles de cascade et contraintes d'unicité garantissant la cohérence.</a:t>
-            </a:r>
-          </a:p>
-        </p:txBody>
-      </p:sp>
+        </p:spPr>
+      </p:pic>
       <p:sp>
         <p:nvSpPr>
           <p:cNvPr id="5" name="TextBox 4"/>
-          <p:cNvSpPr txBox="1"/>
-          <p:nvPr/>
-        </p:nvSpPr>
-        <p:spPr>
-          <a:xfrm>
-            <a:off x="6400800" y="1371600"/>
-            <a:ext cx="4754880" cy="365760"/>
-          </a:xfrm>
-          <a:prstGeom prst="rect">
-            <a:avLst/>
-          </a:prstGeom>
-          <a:noFill/>
-        </p:spPr>
-        <p:txBody>
-          <a:bodyPr wrap="square" lIns="45720" rIns="45720" tIns="27432" bIns="27432">
-            <a:spAutoFit/>
-          </a:bodyPr>
-          <a:lstStyle/>
-          <a:p>
-            <a:pPr algn="l">
-              <a:spcAft>
-                <a:spcPts val="200"/>
-              </a:spcAft>
-              <a:defRPr sz="1600" b="1">
-                <a:solidFill>
-                  <a:srgbClr val="1E40AF"/>
-                </a:solidFill>
-              </a:defRPr>
-            </a:pPr>
-            <a:r>
-              <a:t>Cartographie simplifiée des entités</a:t>
-            </a:r>
-          </a:p>
-        </p:txBody>
-      </p:sp>
-      <p:sp>
-        <p:nvSpPr>
-          <p:cNvPr id="6" name="Rounded Rectangle 5"/>
-          <p:cNvSpPr/>
-          <p:nvPr/>
-        </p:nvSpPr>
-        <p:spPr>
-          <a:xfrm>
-            <a:off x="6400800" y="1828800"/>
-            <a:ext cx="2377440" cy="4480560"/>
-          </a:xfrm>
-          <a:prstGeom prst="roundRect">
-            <a:avLst/>
-          </a:prstGeom>
-          <a:solidFill>
-            <a:srgbClr val="EFF6FF"/>
-          </a:solidFill>
-          <a:ln>
-            <a:noFill/>
-          </a:ln>
-          <a:effectLst/>
-        </p:spPr>
-        <p:style>
-          <a:lnRef idx="1">
-            <a:schemeClr val="accent1"/>
-          </a:lnRef>
-          <a:fillRef idx="3">
-            <a:schemeClr val="accent1"/>
-          </a:fillRef>
-          <a:effectRef idx="2">
-            <a:schemeClr val="accent1"/>
-          </a:effectRef>
-          <a:fontRef idx="minor">
-            <a:schemeClr val="lt1"/>
-          </a:fontRef>
-        </p:style>
-        <p:txBody>
-          <a:bodyPr rtlCol="0" anchor="ctr"/>
-          <a:lstStyle/>
-          <a:p>
-            <a:pPr algn="ctr"/>
-          </a:p>
-        </p:txBody>
-      </p:sp>
-      <p:sp>
-        <p:nvSpPr>
-          <p:cNvPr id="7" name="Rounded Rectangle 6"/>
-          <p:cNvSpPr/>
-          <p:nvPr/>
-        </p:nvSpPr>
-        <p:spPr>
-          <a:xfrm>
-            <a:off x="8961120" y="1828800"/>
-            <a:ext cx="2377440" cy="4480560"/>
-          </a:xfrm>
-          <a:prstGeom prst="roundRect">
-            <a:avLst/>
-          </a:prstGeom>
-          <a:solidFill>
-            <a:srgbClr val="EFF6FF"/>
-          </a:solidFill>
-          <a:ln>
-            <a:noFill/>
-          </a:ln>
-          <a:effectLst/>
-        </p:spPr>
-        <p:style>
-          <a:lnRef idx="1">
-            <a:schemeClr val="accent1"/>
-          </a:lnRef>
-          <a:fillRef idx="3">
-            <a:schemeClr val="accent1"/>
-          </a:fillRef>
-          <a:effectRef idx="2">
-            <a:schemeClr val="accent1"/>
-          </a:effectRef>
-          <a:fontRef idx="minor">
-            <a:schemeClr val="lt1"/>
-          </a:fontRef>
-        </p:style>
-        <p:txBody>
-          <a:bodyPr rtlCol="0" anchor="ctr"/>
-          <a:lstStyle/>
-          <a:p>
-            <a:pPr algn="ctr"/>
-          </a:p>
-        </p:txBody>
-      </p:sp>
-      <p:sp>
-        <p:nvSpPr>
-          <p:cNvPr id="8" name="TextBox 7"/>
-          <p:cNvSpPr txBox="1"/>
-          <p:nvPr/>
-        </p:nvSpPr>
-        <p:spPr>
-          <a:xfrm>
-            <a:off x="6583680" y="1920240"/>
-            <a:ext cx="2011680" cy="365760"/>
-          </a:xfrm>
-          <a:prstGeom prst="rect">
-            <a:avLst/>
-          </a:prstGeom>
-          <a:noFill/>
-        </p:spPr>
-        <p:txBody>
-          <a:bodyPr wrap="square" lIns="45720" rIns="45720" tIns="27432" bIns="27432">
-            <a:spAutoFit/>
-          </a:bodyPr>
-          <a:lstStyle/>
-          <a:p>
-            <a:pPr algn="l">
-              <a:spcAft>
-                <a:spcPts val="200"/>
-              </a:spcAft>
-              <a:defRPr sz="1400" b="1">
-                <a:solidFill>
-                  <a:srgbClr val="111827"/>
-                </a:solidFill>
-              </a:defRPr>
-            </a:pPr>
-            <a:r>
-              <a:t>Toutes les données</a:t>
-            </a:r>
-          </a:p>
-        </p:txBody>
-      </p:sp>
-      <p:sp>
-        <p:nvSpPr>
-          <p:cNvPr id="9" name="TextBox 8"/>
-          <p:cNvSpPr txBox="1"/>
-          <p:nvPr/>
-        </p:nvSpPr>
-        <p:spPr>
-          <a:xfrm>
-            <a:off x="9144000" y="1920240"/>
-            <a:ext cx="2011680" cy="365760"/>
-          </a:xfrm>
-          <a:prstGeom prst="rect">
-            <a:avLst/>
-          </a:prstGeom>
-          <a:noFill/>
-        </p:spPr>
-        <p:txBody>
-          <a:bodyPr wrap="square" lIns="45720" rIns="45720" tIns="27432" bIns="27432">
-            <a:spAutoFit/>
-          </a:bodyPr>
-          <a:lstStyle/>
-          <a:p>
-            <a:pPr algn="l">
-              <a:spcAft>
-                <a:spcPts val="200"/>
-              </a:spcAft>
-              <a:defRPr sz="1400" b="1">
-                <a:solidFill>
-                  <a:srgbClr val="111827"/>
-                </a:solidFill>
-              </a:defRPr>
-            </a:pPr>
-            <a:r>
-              <a:t>RGPD &amp; pilotage</a:t>
-            </a:r>
-          </a:p>
-        </p:txBody>
-      </p:sp>
-      <p:sp>
-        <p:nvSpPr>
-          <p:cNvPr id="10" name="TextBox 9"/>
           <p:cNvSpPr txBox="1"/>
           <p:nvPr/>
         </p:nvSpPr>
@@ -8304,7 +6712,19 @@
               </a:defRPr>
             </a:pPr>
             <a:r>
-              <a:t>Architecture 3-tiers</a:t>
+              <a:t>Démonstration — Espace Alumni</a:t>
+            </a:r>
+          </a:p>
+          <a:p>
+            <a:pPr>
+              <a:defRPr sz="1400">
+                <a:solidFill>
+                  <a:srgbClr val="EFF6FF"/>
+                </a:solidFill>
+              </a:defRPr>
+            </a:pPr>
+            <a:r>
+              <a:t>Profil, parcours, consentement, questionnaire</a:t>
             </a:r>
           </a:p>
         </p:txBody>
@@ -8352,344 +6772,33 @@
           </a:p>
         </p:txBody>
       </p:sp>
-      <p:sp>
-        <p:nvSpPr>
-          <p:cNvPr id="4" name="Rounded Rectangle 3"/>
-          <p:cNvSpPr/>
-          <p:nvPr/>
-        </p:nvSpPr>
-        <p:spPr>
-          <a:xfrm>
-            <a:off x="822960" y="1554480"/>
-            <a:ext cx="3291840" cy="4023360"/>
-          </a:xfrm>
-          <a:prstGeom prst="roundRect">
-            <a:avLst/>
-          </a:prstGeom>
-          <a:solidFill>
-            <a:srgbClr val="1E40AF"/>
-          </a:solidFill>
-          <a:ln>
-            <a:noFill/>
-          </a:ln>
-          <a:effectLst/>
-        </p:spPr>
-        <p:style>
-          <a:lnRef idx="1">
-            <a:schemeClr val="accent1"/>
-          </a:lnRef>
-          <a:fillRef idx="3">
-            <a:schemeClr val="accent1"/>
-          </a:fillRef>
-          <a:effectRef idx="2">
-            <a:schemeClr val="accent1"/>
-          </a:effectRef>
-          <a:fontRef idx="minor">
-            <a:schemeClr val="lt1"/>
-          </a:fontRef>
-        </p:style>
-        <p:txBody>
-          <a:bodyPr rtlCol="0" anchor="ctr" wrap="square"/>
-          <a:lstStyle/>
-          <a:p>
-            <a:pPr algn="ctr">
-              <a:defRPr sz="2000" b="1">
-                <a:solidFill>
-                  <a:srgbClr val="FFFFFF"/>
-                </a:solidFill>
-              </a:defRPr>
-            </a:pPr>
-            <a:r>
-              <a:t>FRONTEND</a:t>
-            </a:r>
-          </a:p>
-          <a:p>
-            <a:pPr>
-              <a:defRPr sz="1500">
-                <a:solidFill>
-                  <a:srgbClr val="FFFFFF"/>
-                </a:solidFill>
-              </a:defRPr>
-            </a:pPr>
-            <a:r>
-              <a:t>React + Vite (SPA)</a:t>
-            </a:r>
-            <a:br/>
-            <a:r>
-              <a:t>Espace Admin / Espace Alumni</a:t>
-            </a:r>
-            <a:br/>
-            <a:r>
-              <a:t>proxy /api → port 8000</a:t>
-            </a:r>
-          </a:p>
-        </p:txBody>
-      </p:sp>
-      <p:sp>
-        <p:nvSpPr>
-          <p:cNvPr id="5" name="Right Arrow 4"/>
-          <p:cNvSpPr/>
-          <p:nvPr/>
-        </p:nvSpPr>
-        <p:spPr>
-          <a:xfrm>
-            <a:off x="4069080" y="3383280"/>
-            <a:ext cx="256032" cy="365760"/>
-          </a:xfrm>
-          <a:prstGeom prst="rightArrow">
-            <a:avLst/>
-          </a:prstGeom>
-          <a:solidFill>
-            <a:srgbClr val="6B7280"/>
-          </a:solidFill>
-          <a:ln>
-            <a:noFill/>
-          </a:ln>
-        </p:spPr>
-        <p:style>
-          <a:lnRef idx="1">
-            <a:schemeClr val="accent1"/>
-          </a:lnRef>
-          <a:fillRef idx="3">
-            <a:schemeClr val="accent1"/>
-          </a:fillRef>
-          <a:effectRef idx="2">
-            <a:schemeClr val="accent1"/>
-          </a:effectRef>
-          <a:fontRef idx="minor">
-            <a:schemeClr val="lt1"/>
-          </a:fontRef>
-        </p:style>
-        <p:txBody>
-          <a:bodyPr rtlCol="0" anchor="ctr"/>
-          <a:lstStyle/>
-          <a:p>
-            <a:pPr algn="ctr"/>
-          </a:p>
-        </p:txBody>
-      </p:sp>
-      <p:sp>
-        <p:nvSpPr>
-          <p:cNvPr id="6" name="Rounded Rectangle 5"/>
-          <p:cNvSpPr/>
-          <p:nvPr/>
-        </p:nvSpPr>
-        <p:spPr>
-          <a:xfrm>
-            <a:off x="4434840" y="1554480"/>
-            <a:ext cx="3291840" cy="4023360"/>
-          </a:xfrm>
-          <a:prstGeom prst="roundRect">
-            <a:avLst/>
-          </a:prstGeom>
-          <a:solidFill>
-            <a:srgbClr val="10B981"/>
-          </a:solidFill>
-          <a:ln>
-            <a:noFill/>
-          </a:ln>
-          <a:effectLst/>
-        </p:spPr>
-        <p:style>
-          <a:lnRef idx="1">
-            <a:schemeClr val="accent1"/>
-          </a:lnRef>
-          <a:fillRef idx="3">
-            <a:schemeClr val="accent1"/>
-          </a:fillRef>
-          <a:effectRef idx="2">
-            <a:schemeClr val="accent1"/>
-          </a:effectRef>
-          <a:fontRef idx="minor">
-            <a:schemeClr val="lt1"/>
-          </a:fontRef>
-        </p:style>
-        <p:txBody>
-          <a:bodyPr rtlCol="0" anchor="ctr" wrap="square"/>
-          <a:lstStyle/>
-          <a:p>
-            <a:pPr algn="ctr">
-              <a:defRPr sz="2000" b="1">
-                <a:solidFill>
-                  <a:srgbClr val="FFFFFF"/>
-                </a:solidFill>
-              </a:defRPr>
-            </a:pPr>
-            <a:r>
-              <a:t>BACKEND</a:t>
-            </a:r>
-          </a:p>
-          <a:p>
-            <a:pPr>
-              <a:defRPr sz="1500">
-                <a:solidFill>
-                  <a:srgbClr val="FFFFFF"/>
-                </a:solidFill>
-              </a:defRPr>
-            </a:pPr>
-            <a:r>
-              <a:t>FastAPI — 82 endpoints, 16 routeurs</a:t>
-            </a:r>
-            <a:br/>
-            <a:r>
-              <a:t>auth OTP + JWT, clé API, RGPD</a:t>
-            </a:r>
-          </a:p>
-        </p:txBody>
-      </p:sp>
-      <p:sp>
-        <p:nvSpPr>
-          <p:cNvPr id="7" name="Right Arrow 6"/>
-          <p:cNvSpPr/>
-          <p:nvPr/>
-        </p:nvSpPr>
-        <p:spPr>
-          <a:xfrm>
-            <a:off x="7680960" y="3383280"/>
-            <a:ext cx="256032" cy="365760"/>
-          </a:xfrm>
-          <a:prstGeom prst="rightArrow">
-            <a:avLst/>
-          </a:prstGeom>
-          <a:solidFill>
-            <a:srgbClr val="6B7280"/>
-          </a:solidFill>
-          <a:ln>
-            <a:noFill/>
-          </a:ln>
-        </p:spPr>
-        <p:style>
-          <a:lnRef idx="1">
-            <a:schemeClr val="accent1"/>
-          </a:lnRef>
-          <a:fillRef idx="3">
-            <a:schemeClr val="accent1"/>
-          </a:fillRef>
-          <a:effectRef idx="2">
-            <a:schemeClr val="accent1"/>
-          </a:effectRef>
-          <a:fontRef idx="minor">
-            <a:schemeClr val="lt1"/>
-          </a:fontRef>
-        </p:style>
-        <p:txBody>
-          <a:bodyPr rtlCol="0" anchor="ctr"/>
-          <a:lstStyle/>
-          <a:p>
-            <a:pPr algn="ctr"/>
-          </a:p>
-        </p:txBody>
-      </p:sp>
-      <p:sp>
-        <p:nvSpPr>
-          <p:cNvPr id="8" name="Rounded Rectangle 7"/>
-          <p:cNvSpPr/>
-          <p:nvPr/>
-        </p:nvSpPr>
-        <p:spPr>
-          <a:xfrm>
-            <a:off x="8046720" y="1554480"/>
-            <a:ext cx="3291840" cy="4023360"/>
-          </a:xfrm>
-          <a:prstGeom prst="roundRect">
-            <a:avLst/>
-          </a:prstGeom>
-          <a:solidFill>
-            <a:srgbClr val="111827"/>
-          </a:solidFill>
-          <a:ln>
-            <a:noFill/>
-          </a:ln>
-          <a:effectLst/>
-        </p:spPr>
-        <p:style>
-          <a:lnRef idx="1">
-            <a:schemeClr val="accent1"/>
-          </a:lnRef>
-          <a:fillRef idx="3">
-            <a:schemeClr val="accent1"/>
-          </a:fillRef>
-          <a:effectRef idx="2">
-            <a:schemeClr val="accent1"/>
-          </a:effectRef>
-          <a:fontRef idx="minor">
-            <a:schemeClr val="lt1"/>
-          </a:fontRef>
-        </p:style>
-        <p:txBody>
-          <a:bodyPr rtlCol="0" anchor="ctr" wrap="square"/>
-          <a:lstStyle/>
-          <a:p>
-            <a:pPr algn="ctr">
-              <a:defRPr sz="2000" b="1">
-                <a:solidFill>
-                  <a:srgbClr val="FFFFFF"/>
-                </a:solidFill>
-              </a:defRPr>
-            </a:pPr>
-            <a:r>
-              <a:t>BASE DE DONNÉES</a:t>
-            </a:r>
-          </a:p>
-          <a:p>
-            <a:pPr>
-              <a:defRPr sz="1500">
-                <a:solidFill>
-                  <a:srgbClr val="FFFFFF"/>
-                </a:solidFill>
-              </a:defRPr>
-            </a:pPr>
-            <a:r>
-              <a:t>PostgreSQL</a:t>
-            </a:r>
-            <a:br/>
-            <a:r>
-              <a:t>14 tables, 16 migrations, JSONB</a:t>
-            </a:r>
-          </a:p>
-        </p:txBody>
-      </p:sp>
-      <p:sp>
-        <p:nvSpPr>
-          <p:cNvPr id="9" name="TextBox 8"/>
-          <p:cNvSpPr txBox="1"/>
-          <p:nvPr/>
-        </p:nvSpPr>
-        <p:spPr>
-          <a:xfrm>
-            <a:off x="822960" y="5760720"/>
-            <a:ext cx="10607040" cy="548640"/>
+      <p:pic>
+        <p:nvPicPr>
+          <p:cNvPr id="4" name="Picture 3" descr="anC_parcours_light.png"/>
+          <p:cNvPicPr>
+            <a:picLocks noChangeAspect="1"/>
+          </p:cNvPicPr>
+          <p:nvPr/>
+        </p:nvPicPr>
+        <p:blipFill>
+          <a:blip r:embed="rId2"/>
+          <a:stretch>
+            <a:fillRect/>
+          </a:stretch>
+        </p:blipFill>
+        <p:spPr>
+          <a:xfrm>
+            <a:off x="822960" y="1280160"/>
+            <a:ext cx="10607040" cy="6629400"/>
           </a:xfrm>
           <a:prstGeom prst="rect">
             <a:avLst/>
           </a:prstGeom>
-          <a:noFill/>
-        </p:spPr>
-        <p:txBody>
-          <a:bodyPr wrap="square" lIns="45720" rIns="45720" tIns="27432" bIns="27432">
-            <a:spAutoFit/>
-          </a:bodyPr>
-          <a:lstStyle/>
-          <a:p>
-            <a:pPr algn="l">
-              <a:spcAft>
-                <a:spcPts val="200"/>
-              </a:spcAft>
-              <a:defRPr sz="1700" b="1">
-                <a:solidFill>
-                  <a:srgbClr val="1E40AF"/>
-                </a:solidFill>
-              </a:defRPr>
-            </a:pPr>
-            <a:r>
-              <a:t>Côté applicatif : authentification OTP (alumni) / clé API + hash (admin) ; sessions JWT.</a:t>
-            </a:r>
-          </a:p>
-        </p:txBody>
-      </p:sp>
-      <p:sp>
-        <p:nvSpPr>
-          <p:cNvPr id="10" name="TextBox 9"/>
+        </p:spPr>
+      </p:pic>
+      <p:sp>
+        <p:nvSpPr>
+          <p:cNvPr id="5" name="TextBox 4"/>
           <p:cNvSpPr txBox="1"/>
           <p:nvPr/>
         </p:nvSpPr>
@@ -8795,19 +6904,7 @@
               </a:defRPr>
             </a:pPr>
             <a:r>
-              <a:t>Démonstration — Espace Administration</a:t>
-            </a:r>
-          </a:p>
-          <a:p>
-            <a:pPr>
-              <a:defRPr sz="1400">
-                <a:solidFill>
-                  <a:srgbClr val="EFF6FF"/>
-                </a:solidFill>
-              </a:defRPr>
-            </a:pPr>
-            <a:r>
-              <a:t>Tableau de bord, annuaire, RGPD</a:t>
+              <a:t>Indicateurs d'insertion professionnelle</a:t>
             </a:r>
           </a:p>
         </p:txBody>
@@ -8855,9 +6952,122 @@
           </a:p>
         </p:txBody>
       </p:sp>
+      <p:sp>
+        <p:nvSpPr>
+          <p:cNvPr id="4" name="TextBox 3"/>
+          <p:cNvSpPr txBox="1"/>
+          <p:nvPr/>
+        </p:nvSpPr>
+        <p:spPr>
+          <a:xfrm>
+            <a:off x="822960" y="1371600"/>
+            <a:ext cx="5394960" cy="4937760"/>
+          </a:xfrm>
+          <a:prstGeom prst="rect">
+            <a:avLst/>
+          </a:prstGeom>
+          <a:noFill/>
+        </p:spPr>
+        <p:txBody>
+          <a:bodyPr wrap="square" lIns="45720" tIns="27432">
+            <a:spAutoFit/>
+          </a:bodyPr>
+          <a:lstStyle/>
+          <a:p>
+            <a:pPr>
+              <a:spcAft>
+                <a:spcPts val="800"/>
+              </a:spcAft>
+              <a:defRPr sz="1700">
+                <a:solidFill>
+                  <a:srgbClr val="111827"/>
+                </a:solidFill>
+              </a:defRPr>
+            </a:pPr>
+            <a:r>
+              <a:t>• 8 indicateurs reproductibles, formule et source explicites.</a:t>
+            </a:r>
+          </a:p>
+          <a:p>
+            <a:pPr>
+              <a:spcAft>
+                <a:spcPts val="800"/>
+              </a:spcAft>
+              <a:defRPr sz="1700">
+                <a:solidFill>
+                  <a:srgbClr val="111827"/>
+                </a:solidFill>
+              </a:defRPr>
+            </a:pPr>
+            <a:r>
+              <a:t>• Taux d'emploi à 6 mois (expériences actives).</a:t>
+            </a:r>
+          </a:p>
+          <a:p>
+            <a:pPr>
+              <a:spcAft>
+                <a:spcPts val="800"/>
+              </a:spcAft>
+              <a:defRPr sz="1700">
+                <a:solidFill>
+                  <a:srgbClr val="111827"/>
+                </a:solidFill>
+              </a:defRPr>
+            </a:pPr>
+            <a:r>
+              <a:t>• Adéquation formation/emploi via les tags KPI.</a:t>
+            </a:r>
+          </a:p>
+          <a:p>
+            <a:pPr>
+              <a:spcAft>
+                <a:spcPts val="800"/>
+              </a:spcAft>
+              <a:defRPr sz="1700">
+                <a:solidFill>
+                  <a:srgbClr val="111827"/>
+                </a:solidFill>
+              </a:defRPr>
+            </a:pPr>
+            <a:r>
+              <a:t>• Salaire moyen / min / max (champ annuel).</a:t>
+            </a:r>
+          </a:p>
+          <a:p>
+            <a:pPr>
+              <a:spcAft>
+                <a:spcPts val="800"/>
+              </a:spcAft>
+              <a:defRPr sz="1700">
+                <a:solidFill>
+                  <a:srgbClr val="111827"/>
+                </a:solidFill>
+              </a:defRPr>
+            </a:pPr>
+            <a:r>
+              <a:t>• Répartition par promotion et secteur, taux de complétion.</a:t>
+            </a:r>
+          </a:p>
+          <a:p>
+            <a:pPr>
+              <a:spcAft>
+                <a:spcPts val="800"/>
+              </a:spcAft>
+              <a:defRPr sz="1700">
+                <a:solidFill>
+                  <a:srgbClr val="111827"/>
+                </a:solidFill>
+              </a:defRPr>
+            </a:pPr>
+            <a:r>
+              <a:t>• Pas de chiffre trompeur : cohortes immatures → « non disponible ».</a:t>
+            </a:r>
+          </a:p>
+        </p:txBody>
+      </p:sp>
       <p:pic>
         <p:nvPicPr>
-          <p:cNvPr id="4" name="Picture 3" descr="anB_dashboard_light.png"/>
+          <p:cNvPr id="5" name="Picture 4" descr="anB_dashboard_light.png"/>
           <p:cNvPicPr>
             <a:picLocks noChangeAspect="1"/>
           </p:cNvPicPr>
@@ -8871,8 +7081,8 @@
         </p:blipFill>
         <p:spPr>
           <a:xfrm>
-            <a:off x="822960" y="1280160"/>
-            <a:ext cx="10607040" cy="6629400"/>
+            <a:off x="6400800" y="1737360"/>
+            <a:ext cx="5120640" cy="3200400"/>
           </a:xfrm>
           <a:prstGeom prst="rect">
             <a:avLst/>
@@ -8881,7 +7091,7 @@
       </p:pic>
       <p:sp>
         <p:nvSpPr>
-          <p:cNvPr id="5" name="TextBox 4"/>
+          <p:cNvPr id="6" name="TextBox 5"/>
           <p:cNvSpPr txBox="1"/>
           <p:nvPr/>
         </p:nvSpPr>

</xml_diff>

<commit_message>
fix(soutenance): fix overflowing slides (goals, demo screenshots, RGPD); no shape exceeds slide bounds
</commit_message>
<xml_diff>
--- a/Rapport/Soutenance - Alumni CRM - PreMSc 2026.pptx
+++ b/Rapport/Soutenance - Alumni CRM - PreMSc 2026.pptx
@@ -4749,8 +4749,8 @@
         </p:nvSpPr>
         <p:spPr>
           <a:xfrm>
-            <a:off x="822960" y="1234440"/>
-            <a:ext cx="10607040" cy="1554480"/>
+            <a:off x="822960" y="1143000"/>
+            <a:ext cx="10607040" cy="1280160"/>
           </a:xfrm>
           <a:prstGeom prst="rect">
             <a:avLst/>
@@ -4765,9 +4765,9 @@
           <a:p>
             <a:pPr>
               <a:spcAft>
-                <a:spcPts val="800"/>
+                <a:spcPts val="600"/>
               </a:spcAft>
-              <a:defRPr sz="1700">
+              <a:defRPr sz="1500">
                 <a:solidFill>
                   <a:srgbClr val="111827"/>
                 </a:solidFill>
@@ -4780,9 +4780,9 @@
           <a:p>
             <a:pPr>
               <a:spcAft>
-                <a:spcPts val="800"/>
+                <a:spcPts val="600"/>
               </a:spcAft>
-              <a:defRPr sz="1700">
+              <a:defRPr sz="1500">
                 <a:solidFill>
                   <a:srgbClr val="111827"/>
                 </a:solidFill>
@@ -4802,8 +4802,8 @@
         </p:nvSpPr>
         <p:spPr>
           <a:xfrm>
-            <a:off x="822960" y="2743200"/>
-            <a:ext cx="10607040" cy="822960"/>
+            <a:off x="822960" y="2560320"/>
+            <a:ext cx="10607040" cy="731520"/>
           </a:xfrm>
           <a:prstGeom prst="roundRect">
             <a:avLst/>
@@ -4846,8 +4846,8 @@
         </p:nvSpPr>
         <p:spPr>
           <a:xfrm>
-            <a:off x="1097280" y="2852928"/>
-            <a:ext cx="10058400" cy="640080"/>
+            <a:off x="1097280" y="2633472"/>
+            <a:ext cx="10058400" cy="594360"/>
           </a:xfrm>
           <a:prstGeom prst="rect">
             <a:avLst/>
@@ -4864,7 +4864,7 @@
               <a:spcAft>
                 <a:spcPts val="200"/>
               </a:spcAft>
-              <a:defRPr sz="1600" b="1">
+              <a:defRPr sz="1500" b="1">
                 <a:solidFill>
                   <a:srgbClr val="1E40AF"/>
                 </a:solidFill>
@@ -4884,8 +4884,8 @@
         </p:nvSpPr>
         <p:spPr>
           <a:xfrm>
-            <a:off x="822960" y="3657600"/>
-            <a:ext cx="914400" cy="777240"/>
+            <a:off x="822960" y="3429000"/>
+            <a:ext cx="822960" cy="548640"/>
           </a:xfrm>
           <a:prstGeom prst="roundRect">
             <a:avLst/>
@@ -4917,7 +4917,7 @@
           <a:lstStyle/>
           <a:p>
             <a:pPr algn="ctr">
-              <a:defRPr sz="2000" b="1">
+              <a:defRPr sz="1700" b="1">
                 <a:solidFill>
                   <a:srgbClr val="FFFFFF"/>
                 </a:solidFill>
@@ -4937,8 +4937,8 @@
         </p:nvSpPr>
         <p:spPr>
           <a:xfrm>
-            <a:off x="1965960" y="3794760"/>
-            <a:ext cx="9418320" cy="548640"/>
+            <a:off x="1828800" y="3456432"/>
+            <a:ext cx="9509760" cy="502920"/>
           </a:xfrm>
           <a:prstGeom prst="rect">
             <a:avLst/>
@@ -4975,8 +4975,8 @@
         </p:nvSpPr>
         <p:spPr>
           <a:xfrm>
-            <a:off x="822960" y="4480560"/>
-            <a:ext cx="914400" cy="777240"/>
+            <a:off x="822960" y="3995928"/>
+            <a:ext cx="822960" cy="548640"/>
           </a:xfrm>
           <a:prstGeom prst="roundRect">
             <a:avLst/>
@@ -5008,7 +5008,7 @@
           <a:lstStyle/>
           <a:p>
             <a:pPr algn="ctr">
-              <a:defRPr sz="2000" b="1">
+              <a:defRPr sz="1700" b="1">
                 <a:solidFill>
                   <a:srgbClr val="FFFFFF"/>
                 </a:solidFill>
@@ -5028,8 +5028,8 @@
         </p:nvSpPr>
         <p:spPr>
           <a:xfrm>
-            <a:off x="1965960" y="4617720"/>
-            <a:ext cx="9418320" cy="548640"/>
+            <a:off x="1828800" y="4023360"/>
+            <a:ext cx="9509760" cy="502920"/>
           </a:xfrm>
           <a:prstGeom prst="rect">
             <a:avLst/>
@@ -5066,8 +5066,8 @@
         </p:nvSpPr>
         <p:spPr>
           <a:xfrm>
-            <a:off x="822960" y="5303520"/>
-            <a:ext cx="914400" cy="777240"/>
+            <a:off x="822960" y="4562856"/>
+            <a:ext cx="822960" cy="548640"/>
           </a:xfrm>
           <a:prstGeom prst="roundRect">
             <a:avLst/>
@@ -5099,7 +5099,7 @@
           <a:lstStyle/>
           <a:p>
             <a:pPr algn="ctr">
-              <a:defRPr sz="2000" b="1">
+              <a:defRPr sz="1700" b="1">
                 <a:solidFill>
                   <a:srgbClr val="FFFFFF"/>
                 </a:solidFill>
@@ -5119,8 +5119,8 @@
         </p:nvSpPr>
         <p:spPr>
           <a:xfrm>
-            <a:off x="1965960" y="5440680"/>
-            <a:ext cx="9418320" cy="548640"/>
+            <a:off x="1828800" y="4590288"/>
+            <a:ext cx="9509760" cy="502920"/>
           </a:xfrm>
           <a:prstGeom prst="rect">
             <a:avLst/>
@@ -5157,8 +5157,8 @@
         </p:nvSpPr>
         <p:spPr>
           <a:xfrm>
-            <a:off x="822960" y="6126480"/>
-            <a:ext cx="914400" cy="777240"/>
+            <a:off x="822960" y="5129784"/>
+            <a:ext cx="822960" cy="548640"/>
           </a:xfrm>
           <a:prstGeom prst="roundRect">
             <a:avLst/>
@@ -5190,7 +5190,7 @@
           <a:lstStyle/>
           <a:p>
             <a:pPr algn="ctr">
-              <a:defRPr sz="2000" b="1">
+              <a:defRPr sz="1700" b="1">
                 <a:solidFill>
                   <a:srgbClr val="FFFFFF"/>
                 </a:solidFill>
@@ -5210,8 +5210,8 @@
         </p:nvSpPr>
         <p:spPr>
           <a:xfrm>
-            <a:off x="1965960" y="6263640"/>
-            <a:ext cx="9418320" cy="548640"/>
+            <a:off x="1828800" y="5157216"/>
+            <a:ext cx="9509760" cy="502920"/>
           </a:xfrm>
           <a:prstGeom prst="rect">
             <a:avLst/>
@@ -5248,8 +5248,8 @@
         </p:nvSpPr>
         <p:spPr>
           <a:xfrm>
-            <a:off x="822960" y="6949440"/>
-            <a:ext cx="914400" cy="777240"/>
+            <a:off x="822960" y="5696712"/>
+            <a:ext cx="822960" cy="548640"/>
           </a:xfrm>
           <a:prstGeom prst="roundRect">
             <a:avLst/>
@@ -5281,7 +5281,7 @@
           <a:lstStyle/>
           <a:p>
             <a:pPr algn="ctr">
-              <a:defRPr sz="2000" b="1">
+              <a:defRPr sz="1700" b="1">
                 <a:solidFill>
                   <a:srgbClr val="FFFFFF"/>
                 </a:solidFill>
@@ -5301,8 +5301,8 @@
         </p:nvSpPr>
         <p:spPr>
           <a:xfrm>
-            <a:off x="1965960" y="7086600"/>
-            <a:ext cx="9418320" cy="548640"/>
+            <a:off x="1828800" y="5724144"/>
+            <a:ext cx="9509760" cy="502920"/>
           </a:xfrm>
           <a:prstGeom prst="rect">
             <a:avLst/>
@@ -6304,8 +6304,8 @@
         </p:nvSpPr>
         <p:spPr>
           <a:xfrm>
-            <a:off x="822960" y="1280160"/>
-            <a:ext cx="5394960" cy="2377440"/>
+            <a:off x="822960" y="1234440"/>
+            <a:ext cx="5394960" cy="2286000"/>
           </a:xfrm>
           <a:prstGeom prst="rect">
             <a:avLst/>
@@ -6320,9 +6320,9 @@
           <a:p>
             <a:pPr>
               <a:spcAft>
-                <a:spcPts val="800"/>
+                <a:spcPts val="600"/>
               </a:spcAft>
-              <a:defRPr sz="1600">
+              <a:defRPr sz="1500">
                 <a:solidFill>
                   <a:srgbClr val="111827"/>
                 </a:solidFill>
@@ -6335,9 +6335,9 @@
           <a:p>
             <a:pPr>
               <a:spcAft>
-                <a:spcPts val="800"/>
+                <a:spcPts val="600"/>
               </a:spcAft>
-              <a:defRPr sz="1600">
+              <a:defRPr sz="1500">
                 <a:solidFill>
                   <a:srgbClr val="111827"/>
                 </a:solidFill>
@@ -6350,9 +6350,9 @@
           <a:p>
             <a:pPr>
               <a:spcAft>
-                <a:spcPts val="800"/>
+                <a:spcPts val="600"/>
               </a:spcAft>
-              <a:defRPr sz="1600">
+              <a:defRPr sz="1500">
                 <a:solidFill>
                   <a:srgbClr val="111827"/>
                 </a:solidFill>
@@ -6381,7 +6381,7 @@
         <p:spPr>
           <a:xfrm>
             <a:off x="822960" y="3657600"/>
-            <a:ext cx="5394960" cy="3371850"/>
+            <a:ext cx="4297680" cy="2686050"/>
           </a:xfrm>
           <a:prstGeom prst="rect">
             <a:avLst/>
@@ -6404,7 +6404,7 @@
         </p:blipFill>
         <p:spPr>
           <a:xfrm>
-            <a:off x="6400800" y="1280160"/>
+            <a:off x="6400800" y="1234440"/>
             <a:ext cx="5394960" cy="3371850"/>
           </a:xfrm>
           <a:prstGeom prst="rect">
@@ -6596,8 +6596,8 @@
         </p:blipFill>
         <p:spPr>
           <a:xfrm>
-            <a:off x="822960" y="1280160"/>
-            <a:ext cx="10607040" cy="6629400"/>
+            <a:off x="1737360" y="1234440"/>
+            <a:ext cx="8119872" cy="5074920"/>
           </a:xfrm>
           <a:prstGeom prst="rect">
             <a:avLst/>
@@ -6788,8 +6788,8 @@
         </p:blipFill>
         <p:spPr>
           <a:xfrm>
-            <a:off x="822960" y="1280160"/>
-            <a:ext cx="10607040" cy="6629400"/>
+            <a:off x="1737360" y="1234440"/>
+            <a:ext cx="8119872" cy="5074920"/>
           </a:xfrm>
           <a:prstGeom prst="rect">
             <a:avLst/>

</xml_diff>

<commit_message>
feat(soutenance): rebuild deck to 13 slides - add MCD capture, rewrite context slide, add concrete example per section
</commit_message>
<xml_diff>
--- a/Rapport/Soutenance - Alumni CRM - PreMSc 2026.pptx
+++ b/Rapport/Soutenance - Alumni CRM - PreMSc 2026.pptx
@@ -16,6 +16,8 @@
     <p:sldId id="264" r:id="rId15"/>
     <p:sldId id="265" r:id="rId16"/>
     <p:sldId id="266" r:id="rId17"/>
+    <p:sldId id="267" r:id="rId18"/>
+    <p:sldId id="268" r:id="rId19"/>
   </p:sldIdLst>
   <p:sldSz cx="12191695" cy="6858000" type="screen4x3"/>
   <p:notesSz cx="6858000" cy="9144000"/>
@@ -3493,7 +3495,19 @@
               </a:defRPr>
             </a:pPr>
             <a:r>
-              <a:t>Bilan, difficultés et perspectives</a:t>
+              <a:t>Démonstration — Espace Alumni</a:t>
+            </a:r>
+          </a:p>
+          <a:p>
+            <a:pPr>
+              <a:defRPr sz="1400">
+                <a:solidFill>
+                  <a:srgbClr val="EFF6FF"/>
+                </a:solidFill>
+              </a:defRPr>
+            </a:pPr>
+            <a:r>
+              <a:t>Profil, parcours, consentement, questionnaire</a:t>
             </a:r>
           </a:p>
         </p:txBody>
@@ -3541,153 +3555,33 @@
           </a:p>
         </p:txBody>
       </p:sp>
-      <p:sp>
-        <p:nvSpPr>
-          <p:cNvPr id="4" name="TextBox 3"/>
-          <p:cNvSpPr txBox="1"/>
-          <p:nvPr/>
-        </p:nvSpPr>
-        <p:spPr>
-          <a:xfrm>
-            <a:off x="822960" y="1280160"/>
-            <a:ext cx="10607040" cy="2011680"/>
-          </a:xfrm>
-          <a:prstGeom prst="rect">
-            <a:avLst/>
-          </a:prstGeom>
-          <a:noFill/>
-        </p:spPr>
-        <p:txBody>
-          <a:bodyPr wrap="square" lIns="45720" tIns="27432">
-            <a:spAutoFit/>
-          </a:bodyPr>
-          <a:lstStyle/>
-          <a:p>
-            <a:pPr>
-              <a:spcAft>
-                <a:spcPts val="800"/>
-              </a:spcAft>
-              <a:defRPr sz="1700">
-                <a:solidFill>
-                  <a:srgbClr val="111827"/>
-                </a:solidFill>
-              </a:defRPr>
-            </a:pPr>
-            <a:r>
-              <a:t>• Prototype complet et opérationnel, documenté « comme du code ».</a:t>
-            </a:r>
-          </a:p>
-          <a:p>
-            <a:pPr>
-              <a:spcAft>
-                <a:spcPts val="800"/>
-              </a:spcAft>
-              <a:defRPr sz="1700">
-                <a:solidFill>
-                  <a:srgbClr val="111827"/>
-                </a:solidFill>
-              </a:defRPr>
-            </a:pPr>
-            <a:r>
-              <a:t>• Compétences : full-stack, sécurité applicative, migrations versionnées, RGPD.</a:t>
-            </a:r>
-          </a:p>
-        </p:txBody>
-      </p:sp>
+      <p:pic>
+        <p:nvPicPr>
+          <p:cNvPr id="4" name="Picture 3" descr="anC_parcours_light.png"/>
+          <p:cNvPicPr>
+            <a:picLocks noChangeAspect="1"/>
+          </p:cNvPicPr>
+          <p:nvPr/>
+        </p:nvPicPr>
+        <p:blipFill>
+          <a:blip r:embed="rId2"/>
+          <a:stretch>
+            <a:fillRect/>
+          </a:stretch>
+        </p:blipFill>
+        <p:spPr>
+          <a:xfrm>
+            <a:off x="1737360" y="1234440"/>
+            <a:ext cx="8119872" cy="5074920"/>
+          </a:xfrm>
+          <a:prstGeom prst="rect">
+            <a:avLst/>
+          </a:prstGeom>
+        </p:spPr>
+      </p:pic>
       <p:sp>
         <p:nvSpPr>
           <p:cNvPr id="5" name="TextBox 4"/>
-          <p:cNvSpPr txBox="1"/>
-          <p:nvPr/>
-        </p:nvSpPr>
-        <p:spPr>
-          <a:xfrm>
-            <a:off x="822960" y="3200400"/>
-            <a:ext cx="10607040" cy="1554480"/>
-          </a:xfrm>
-          <a:prstGeom prst="rect">
-            <a:avLst/>
-          </a:prstGeom>
-          <a:noFill/>
-        </p:spPr>
-        <p:txBody>
-          <a:bodyPr wrap="square" lIns="45720" tIns="27432">
-            <a:spAutoFit/>
-          </a:bodyPr>
-          <a:lstStyle/>
-          <a:p>
-            <a:pPr>
-              <a:spcAft>
-                <a:spcPts val="800"/>
-              </a:spcAft>
-              <a:defRPr sz="1600">
-                <a:solidFill>
-                  <a:srgbClr val="111827"/>
-                </a:solidFill>
-              </a:defRPr>
-            </a:pPr>
-            <a:r>
-              <a:t>• Limites assumées : tests automatisés non conservés, newsletter et mise à jour d'expérience à faire.</a:t>
-            </a:r>
-          </a:p>
-        </p:txBody>
-      </p:sp>
-      <p:sp>
-        <p:nvSpPr>
-          <p:cNvPr id="6" name="TextBox 5"/>
-          <p:cNvSpPr txBox="1"/>
-          <p:nvPr/>
-        </p:nvSpPr>
-        <p:spPr>
-          <a:xfrm>
-            <a:off x="822960" y="4480560"/>
-            <a:ext cx="10607040" cy="1828800"/>
-          </a:xfrm>
-          <a:prstGeom prst="rect">
-            <a:avLst/>
-          </a:prstGeom>
-          <a:noFill/>
-        </p:spPr>
-        <p:txBody>
-          <a:bodyPr wrap="square" lIns="45720" tIns="27432">
-            <a:spAutoFit/>
-          </a:bodyPr>
-          <a:lstStyle/>
-          <a:p>
-            <a:pPr>
-              <a:spcAft>
-                <a:spcPts val="600"/>
-              </a:spcAft>
-              <a:defRPr sz="1600">
-                <a:solidFill>
-                  <a:srgbClr val="111827"/>
-                </a:solidFill>
-              </a:defRPr>
-            </a:pPr>
-            <a:r>
-              <a:t>• Court terme : suite de tests, automatisation du questionnaire, frontend newsletter.</a:t>
-            </a:r>
-          </a:p>
-          <a:p>
-            <a:pPr>
-              <a:spcAft>
-                <a:spcPts val="600"/>
-              </a:spcAft>
-              <a:defRPr sz="1600">
-                <a:solidFill>
-                  <a:srgbClr val="111827"/>
-                </a:solidFill>
-              </a:defRPr>
-            </a:pPr>
-            <a:r>
-              <a:t>• Moyen/long terme : mentorat, chiffrement applicatif, application mobile / PWA.</a:t>
-            </a:r>
-          </a:p>
-        </p:txBody>
-      </p:sp>
-      <p:sp>
-        <p:nvSpPr>
-          <p:cNvPr id="7" name="TextBox 6"/>
           <p:cNvSpPr txBox="1"/>
           <p:nvPr/>
         </p:nvSpPr>
@@ -3755,6 +3649,767 @@
         <p:spPr>
           <a:xfrm>
             <a:off x="0" y="0"/>
+            <a:ext cx="12191695" cy="1005840"/>
+          </a:xfrm>
+          <a:prstGeom prst="rect">
+            <a:avLst/>
+          </a:prstGeom>
+          <a:solidFill>
+            <a:srgbClr val="1E40AF"/>
+          </a:solidFill>
+          <a:ln>
+            <a:noFill/>
+          </a:ln>
+        </p:spPr>
+        <p:style>
+          <a:lnRef idx="1">
+            <a:schemeClr val="accent1"/>
+          </a:lnRef>
+          <a:fillRef idx="3">
+            <a:schemeClr val="accent1"/>
+          </a:fillRef>
+          <a:effectRef idx="2">
+            <a:schemeClr val="accent1"/>
+          </a:effectRef>
+          <a:fontRef idx="minor">
+            <a:schemeClr val="lt1"/>
+          </a:fontRef>
+        </p:style>
+        <p:txBody>
+          <a:bodyPr rtlCol="0" anchor="ctr" lIns="457200" tIns="137160" wrap="square"/>
+          <a:lstStyle/>
+          <a:p>
+            <a:pPr algn="ctr">
+              <a:defRPr sz="2800" b="1">
+                <a:solidFill>
+                  <a:srgbClr val="FFFFFF"/>
+                </a:solidFill>
+              </a:defRPr>
+            </a:pPr>
+            <a:r>
+              <a:t>Indicateurs d'insertion professionnelle</a:t>
+            </a:r>
+          </a:p>
+        </p:txBody>
+      </p:sp>
+      <p:sp>
+        <p:nvSpPr>
+          <p:cNvPr id="3" name="Rectangle 2"/>
+          <p:cNvSpPr/>
+          <p:nvPr/>
+        </p:nvSpPr>
+        <p:spPr>
+          <a:xfrm>
+            <a:off x="0" y="1005840"/>
+            <a:ext cx="12191695" cy="54864"/>
+          </a:xfrm>
+          <a:prstGeom prst="rect">
+            <a:avLst/>
+          </a:prstGeom>
+          <a:solidFill>
+            <a:srgbClr val="10B981"/>
+          </a:solidFill>
+          <a:ln>
+            <a:noFill/>
+          </a:ln>
+        </p:spPr>
+        <p:style>
+          <a:lnRef idx="1">
+            <a:schemeClr val="accent1"/>
+          </a:lnRef>
+          <a:fillRef idx="3">
+            <a:schemeClr val="accent1"/>
+          </a:fillRef>
+          <a:effectRef idx="2">
+            <a:schemeClr val="accent1"/>
+          </a:effectRef>
+          <a:fontRef idx="minor">
+            <a:schemeClr val="lt1"/>
+          </a:fontRef>
+        </p:style>
+        <p:txBody>
+          <a:bodyPr rtlCol="0" anchor="ctr"/>
+          <a:lstStyle/>
+          <a:p>
+            <a:pPr algn="ctr"/>
+          </a:p>
+        </p:txBody>
+      </p:sp>
+      <p:sp>
+        <p:nvSpPr>
+          <p:cNvPr id="4" name="TextBox 3"/>
+          <p:cNvSpPr txBox="1"/>
+          <p:nvPr/>
+        </p:nvSpPr>
+        <p:spPr>
+          <a:xfrm>
+            <a:off x="822960" y="1188720"/>
+            <a:ext cx="5394960" cy="2926080"/>
+          </a:xfrm>
+          <a:prstGeom prst="rect">
+            <a:avLst/>
+          </a:prstGeom>
+          <a:noFill/>
+        </p:spPr>
+        <p:txBody>
+          <a:bodyPr wrap="square" lIns="45720" tIns="27432">
+            <a:spAutoFit/>
+          </a:bodyPr>
+          <a:lstStyle/>
+          <a:p>
+            <a:pPr>
+              <a:spcAft>
+                <a:spcPts val="600"/>
+              </a:spcAft>
+              <a:defRPr sz="1500">
+                <a:solidFill>
+                  <a:srgbClr val="111827"/>
+                </a:solidFill>
+              </a:defRPr>
+            </a:pPr>
+            <a:r>
+              <a:t>• 8 indicateurs reproductibles, formule et source explicites.</a:t>
+            </a:r>
+          </a:p>
+          <a:p>
+            <a:pPr>
+              <a:spcAft>
+                <a:spcPts val="600"/>
+              </a:spcAft>
+              <a:defRPr sz="1500">
+                <a:solidFill>
+                  <a:srgbClr val="111827"/>
+                </a:solidFill>
+              </a:defRPr>
+            </a:pPr>
+            <a:r>
+              <a:t>• Taux d'emploi à 6 mois (expériences actives).</a:t>
+            </a:r>
+          </a:p>
+          <a:p>
+            <a:pPr>
+              <a:spcAft>
+                <a:spcPts val="600"/>
+              </a:spcAft>
+              <a:defRPr sz="1500">
+                <a:solidFill>
+                  <a:srgbClr val="111827"/>
+                </a:solidFill>
+              </a:defRPr>
+            </a:pPr>
+            <a:r>
+              <a:t>• Adéquation formation/emploi via les tags KPI.</a:t>
+            </a:r>
+          </a:p>
+          <a:p>
+            <a:pPr>
+              <a:spcAft>
+                <a:spcPts val="600"/>
+              </a:spcAft>
+              <a:defRPr sz="1500">
+                <a:solidFill>
+                  <a:srgbClr val="111827"/>
+                </a:solidFill>
+              </a:defRPr>
+            </a:pPr>
+            <a:r>
+              <a:t>• Salaire moyen / min / max (champ annuel).</a:t>
+            </a:r>
+          </a:p>
+          <a:p>
+            <a:pPr>
+              <a:spcAft>
+                <a:spcPts val="600"/>
+              </a:spcAft>
+              <a:defRPr sz="1500">
+                <a:solidFill>
+                  <a:srgbClr val="111827"/>
+                </a:solidFill>
+              </a:defRPr>
+            </a:pPr>
+            <a:r>
+              <a:t>• Répartition par promotion et secteur.</a:t>
+            </a:r>
+          </a:p>
+          <a:p>
+            <a:pPr>
+              <a:spcAft>
+                <a:spcPts val="600"/>
+              </a:spcAft>
+              <a:defRPr sz="1500">
+                <a:solidFill>
+                  <a:srgbClr val="111827"/>
+                </a:solidFill>
+              </a:defRPr>
+            </a:pPr>
+            <a:r>
+              <a:t>• Pas de chiffre trompeur : cohortes immatures → « non disponible ».</a:t>
+            </a:r>
+          </a:p>
+        </p:txBody>
+      </p:sp>
+      <p:sp>
+        <p:nvSpPr>
+          <p:cNvPr id="5" name="Rounded Rectangle 4"/>
+          <p:cNvSpPr/>
+          <p:nvPr/>
+        </p:nvSpPr>
+        <p:spPr>
+          <a:xfrm>
+            <a:off x="822960" y="5349240"/>
+            <a:ext cx="10607040" cy="868680"/>
+          </a:xfrm>
+          <a:prstGeom prst="roundRect">
+            <a:avLst/>
+          </a:prstGeom>
+          <a:solidFill>
+            <a:srgbClr val="EFF6FF"/>
+          </a:solidFill>
+          <a:ln w="12700">
+            <a:solidFill>
+              <a:srgbClr val="10B981"/>
+            </a:solidFill>
+          </a:ln>
+          <a:effectLst/>
+        </p:spPr>
+        <p:style>
+          <a:lnRef idx="1">
+            <a:schemeClr val="accent1"/>
+          </a:lnRef>
+          <a:fillRef idx="3">
+            <a:schemeClr val="accent1"/>
+          </a:fillRef>
+          <a:effectRef idx="2">
+            <a:schemeClr val="accent1"/>
+          </a:effectRef>
+          <a:fontRef idx="minor">
+            <a:schemeClr val="lt1"/>
+          </a:fontRef>
+        </p:style>
+        <p:txBody>
+          <a:bodyPr rtlCol="0" anchor="ctr"/>
+          <a:lstStyle/>
+          <a:p>
+            <a:pPr algn="ctr"/>
+          </a:p>
+        </p:txBody>
+      </p:sp>
+      <p:sp>
+        <p:nvSpPr>
+          <p:cNvPr id="6" name="TextBox 5"/>
+          <p:cNvSpPr txBox="1"/>
+          <p:nvPr/>
+        </p:nvSpPr>
+        <p:spPr>
+          <a:xfrm>
+            <a:off x="1097280" y="5440680"/>
+            <a:ext cx="1920240" cy="640080"/>
+          </a:xfrm>
+          <a:prstGeom prst="rect">
+            <a:avLst/>
+          </a:prstGeom>
+          <a:noFill/>
+        </p:spPr>
+        <p:txBody>
+          <a:bodyPr wrap="square" lIns="45720" rIns="45720" tIns="27432" bIns="27432">
+            <a:spAutoFit/>
+          </a:bodyPr>
+          <a:lstStyle/>
+          <a:p>
+            <a:pPr algn="l">
+              <a:spcAft>
+                <a:spcPts val="200"/>
+              </a:spcAft>
+              <a:defRPr sz="1400" b="1">
+                <a:solidFill>
+                  <a:srgbClr val="10B981"/>
+                </a:solidFill>
+              </a:defRPr>
+            </a:pPr>
+            <a:r>
+              <a:t>EXEMPLE</a:t>
+            </a:r>
+          </a:p>
+        </p:txBody>
+      </p:sp>
+      <p:sp>
+        <p:nvSpPr>
+          <p:cNvPr id="7" name="TextBox 6"/>
+          <p:cNvSpPr txBox="1"/>
+          <p:nvPr/>
+        </p:nvSpPr>
+        <p:spPr>
+          <a:xfrm>
+            <a:off x="3017520" y="5458968"/>
+            <a:ext cx="8229600" cy="640080"/>
+          </a:xfrm>
+          <a:prstGeom prst="rect">
+            <a:avLst/>
+          </a:prstGeom>
+          <a:noFill/>
+        </p:spPr>
+        <p:txBody>
+          <a:bodyPr wrap="square" lIns="45720" rIns="45720" tIns="27432" bIns="27432">
+            <a:spAutoFit/>
+          </a:bodyPr>
+          <a:lstStyle/>
+          <a:p>
+            <a:pPr algn="l">
+              <a:spcAft>
+                <a:spcPts val="200"/>
+              </a:spcAft>
+              <a:defRPr sz="1500" b="0">
+                <a:solidFill>
+                  <a:srgbClr val="111827"/>
+                </a:solidFill>
+              </a:defRPr>
+            </a:pPr>
+            <a:r>
+              <a:t>Calcul : taux d'emploi à 6 mois = diplômés de la promo en poste actif à la date de référence / diplômés de la promo (cohorte mature).</a:t>
+            </a:r>
+          </a:p>
+        </p:txBody>
+      </p:sp>
+      <p:pic>
+        <p:nvPicPr>
+          <p:cNvPr id="8" name="Picture 7" descr="anB_dashboard_light.png"/>
+          <p:cNvPicPr>
+            <a:picLocks noChangeAspect="1"/>
+          </p:cNvPicPr>
+          <p:nvPr/>
+        </p:nvPicPr>
+        <p:blipFill>
+          <a:blip r:embed="rId2"/>
+          <a:stretch>
+            <a:fillRect/>
+          </a:stretch>
+        </p:blipFill>
+        <p:spPr>
+          <a:xfrm>
+            <a:off x="6400800" y="1737360"/>
+            <a:ext cx="5120640" cy="3200400"/>
+          </a:xfrm>
+          <a:prstGeom prst="rect">
+            <a:avLst/>
+          </a:prstGeom>
+        </p:spPr>
+      </p:pic>
+      <p:sp>
+        <p:nvSpPr>
+          <p:cNvPr id="9" name="TextBox 8"/>
+          <p:cNvSpPr txBox="1"/>
+          <p:nvPr/>
+        </p:nvSpPr>
+        <p:spPr>
+          <a:xfrm>
+            <a:off x="365760" y="6446520"/>
+            <a:ext cx="11430000" cy="365760"/>
+          </a:xfrm>
+          <a:prstGeom prst="rect">
+            <a:avLst/>
+          </a:prstGeom>
+          <a:noFill/>
+        </p:spPr>
+        <p:txBody>
+          <a:bodyPr wrap="none">
+            <a:spAutoFit/>
+          </a:bodyPr>
+          <a:lstStyle/>
+          <a:p>
+            <a:pPr>
+              <a:defRPr sz="1100">
+                <a:solidFill>
+                  <a:srgbClr val="6B7280"/>
+                </a:solidFill>
+              </a:defRPr>
+            </a:pPr>
+            <a:r>
+              <a:t>Alumni CRM — Stage PreMSc 2026 — IONIS-STM        11</a:t>
+            </a:r>
+          </a:p>
+        </p:txBody>
+      </p:sp>
+    </p:spTree>
+  </p:cSld>
+  <p:clrMapOvr>
+    <a:masterClrMapping/>
+  </p:clrMapOvr>
+</p:sld>
+</file>
+
+<file path=ppt/slides/slide12.xml><?xml version="1.0" encoding="utf-8"?>
+<p:sld xmlns:a="http://schemas.openxmlformats.org/drawingml/2006/main" xmlns:p="http://schemas.openxmlformats.org/presentationml/2006/main" xmlns:r="http://schemas.openxmlformats.org/officeDocument/2006/relationships">
+  <p:cSld>
+    <p:bg>
+      <p:bgPr>
+        <a:solidFill>
+          <a:srgbClr val="FFFFFF"/>
+        </a:solidFill>
+        <a:effectLst/>
+      </p:bgPr>
+    </p:bg>
+    <p:spTree>
+      <p:nvGrpSpPr>
+        <p:cNvPr id="1" name=""/>
+        <p:cNvGrpSpPr/>
+        <p:nvPr/>
+      </p:nvGrpSpPr>
+      <p:grpSpPr/>
+      <p:sp>
+        <p:nvSpPr>
+          <p:cNvPr id="2" name="Rectangle 1"/>
+          <p:cNvSpPr/>
+          <p:nvPr/>
+        </p:nvSpPr>
+        <p:spPr>
+          <a:xfrm>
+            <a:off x="0" y="0"/>
+            <a:ext cx="12191695" cy="1005840"/>
+          </a:xfrm>
+          <a:prstGeom prst="rect">
+            <a:avLst/>
+          </a:prstGeom>
+          <a:solidFill>
+            <a:srgbClr val="1E40AF"/>
+          </a:solidFill>
+          <a:ln>
+            <a:noFill/>
+          </a:ln>
+        </p:spPr>
+        <p:style>
+          <a:lnRef idx="1">
+            <a:schemeClr val="accent1"/>
+          </a:lnRef>
+          <a:fillRef idx="3">
+            <a:schemeClr val="accent1"/>
+          </a:fillRef>
+          <a:effectRef idx="2">
+            <a:schemeClr val="accent1"/>
+          </a:effectRef>
+          <a:fontRef idx="minor">
+            <a:schemeClr val="lt1"/>
+          </a:fontRef>
+        </p:style>
+        <p:txBody>
+          <a:bodyPr rtlCol="0" anchor="ctr" lIns="457200" tIns="137160" wrap="square"/>
+          <a:lstStyle/>
+          <a:p>
+            <a:pPr algn="ctr">
+              <a:defRPr sz="2800" b="1">
+                <a:solidFill>
+                  <a:srgbClr val="FFFFFF"/>
+                </a:solidFill>
+              </a:defRPr>
+            </a:pPr>
+            <a:r>
+              <a:t>Bilan et perspectives</a:t>
+            </a:r>
+          </a:p>
+        </p:txBody>
+      </p:sp>
+      <p:sp>
+        <p:nvSpPr>
+          <p:cNvPr id="3" name="Rectangle 2"/>
+          <p:cNvSpPr/>
+          <p:nvPr/>
+        </p:nvSpPr>
+        <p:spPr>
+          <a:xfrm>
+            <a:off x="0" y="1005840"/>
+            <a:ext cx="12191695" cy="54864"/>
+          </a:xfrm>
+          <a:prstGeom prst="rect">
+            <a:avLst/>
+          </a:prstGeom>
+          <a:solidFill>
+            <a:srgbClr val="10B981"/>
+          </a:solidFill>
+          <a:ln>
+            <a:noFill/>
+          </a:ln>
+        </p:spPr>
+        <p:style>
+          <a:lnRef idx="1">
+            <a:schemeClr val="accent1"/>
+          </a:lnRef>
+          <a:fillRef idx="3">
+            <a:schemeClr val="accent1"/>
+          </a:fillRef>
+          <a:effectRef idx="2">
+            <a:schemeClr val="accent1"/>
+          </a:effectRef>
+          <a:fontRef idx="minor">
+            <a:schemeClr val="lt1"/>
+          </a:fontRef>
+        </p:style>
+        <p:txBody>
+          <a:bodyPr rtlCol="0" anchor="ctr"/>
+          <a:lstStyle/>
+          <a:p>
+            <a:pPr algn="ctr"/>
+          </a:p>
+        </p:txBody>
+      </p:sp>
+      <p:sp>
+        <p:nvSpPr>
+          <p:cNvPr id="4" name="TextBox 3"/>
+          <p:cNvSpPr txBox="1"/>
+          <p:nvPr/>
+        </p:nvSpPr>
+        <p:spPr>
+          <a:xfrm>
+            <a:off x="822960" y="1188720"/>
+            <a:ext cx="10607040" cy="2926080"/>
+          </a:xfrm>
+          <a:prstGeom prst="rect">
+            <a:avLst/>
+          </a:prstGeom>
+          <a:noFill/>
+        </p:spPr>
+        <p:txBody>
+          <a:bodyPr wrap="square" lIns="45720" tIns="27432">
+            <a:spAutoFit/>
+          </a:bodyPr>
+          <a:lstStyle/>
+          <a:p>
+            <a:pPr>
+              <a:spcAft>
+                <a:spcPts val="900"/>
+              </a:spcAft>
+              <a:defRPr sz="1600">
+                <a:solidFill>
+                  <a:srgbClr val="111827"/>
+                </a:solidFill>
+              </a:defRPr>
+            </a:pPr>
+            <a:r>
+              <a:t>• Prototype complet et opérationnel, documenté « comme du code » (rapports, cartographies, guide des processus, support de soutenance).</a:t>
+            </a:r>
+          </a:p>
+          <a:p>
+            <a:pPr>
+              <a:spcAft>
+                <a:spcPts val="900"/>
+              </a:spcAft>
+              <a:defRPr sz="1600">
+                <a:solidFill>
+                  <a:srgbClr val="111827"/>
+                </a:solidFill>
+              </a:defRPr>
+            </a:pPr>
+            <a:r>
+              <a:t>• Compétences : full-stack, sécurité applicative, migrations versionnées, RGPD.</a:t>
+            </a:r>
+          </a:p>
+          <a:p>
+            <a:pPr>
+              <a:spcAft>
+                <a:spcPts val="900"/>
+              </a:spcAft>
+              <a:defRPr sz="1600">
+                <a:solidFill>
+                  <a:srgbClr val="111827"/>
+                </a:solidFill>
+              </a:defRPr>
+            </a:pPr>
+            <a:r>
+              <a:t>• Perspectives : suite de tests automatisés, automatisation du questionnaire, frontend newsletter, mentorat, application mobile / PWA.</a:t>
+            </a:r>
+          </a:p>
+        </p:txBody>
+      </p:sp>
+      <p:sp>
+        <p:nvSpPr>
+          <p:cNvPr id="5" name="Rounded Rectangle 4"/>
+          <p:cNvSpPr/>
+          <p:nvPr/>
+        </p:nvSpPr>
+        <p:spPr>
+          <a:xfrm>
+            <a:off x="822960" y="5349240"/>
+            <a:ext cx="10607040" cy="868680"/>
+          </a:xfrm>
+          <a:prstGeom prst="roundRect">
+            <a:avLst/>
+          </a:prstGeom>
+          <a:solidFill>
+            <a:srgbClr val="EFF6FF"/>
+          </a:solidFill>
+          <a:ln w="12700">
+            <a:solidFill>
+              <a:srgbClr val="10B981"/>
+            </a:solidFill>
+          </a:ln>
+          <a:effectLst/>
+        </p:spPr>
+        <p:style>
+          <a:lnRef idx="1">
+            <a:schemeClr val="accent1"/>
+          </a:lnRef>
+          <a:fillRef idx="3">
+            <a:schemeClr val="accent1"/>
+          </a:fillRef>
+          <a:effectRef idx="2">
+            <a:schemeClr val="accent1"/>
+          </a:effectRef>
+          <a:fontRef idx="minor">
+            <a:schemeClr val="lt1"/>
+          </a:fontRef>
+        </p:style>
+        <p:txBody>
+          <a:bodyPr rtlCol="0" anchor="ctr"/>
+          <a:lstStyle/>
+          <a:p>
+            <a:pPr algn="ctr"/>
+          </a:p>
+        </p:txBody>
+      </p:sp>
+      <p:sp>
+        <p:nvSpPr>
+          <p:cNvPr id="6" name="TextBox 5"/>
+          <p:cNvSpPr txBox="1"/>
+          <p:nvPr/>
+        </p:nvSpPr>
+        <p:spPr>
+          <a:xfrm>
+            <a:off x="1097280" y="5440680"/>
+            <a:ext cx="1920240" cy="640080"/>
+          </a:xfrm>
+          <a:prstGeom prst="rect">
+            <a:avLst/>
+          </a:prstGeom>
+          <a:noFill/>
+        </p:spPr>
+        <p:txBody>
+          <a:bodyPr wrap="square" lIns="45720" rIns="45720" tIns="27432" bIns="27432">
+            <a:spAutoFit/>
+          </a:bodyPr>
+          <a:lstStyle/>
+          <a:p>
+            <a:pPr algn="l">
+              <a:spcAft>
+                <a:spcPts val="200"/>
+              </a:spcAft>
+              <a:defRPr sz="1400" b="1">
+                <a:solidFill>
+                  <a:srgbClr val="10B981"/>
+                </a:solidFill>
+              </a:defRPr>
+            </a:pPr>
+            <a:r>
+              <a:t>EXEMPLE</a:t>
+            </a:r>
+          </a:p>
+        </p:txBody>
+      </p:sp>
+      <p:sp>
+        <p:nvSpPr>
+          <p:cNvPr id="7" name="TextBox 6"/>
+          <p:cNvSpPr txBox="1"/>
+          <p:nvPr/>
+        </p:nvSpPr>
+        <p:spPr>
+          <a:xfrm>
+            <a:off x="3017520" y="5458968"/>
+            <a:ext cx="8229600" cy="640080"/>
+          </a:xfrm>
+          <a:prstGeom prst="rect">
+            <a:avLst/>
+          </a:prstGeom>
+          <a:noFill/>
+        </p:spPr>
+        <p:txBody>
+          <a:bodyPr wrap="square" lIns="45720" rIns="45720" tIns="27432" bIns="27432">
+            <a:spAutoFit/>
+          </a:bodyPr>
+          <a:lstStyle/>
+          <a:p>
+            <a:pPr algn="l">
+              <a:spcAft>
+                <a:spcPts val="200"/>
+              </a:spcAft>
+              <a:defRPr sz="1500" b="0">
+                <a:solidFill>
+                  <a:srgbClr val="111827"/>
+                </a:solidFill>
+              </a:defRPr>
+            </a:pPr>
+            <a:r>
+              <a:t>Suite : le dépôt Git versionne les migrations et les scripts de génération : le projet reste rejouable et transmissible à la reprise.</a:t>
+            </a:r>
+          </a:p>
+        </p:txBody>
+      </p:sp>
+      <p:sp>
+        <p:nvSpPr>
+          <p:cNvPr id="8" name="TextBox 7"/>
+          <p:cNvSpPr txBox="1"/>
+          <p:nvPr/>
+        </p:nvSpPr>
+        <p:spPr>
+          <a:xfrm>
+            <a:off x="365760" y="6446520"/>
+            <a:ext cx="11430000" cy="365760"/>
+          </a:xfrm>
+          <a:prstGeom prst="rect">
+            <a:avLst/>
+          </a:prstGeom>
+          <a:noFill/>
+        </p:spPr>
+        <p:txBody>
+          <a:bodyPr wrap="none">
+            <a:spAutoFit/>
+          </a:bodyPr>
+          <a:lstStyle/>
+          <a:p>
+            <a:pPr>
+              <a:defRPr sz="1100">
+                <a:solidFill>
+                  <a:srgbClr val="6B7280"/>
+                </a:solidFill>
+              </a:defRPr>
+            </a:pPr>
+            <a:r>
+              <a:t>Alumni CRM — Stage PreMSc 2026 — IONIS-STM        12</a:t>
+            </a:r>
+          </a:p>
+        </p:txBody>
+      </p:sp>
+    </p:spTree>
+  </p:cSld>
+  <p:clrMapOvr>
+    <a:masterClrMapping/>
+  </p:clrMapOvr>
+</p:sld>
+</file>
+
+<file path=ppt/slides/slide13.xml><?xml version="1.0" encoding="utf-8"?>
+<p:sld xmlns:a="http://schemas.openxmlformats.org/drawingml/2006/main" xmlns:p="http://schemas.openxmlformats.org/presentationml/2006/main" xmlns:r="http://schemas.openxmlformats.org/officeDocument/2006/relationships">
+  <p:cSld>
+    <p:bg>
+      <p:bgPr>
+        <a:solidFill>
+          <a:srgbClr val="FFFFFF"/>
+        </a:solidFill>
+        <a:effectLst/>
+      </p:bgPr>
+    </p:bg>
+    <p:spTree>
+      <p:nvGrpSpPr>
+        <p:cNvPr id="1" name=""/>
+        <p:cNvGrpSpPr/>
+        <p:nvPr/>
+      </p:nvGrpSpPr>
+      <p:grpSpPr/>
+      <p:sp>
+        <p:nvSpPr>
+          <p:cNvPr id="2" name="Rectangle 1"/>
+          <p:cNvSpPr/>
+          <p:nvPr/>
+        </p:nvSpPr>
+        <p:spPr>
+          <a:xfrm>
+            <a:off x="0" y="0"/>
             <a:ext cx="12191695" cy="164592"/>
           </a:xfrm>
           <a:prstGeom prst="rect">
@@ -4047,8 +4702,8 @@
         </p:nvSpPr>
         <p:spPr>
           <a:xfrm>
-            <a:off x="822960" y="1371600"/>
-            <a:ext cx="914400" cy="731520"/>
+            <a:off x="822960" y="1325880"/>
+            <a:ext cx="914400" cy="658368"/>
           </a:xfrm>
           <a:prstGeom prst="roundRect">
             <a:avLst/>
@@ -4080,7 +4735,7 @@
           <a:lstStyle/>
           <a:p>
             <a:pPr algn="ctr">
-              <a:defRPr sz="2600" b="1">
+              <a:defRPr sz="2400" b="1">
                 <a:solidFill>
                   <a:srgbClr val="FFFFFF"/>
                 </a:solidFill>
@@ -4100,8 +4755,8 @@
         </p:nvSpPr>
         <p:spPr>
           <a:xfrm>
-            <a:off x="1965960" y="1508760"/>
-            <a:ext cx="9418320" cy="548640"/>
+            <a:off x="1965960" y="1417320"/>
+            <a:ext cx="9418320" cy="502920"/>
           </a:xfrm>
           <a:prstGeom prst="rect">
             <a:avLst/>
@@ -4125,7 +4780,7 @@
               </a:defRPr>
             </a:pPr>
             <a:r>
-              <a:t>Contexte, objectifs</a:t>
+              <a:t>Contexte et objectifs</a:t>
             </a:r>
           </a:p>
         </p:txBody>
@@ -4138,8 +4793,8 @@
         </p:nvSpPr>
         <p:spPr>
           <a:xfrm>
-            <a:off x="822960" y="2212848"/>
-            <a:ext cx="914400" cy="731520"/>
+            <a:off x="822960" y="2057400"/>
+            <a:ext cx="914400" cy="658368"/>
           </a:xfrm>
           <a:prstGeom prst="roundRect">
             <a:avLst/>
@@ -4171,7 +4826,7 @@
           <a:lstStyle/>
           <a:p>
             <a:pPr algn="ctr">
-              <a:defRPr sz="2600" b="1">
+              <a:defRPr sz="2400" b="1">
                 <a:solidFill>
                   <a:srgbClr val="FFFFFF"/>
                 </a:solidFill>
@@ -4191,8 +4846,8 @@
         </p:nvSpPr>
         <p:spPr>
           <a:xfrm>
-            <a:off x="1965960" y="2350008"/>
-            <a:ext cx="9418320" cy="548640"/>
+            <a:off x="1965960" y="2148840"/>
+            <a:ext cx="9418320" cy="502920"/>
           </a:xfrm>
           <a:prstGeom prst="rect">
             <a:avLst/>
@@ -4229,8 +4884,8 @@
         </p:nvSpPr>
         <p:spPr>
           <a:xfrm>
-            <a:off x="822960" y="3054096"/>
-            <a:ext cx="914400" cy="731520"/>
+            <a:off x="822960" y="2788920"/>
+            <a:ext cx="914400" cy="658368"/>
           </a:xfrm>
           <a:prstGeom prst="roundRect">
             <a:avLst/>
@@ -4262,7 +4917,7 @@
           <a:lstStyle/>
           <a:p>
             <a:pPr algn="ctr">
-              <a:defRPr sz="2600" b="1">
+              <a:defRPr sz="2400" b="1">
                 <a:solidFill>
                   <a:srgbClr val="FFFFFF"/>
                 </a:solidFill>
@@ -4282,8 +4937,8 @@
         </p:nvSpPr>
         <p:spPr>
           <a:xfrm>
-            <a:off x="1965960" y="3191256"/>
-            <a:ext cx="9418320" cy="548640"/>
+            <a:off x="1965960" y="2880360"/>
+            <a:ext cx="9418320" cy="502920"/>
           </a:xfrm>
           <a:prstGeom prst="rect">
             <a:avLst/>
@@ -4307,7 +4962,7 @@
               </a:defRPr>
             </a:pPr>
             <a:r>
-              <a:t>Modèle de données et RGPD</a:t>
+              <a:t>Modèle de données (MCD)</a:t>
             </a:r>
           </a:p>
         </p:txBody>
@@ -4320,8 +4975,8 @@
         </p:nvSpPr>
         <p:spPr>
           <a:xfrm>
-            <a:off x="822960" y="3895344"/>
-            <a:ext cx="914400" cy="731520"/>
+            <a:off x="822960" y="3520440"/>
+            <a:ext cx="914400" cy="658368"/>
           </a:xfrm>
           <a:prstGeom prst="roundRect">
             <a:avLst/>
@@ -4353,7 +5008,7 @@
           <a:lstStyle/>
           <a:p>
             <a:pPr algn="ctr">
-              <a:defRPr sz="2600" b="1">
+              <a:defRPr sz="2400" b="1">
                 <a:solidFill>
                   <a:srgbClr val="FFFFFF"/>
                 </a:solidFill>
@@ -4373,8 +5028,8 @@
         </p:nvSpPr>
         <p:spPr>
           <a:xfrm>
-            <a:off x="1965960" y="4032504"/>
-            <a:ext cx="9418320" cy="548640"/>
+            <a:off x="1965960" y="3611880"/>
+            <a:ext cx="9418320" cy="502920"/>
           </a:xfrm>
           <a:prstGeom prst="rect">
             <a:avLst/>
@@ -4398,7 +5053,7 @@
               </a:defRPr>
             </a:pPr>
             <a:r>
-              <a:t>Démonstration — espaces Admin et Alumni</a:t>
+              <a:t>Conformité RGPD</a:t>
             </a:r>
           </a:p>
         </p:txBody>
@@ -4411,8 +5066,8 @@
         </p:nvSpPr>
         <p:spPr>
           <a:xfrm>
-            <a:off x="822960" y="4736592"/>
-            <a:ext cx="914400" cy="731520"/>
+            <a:off x="822960" y="4251960"/>
+            <a:ext cx="914400" cy="658368"/>
           </a:xfrm>
           <a:prstGeom prst="roundRect">
             <a:avLst/>
@@ -4444,7 +5099,7 @@
           <a:lstStyle/>
           <a:p>
             <a:pPr algn="ctr">
-              <a:defRPr sz="2600" b="1">
+              <a:defRPr sz="2400" b="1">
                 <a:solidFill>
                   <a:srgbClr val="FFFFFF"/>
                 </a:solidFill>
@@ -4464,8 +5119,8 @@
         </p:nvSpPr>
         <p:spPr>
           <a:xfrm>
-            <a:off x="1965960" y="4873752"/>
-            <a:ext cx="9418320" cy="548640"/>
+            <a:off x="1965960" y="4343400"/>
+            <a:ext cx="9418320" cy="502920"/>
           </a:xfrm>
           <a:prstGeom prst="rect">
             <a:avLst/>
@@ -4489,7 +5144,7 @@
               </a:defRPr>
             </a:pPr>
             <a:r>
-              <a:t>Indicateurs d'insertion</a:t>
+              <a:t>Démonstration — Admin et Alumni</a:t>
             </a:r>
           </a:p>
         </p:txBody>
@@ -4502,8 +5157,8 @@
         </p:nvSpPr>
         <p:spPr>
           <a:xfrm>
-            <a:off x="822960" y="5577840"/>
-            <a:ext cx="914400" cy="731520"/>
+            <a:off x="822960" y="4983480"/>
+            <a:ext cx="914400" cy="658368"/>
           </a:xfrm>
           <a:prstGeom prst="roundRect">
             <a:avLst/>
@@ -4535,7 +5190,7 @@
           <a:lstStyle/>
           <a:p>
             <a:pPr algn="ctr">
-              <a:defRPr sz="2600" b="1">
+              <a:defRPr sz="2400" b="1">
                 <a:solidFill>
                   <a:srgbClr val="FFFFFF"/>
                 </a:solidFill>
@@ -4555,8 +5210,8 @@
         </p:nvSpPr>
         <p:spPr>
           <a:xfrm>
-            <a:off x="1965960" y="5715000"/>
-            <a:ext cx="9418320" cy="548640"/>
+            <a:off x="1965960" y="5074920"/>
+            <a:ext cx="9418320" cy="502920"/>
           </a:xfrm>
           <a:prstGeom prst="rect">
             <a:avLst/>
@@ -4580,6 +5235,97 @@
               </a:defRPr>
             </a:pPr>
             <a:r>
+              <a:t>Indicateurs d'insertion</a:t>
+            </a:r>
+          </a:p>
+        </p:txBody>
+      </p:sp>
+      <p:sp>
+        <p:nvSpPr>
+          <p:cNvPr id="16" name="Rounded Rectangle 15"/>
+          <p:cNvSpPr/>
+          <p:nvPr/>
+        </p:nvSpPr>
+        <p:spPr>
+          <a:xfrm>
+            <a:off x="822960" y="5715000"/>
+            <a:ext cx="914400" cy="658368"/>
+          </a:xfrm>
+          <a:prstGeom prst="roundRect">
+            <a:avLst/>
+          </a:prstGeom>
+          <a:solidFill>
+            <a:srgbClr val="1E40AF"/>
+          </a:solidFill>
+          <a:ln>
+            <a:noFill/>
+          </a:ln>
+          <a:effectLst/>
+        </p:spPr>
+        <p:style>
+          <a:lnRef idx="1">
+            <a:schemeClr val="accent1"/>
+          </a:lnRef>
+          <a:fillRef idx="3">
+            <a:schemeClr val="accent1"/>
+          </a:fillRef>
+          <a:effectRef idx="2">
+            <a:schemeClr val="accent1"/>
+          </a:effectRef>
+          <a:fontRef idx="minor">
+            <a:schemeClr val="lt1"/>
+          </a:fontRef>
+        </p:style>
+        <p:txBody>
+          <a:bodyPr rtlCol="0" anchor="ctr" wrap="square"/>
+          <a:lstStyle/>
+          <a:p>
+            <a:pPr algn="ctr">
+              <a:defRPr sz="2400" b="1">
+                <a:solidFill>
+                  <a:srgbClr val="FFFFFF"/>
+                </a:solidFill>
+              </a:defRPr>
+            </a:pPr>
+            <a:r>
+              <a:t>7</a:t>
+            </a:r>
+          </a:p>
+        </p:txBody>
+      </p:sp>
+      <p:sp>
+        <p:nvSpPr>
+          <p:cNvPr id="17" name="TextBox 16"/>
+          <p:cNvSpPr txBox="1"/>
+          <p:nvPr/>
+        </p:nvSpPr>
+        <p:spPr>
+          <a:xfrm>
+            <a:off x="1965960" y="5806440"/>
+            <a:ext cx="9418320" cy="502920"/>
+          </a:xfrm>
+          <a:prstGeom prst="rect">
+            <a:avLst/>
+          </a:prstGeom>
+          <a:noFill/>
+        </p:spPr>
+        <p:txBody>
+          <a:bodyPr wrap="square" lIns="45720" rIns="45720" tIns="27432" bIns="27432">
+            <a:spAutoFit/>
+          </a:bodyPr>
+          <a:lstStyle/>
+          <a:p>
+            <a:pPr algn="l">
+              <a:spcAft>
+                <a:spcPts val="200"/>
+              </a:spcAft>
+              <a:defRPr sz="2000" b="0">
+                <a:solidFill>
+                  <a:srgbClr val="111827"/>
+                </a:solidFill>
+              </a:defRPr>
+            </a:pPr>
+            <a:r>
               <a:t>Bilan et perspectives</a:t>
             </a:r>
           </a:p>
@@ -4587,7 +5333,7 @@
       </p:sp>
       <p:sp>
         <p:nvSpPr>
-          <p:cNvPr id="16" name="TextBox 15"/>
+          <p:cNvPr id="18" name="TextBox 17"/>
           <p:cNvSpPr txBox="1"/>
           <p:nvPr/>
         </p:nvSpPr>
@@ -4693,7 +5439,7 @@
               </a:defRPr>
             </a:pPr>
             <a:r>
-              <a:t>Contexte, enjeux et objectifs</a:t>
+              <a:t>Contexte et enjeux</a:t>
             </a:r>
           </a:p>
         </p:txBody>
@@ -4750,7 +5496,7 @@
         <p:spPr>
           <a:xfrm>
             <a:off x="822960" y="1143000"/>
-            <a:ext cx="10607040" cy="1280160"/>
+            <a:ext cx="10607040" cy="2194560"/>
           </a:xfrm>
           <a:prstGeom prst="rect">
             <a:avLst/>
@@ -4767,14 +5513,14 @@
               <a:spcAft>
                 <a:spcPts val="600"/>
               </a:spcAft>
-              <a:defRPr sz="1500">
+              <a:defRPr sz="1400">
                 <a:solidFill>
                   <a:srgbClr val="111827"/>
                 </a:solidFill>
               </a:defRPr>
             </a:pPr>
             <a:r>
-              <a:t>• Le suivi de l'insertion des diplômés est stratégique : pilotage de la formation, animation du réseau, obligations réglementaires (RGPD).</a:t>
+              <a:t>• IONIS-STM : formations Pré-MSc / MSc1 / MSc2 (développement, cyber, data, management, marketing digital).</a:t>
             </a:r>
           </a:p>
           <a:p>
@@ -4782,14 +5528,29 @@
               <a:spcAft>
                 <a:spcPts val="600"/>
               </a:spcAft>
-              <a:defRPr sz="1500">
+              <a:defRPr sz="1400">
                 <a:solidFill>
                   <a:srgbClr val="111827"/>
                 </a:solidFill>
               </a:defRPr>
             </a:pPr>
             <a:r>
-              <a:t>• Sans système centralisé, les données périment vite et la collecte est manuelle.</a:t>
+              <a:t>• Plusieurs centaines de diplômés par an : suivre leur insertion est stratégique (pilotage, tutelle CTI/HCERES, animation du réseau).</a:t>
+            </a:r>
+          </a:p>
+          <a:p>
+            <a:pPr>
+              <a:spcAft>
+                <a:spcPts val="600"/>
+              </a:spcAft>
+              <a:defRPr sz="1400">
+                <a:solidFill>
+                  <a:srgbClr val="111827"/>
+                </a:solidFill>
+              </a:defRPr>
+            </a:pPr>
+            <a:r>
+              <a:t>• Sans outil centralisé : données dispersées, indicateurs à la main, réseau inactif, RGPD non formalisé.</a:t>
             </a:r>
           </a:p>
         </p:txBody>
@@ -4802,14 +5563,14 @@
         </p:nvSpPr>
         <p:spPr>
           <a:xfrm>
-            <a:off x="822960" y="2560320"/>
-            <a:ext cx="10607040" cy="731520"/>
+            <a:off x="822960" y="3977639"/>
+            <a:ext cx="10607040" cy="1005840"/>
           </a:xfrm>
           <a:prstGeom prst="roundRect">
             <a:avLst/>
           </a:prstGeom>
           <a:solidFill>
-            <a:srgbClr val="EFF6FF"/>
+            <a:srgbClr val="1E40AF"/>
           </a:solidFill>
           <a:ln>
             <a:noFill/>
@@ -4846,8 +5607,8 @@
         </p:nvSpPr>
         <p:spPr>
           <a:xfrm>
-            <a:off x="1097280" y="2633472"/>
-            <a:ext cx="10058400" cy="594360"/>
+            <a:off x="1097280" y="4096512"/>
+            <a:ext cx="10058400" cy="777240"/>
           </a:xfrm>
           <a:prstGeom prst="rect">
             <a:avLst/>
@@ -4864,14 +5625,14 @@
               <a:spcAft>
                 <a:spcPts val="200"/>
               </a:spcAft>
-              <a:defRPr sz="1500" b="1">
-                <a:solidFill>
-                  <a:srgbClr val="1E40AF"/>
-                </a:solidFill>
-              </a:defRPr>
-            </a:pPr>
-            <a:r>
-              <a:t>Problématique : structurer la donnée alumni, piloter l'insertion par des indicateurs fiables, et animer le réseau dans le respect du RGPD.</a:t>
+              <a:defRPr sz="1600" b="1">
+                <a:solidFill>
+                  <a:srgbClr val="FFFFFF"/>
+                </a:solidFill>
+              </a:defRPr>
+            </a:pPr>
+            <a:r>
+              <a:t>Problématique : comment structurer la donnée alumni, produire des indicateurs d'insertion fiables et animer le réseau dans le respect du RGPD ?</a:t>
             </a:r>
           </a:p>
         </p:txBody>
@@ -4884,17 +5645,19 @@
         </p:nvSpPr>
         <p:spPr>
           <a:xfrm>
-            <a:off x="822960" y="3429000"/>
-            <a:ext cx="822960" cy="548640"/>
+            <a:off x="822960" y="5349240"/>
+            <a:ext cx="10607040" cy="868680"/>
           </a:xfrm>
           <a:prstGeom prst="roundRect">
             <a:avLst/>
           </a:prstGeom>
           <a:solidFill>
-            <a:srgbClr val="10B981"/>
+            <a:srgbClr val="EFF6FF"/>
           </a:solidFill>
-          <a:ln>
-            <a:noFill/>
+          <a:ln w="12700">
+            <a:solidFill>
+              <a:srgbClr val="10B981"/>
+            </a:solidFill>
           </a:ln>
           <a:effectLst/>
         </p:spPr>
@@ -4913,19 +5676,10 @@
           </a:fontRef>
         </p:style>
         <p:txBody>
-          <a:bodyPr rtlCol="0" anchor="ctr" wrap="square"/>
-          <a:lstStyle/>
-          <a:p>
-            <a:pPr algn="ctr">
-              <a:defRPr sz="1700" b="1">
-                <a:solidFill>
-                  <a:srgbClr val="FFFFFF"/>
-                </a:solidFill>
-              </a:defRPr>
-            </a:pPr>
-            <a:r>
-              <a:t>O1</a:t>
-            </a:r>
+          <a:bodyPr rtlCol="0" anchor="ctr"/>
+          <a:lstStyle/>
+          <a:p>
+            <a:pPr algn="ctr"/>
           </a:p>
         </p:txBody>
       </p:sp>
@@ -4937,8 +5691,8 @@
         </p:nvSpPr>
         <p:spPr>
           <a:xfrm>
-            <a:off x="1828800" y="3456432"/>
-            <a:ext cx="9509760" cy="502920"/>
+            <a:off x="1097280" y="5440680"/>
+            <a:ext cx="1920240" cy="640080"/>
           </a:xfrm>
           <a:prstGeom prst="rect">
             <a:avLst/>
@@ -4955,81 +5709,28 @@
               <a:spcAft>
                 <a:spcPts val="200"/>
               </a:spcAft>
-              <a:defRPr sz="1700" b="1">
-                <a:solidFill>
-                  <a:srgbClr val="111827"/>
-                </a:solidFill>
-              </a:defRPr>
-            </a:pPr>
-            <a:r>
-              <a:t>Un CRM complet : espace admin + espace alumni</a:t>
-            </a:r>
-          </a:p>
-        </p:txBody>
-      </p:sp>
-      <p:sp>
-        <p:nvSpPr>
-          <p:cNvPr id="9" name="Rounded Rectangle 8"/>
-          <p:cNvSpPr/>
-          <p:nvPr/>
-        </p:nvSpPr>
-        <p:spPr>
-          <a:xfrm>
-            <a:off x="822960" y="3995928"/>
-            <a:ext cx="822960" cy="548640"/>
-          </a:xfrm>
-          <a:prstGeom prst="roundRect">
-            <a:avLst/>
-          </a:prstGeom>
-          <a:solidFill>
-            <a:srgbClr val="10B981"/>
-          </a:solidFill>
-          <a:ln>
-            <a:noFill/>
-          </a:ln>
-          <a:effectLst/>
-        </p:spPr>
-        <p:style>
-          <a:lnRef idx="1">
-            <a:schemeClr val="accent1"/>
-          </a:lnRef>
-          <a:fillRef idx="3">
-            <a:schemeClr val="accent1"/>
-          </a:fillRef>
-          <a:effectRef idx="2">
-            <a:schemeClr val="accent1"/>
-          </a:effectRef>
-          <a:fontRef idx="minor">
-            <a:schemeClr val="lt1"/>
-          </a:fontRef>
-        </p:style>
-        <p:txBody>
-          <a:bodyPr rtlCol="0" anchor="ctr" wrap="square"/>
-          <a:lstStyle/>
-          <a:p>
-            <a:pPr algn="ctr">
-              <a:defRPr sz="1700" b="1">
-                <a:solidFill>
-                  <a:srgbClr val="FFFFFF"/>
-                </a:solidFill>
-              </a:defRPr>
-            </a:pPr>
-            <a:r>
-              <a:t>O2</a:t>
-            </a:r>
-          </a:p>
-        </p:txBody>
-      </p:sp>
-      <p:sp>
-        <p:nvSpPr>
-          <p:cNvPr id="10" name="TextBox 9"/>
+              <a:defRPr sz="1400" b="1">
+                <a:solidFill>
+                  <a:srgbClr val="10B981"/>
+                </a:solidFill>
+              </a:defRPr>
+            </a:pPr>
+            <a:r>
+              <a:t>EXEMPLE</a:t>
+            </a:r>
+          </a:p>
+        </p:txBody>
+      </p:sp>
+      <p:sp>
+        <p:nvSpPr>
+          <p:cNvPr id="9" name="TextBox 8"/>
           <p:cNvSpPr txBox="1"/>
           <p:nvPr/>
         </p:nvSpPr>
         <p:spPr>
           <a:xfrm>
-            <a:off x="1828800" y="4023360"/>
-            <a:ext cx="9509760" cy="502920"/>
+            <a:off x="3017520" y="5458968"/>
+            <a:ext cx="8229600" cy="640080"/>
           </a:xfrm>
           <a:prstGeom prst="rect">
             <a:avLst/>
@@ -5046,294 +5747,21 @@
               <a:spcAft>
                 <a:spcPts val="200"/>
               </a:spcAft>
-              <a:defRPr sz="1700" b="1">
+              <a:defRPr sz="1500" b="0">
                 <a:solidFill>
                   <a:srgbClr val="111827"/>
                 </a:solidFill>
               </a:defRPr>
             </a:pPr>
             <a:r>
-              <a:t>Une base relationnelle SQL modélisée (MCD/MLD)</a:t>
-            </a:r>
-          </a:p>
-        </p:txBody>
-      </p:sp>
-      <p:sp>
-        <p:nvSpPr>
-          <p:cNvPr id="11" name="Rounded Rectangle 10"/>
-          <p:cNvSpPr/>
-          <p:nvPr/>
-        </p:nvSpPr>
-        <p:spPr>
-          <a:xfrm>
-            <a:off x="822960" y="4562856"/>
-            <a:ext cx="822960" cy="548640"/>
-          </a:xfrm>
-          <a:prstGeom prst="roundRect">
-            <a:avLst/>
-          </a:prstGeom>
-          <a:solidFill>
-            <a:srgbClr val="10B981"/>
-          </a:solidFill>
-          <a:ln>
-            <a:noFill/>
-          </a:ln>
-          <a:effectLst/>
-        </p:spPr>
-        <p:style>
-          <a:lnRef idx="1">
-            <a:schemeClr val="accent1"/>
-          </a:lnRef>
-          <a:fillRef idx="3">
-            <a:schemeClr val="accent1"/>
-          </a:fillRef>
-          <a:effectRef idx="2">
-            <a:schemeClr val="accent1"/>
-          </a:effectRef>
-          <a:fontRef idx="minor">
-            <a:schemeClr val="lt1"/>
-          </a:fontRef>
-        </p:style>
-        <p:txBody>
-          <a:bodyPr rtlCol="0" anchor="ctr" wrap="square"/>
-          <a:lstStyle/>
-          <a:p>
-            <a:pPr algn="ctr">
-              <a:defRPr sz="1700" b="1">
-                <a:solidFill>
-                  <a:srgbClr val="FFFFFF"/>
-                </a:solidFill>
-              </a:defRPr>
-            </a:pPr>
-            <a:r>
-              <a:t>O3</a:t>
-            </a:r>
-          </a:p>
-        </p:txBody>
-      </p:sp>
-      <p:sp>
-        <p:nvSpPr>
-          <p:cNvPr id="12" name="TextBox 11"/>
-          <p:cNvSpPr txBox="1"/>
-          <p:nvPr/>
-        </p:nvSpPr>
-        <p:spPr>
-          <a:xfrm>
-            <a:off x="1828800" y="4590288"/>
-            <a:ext cx="9509760" cy="502920"/>
-          </a:xfrm>
-          <a:prstGeom prst="rect">
-            <a:avLst/>
-          </a:prstGeom>
-          <a:noFill/>
-        </p:spPr>
-        <p:txBody>
-          <a:bodyPr wrap="square" lIns="45720" rIns="45720" tIns="27432" bIns="27432">
-            <a:spAutoFit/>
-          </a:bodyPr>
-          <a:lstStyle/>
-          <a:p>
-            <a:pPr algn="l">
-              <a:spcAft>
-                <a:spcPts val="200"/>
-              </a:spcAft>
-              <a:defRPr sz="1700" b="1">
-                <a:solidFill>
-                  <a:srgbClr val="111827"/>
-                </a:solidFill>
-              </a:defRPr>
-            </a:pPr>
-            <a:r>
-              <a:t>Un tableau de bord avec indicateurs d'insertion</a:t>
-            </a:r>
-          </a:p>
-        </p:txBody>
-      </p:sp>
-      <p:sp>
-        <p:nvSpPr>
-          <p:cNvPr id="13" name="Rounded Rectangle 12"/>
-          <p:cNvSpPr/>
-          <p:nvPr/>
-        </p:nvSpPr>
-        <p:spPr>
-          <a:xfrm>
-            <a:off x="822960" y="5129784"/>
-            <a:ext cx="822960" cy="548640"/>
-          </a:xfrm>
-          <a:prstGeom prst="roundRect">
-            <a:avLst/>
-          </a:prstGeom>
-          <a:solidFill>
-            <a:srgbClr val="10B981"/>
-          </a:solidFill>
-          <a:ln>
-            <a:noFill/>
-          </a:ln>
-          <a:effectLst/>
-        </p:spPr>
-        <p:style>
-          <a:lnRef idx="1">
-            <a:schemeClr val="accent1"/>
-          </a:lnRef>
-          <a:fillRef idx="3">
-            <a:schemeClr val="accent1"/>
-          </a:fillRef>
-          <a:effectRef idx="2">
-            <a:schemeClr val="accent1"/>
-          </a:effectRef>
-          <a:fontRef idx="minor">
-            <a:schemeClr val="lt1"/>
-          </a:fontRef>
-        </p:style>
-        <p:txBody>
-          <a:bodyPr rtlCol="0" anchor="ctr" wrap="square"/>
-          <a:lstStyle/>
-          <a:p>
-            <a:pPr algn="ctr">
-              <a:defRPr sz="1700" b="1">
-                <a:solidFill>
-                  <a:srgbClr val="FFFFFF"/>
-                </a:solidFill>
-              </a:defRPr>
-            </a:pPr>
-            <a:r>
-              <a:t>O4</a:t>
-            </a:r>
-          </a:p>
-        </p:txBody>
-      </p:sp>
-      <p:sp>
-        <p:nvSpPr>
-          <p:cNvPr id="14" name="TextBox 13"/>
-          <p:cNvSpPr txBox="1"/>
-          <p:nvPr/>
-        </p:nvSpPr>
-        <p:spPr>
-          <a:xfrm>
-            <a:off x="1828800" y="5157216"/>
-            <a:ext cx="9509760" cy="502920"/>
-          </a:xfrm>
-          <a:prstGeom prst="rect">
-            <a:avLst/>
-          </a:prstGeom>
-          <a:noFill/>
-        </p:spPr>
-        <p:txBody>
-          <a:bodyPr wrap="square" lIns="45720" rIns="45720" tIns="27432" bIns="27432">
-            <a:spAutoFit/>
-          </a:bodyPr>
-          <a:lstStyle/>
-          <a:p>
-            <a:pPr algn="l">
-              <a:spcAft>
-                <a:spcPts val="200"/>
-              </a:spcAft>
-              <a:defRPr sz="1700" b="1">
-                <a:solidFill>
-                  <a:srgbClr val="111827"/>
-                </a:solidFill>
-              </a:defRPr>
-            </a:pPr>
-            <a:r>
-              <a:t>Une conformité RGPD réelle (consentement, export, suppression, audit)</a:t>
-            </a:r>
-          </a:p>
-        </p:txBody>
-      </p:sp>
-      <p:sp>
-        <p:nvSpPr>
-          <p:cNvPr id="15" name="Rounded Rectangle 14"/>
-          <p:cNvSpPr/>
-          <p:nvPr/>
-        </p:nvSpPr>
-        <p:spPr>
-          <a:xfrm>
-            <a:off x="822960" y="5696712"/>
-            <a:ext cx="822960" cy="548640"/>
-          </a:xfrm>
-          <a:prstGeom prst="roundRect">
-            <a:avLst/>
-          </a:prstGeom>
-          <a:solidFill>
-            <a:srgbClr val="10B981"/>
-          </a:solidFill>
-          <a:ln>
-            <a:noFill/>
-          </a:ln>
-          <a:effectLst/>
-        </p:spPr>
-        <p:style>
-          <a:lnRef idx="1">
-            <a:schemeClr val="accent1"/>
-          </a:lnRef>
-          <a:fillRef idx="3">
-            <a:schemeClr val="accent1"/>
-          </a:fillRef>
-          <a:effectRef idx="2">
-            <a:schemeClr val="accent1"/>
-          </a:effectRef>
-          <a:fontRef idx="minor">
-            <a:schemeClr val="lt1"/>
-          </a:fontRef>
-        </p:style>
-        <p:txBody>
-          <a:bodyPr rtlCol="0" anchor="ctr" wrap="square"/>
-          <a:lstStyle/>
-          <a:p>
-            <a:pPr algn="ctr">
-              <a:defRPr sz="1700" b="1">
-                <a:solidFill>
-                  <a:srgbClr val="FFFFFF"/>
-                </a:solidFill>
-              </a:defRPr>
-            </a:pPr>
-            <a:r>
-              <a:t>O5</a:t>
-            </a:r>
-          </a:p>
-        </p:txBody>
-      </p:sp>
-      <p:sp>
-        <p:nvSpPr>
-          <p:cNvPr id="16" name="TextBox 15"/>
-          <p:cNvSpPr txBox="1"/>
-          <p:nvPr/>
-        </p:nvSpPr>
-        <p:spPr>
-          <a:xfrm>
-            <a:off x="1828800" y="5724144"/>
-            <a:ext cx="9509760" cy="502920"/>
-          </a:xfrm>
-          <a:prstGeom prst="rect">
-            <a:avLst/>
-          </a:prstGeom>
-          <a:noFill/>
-        </p:spPr>
-        <p:txBody>
-          <a:bodyPr wrap="square" lIns="45720" rIns="45720" tIns="27432" bIns="27432">
-            <a:spAutoFit/>
-          </a:bodyPr>
-          <a:lstStyle/>
-          <a:p>
-            <a:pPr algn="l">
-              <a:spcAft>
-                <a:spcPts val="200"/>
-              </a:spcAft>
-              <a:defRPr sz="1700" b="1">
-                <a:solidFill>
-                  <a:srgbClr val="111827"/>
-                </a:solidFill>
-              </a:defRPr>
-            </a:pPr>
-            <a:r>
-              <a:t>L'import/export automatisé (Excel / CSV)</a:t>
-            </a:r>
-          </a:p>
-        </p:txBody>
-      </p:sp>
-      <p:sp>
-        <p:nvSpPr>
-          <p:cNvPr id="17" name="TextBox 16"/>
+              <a:t>Contexte : retrouver les anciens d'une promotion repose aujourd'hui sur des fichiers épars et des relances manuelles — la base centrale remplace ce bricolage.</a:t>
+            </a:r>
+          </a:p>
+        </p:txBody>
+      </p:sp>
+      <p:sp>
+        <p:nvSpPr>
+          <p:cNvPr id="10" name="TextBox 9"/>
           <p:cNvSpPr txBox="1"/>
           <p:nvPr/>
         </p:nvSpPr>
@@ -5439,7 +5867,7 @@
               </a:defRPr>
             </a:pPr>
             <a:r>
-              <a:t>Méthodologie et architecture 3-tiers</a:t>
+              <a:t>Objectifs du stage</a:t>
             </a:r>
           </a:p>
         </p:txBody>
@@ -5489,213 +5917,14 @@
       </p:sp>
       <p:sp>
         <p:nvSpPr>
-          <p:cNvPr id="4" name="TextBox 3"/>
-          <p:cNvSpPr txBox="1"/>
-          <p:nvPr/>
-        </p:nvSpPr>
-        <p:spPr>
-          <a:xfrm>
-            <a:off x="822960" y="1234440"/>
-            <a:ext cx="5394960" cy="4389120"/>
-          </a:xfrm>
-          <a:prstGeom prst="rect">
-            <a:avLst/>
-          </a:prstGeom>
-          <a:noFill/>
-        </p:spPr>
-        <p:txBody>
-          <a:bodyPr wrap="square" lIns="45720" tIns="27432">
-            <a:spAutoFit/>
-          </a:bodyPr>
-          <a:lstStyle/>
-          <a:p>
-            <a:pPr>
-              <a:spcAft>
-                <a:spcPts val="1000"/>
-              </a:spcAft>
-              <a:defRPr sz="1700">
-                <a:solidFill>
-                  <a:srgbClr val="111827"/>
-                </a:solidFill>
-              </a:defRPr>
-            </a:pPr>
-            <a:r>
-              <a:t>• Phases : analyse → conception (MCD/MLD) → développement → consolidation.</a:t>
-            </a:r>
-          </a:p>
-          <a:p>
-            <a:pPr>
-              <a:spcAft>
-                <a:spcPts val="1000"/>
-              </a:spcAft>
-              <a:defRPr sz="1700">
-                <a:solidFill>
-                  <a:srgbClr val="111827"/>
-                </a:solidFill>
-              </a:defRPr>
-            </a:pPr>
-            <a:r>
-              <a:t>• Démarche itérative en solo : audit SQL, rejeu des migrations, tests manuels.</a:t>
-            </a:r>
-          </a:p>
-          <a:p>
-            <a:pPr>
-              <a:spcAft>
-                <a:spcPts val="1000"/>
-              </a:spcAft>
-              <a:defRPr sz="1700">
-                <a:solidFill>
-                  <a:srgbClr val="111827"/>
-                </a:solidFill>
-              </a:defRPr>
-            </a:pPr>
-            <a:r>
-              <a:t>• Failles sécurité identifiées (IDOR, upload, secrets) → correctifs documentés.</a:t>
-            </a:r>
-          </a:p>
-          <a:p>
-            <a:pPr>
-              <a:spcAft>
-                <a:spcPts val="1000"/>
-              </a:spcAft>
-              <a:defRPr sz="1700">
-                <a:solidFill>
-                  <a:srgbClr val="111827"/>
-                </a:solidFill>
-              </a:defRPr>
-            </a:pPr>
-            <a:r>
-              <a:t>• Documentation « comme du code » : tous les livrables générés par script.</a:t>
-            </a:r>
-          </a:p>
-        </p:txBody>
-      </p:sp>
-      <p:sp>
-        <p:nvSpPr>
-          <p:cNvPr id="5" name="Rounded Rectangle 4"/>
+          <p:cNvPr id="4" name="Rounded Rectangle 3"/>
           <p:cNvSpPr/>
           <p:nvPr/>
         </p:nvSpPr>
         <p:spPr>
           <a:xfrm>
-            <a:off x="6400800" y="1463040"/>
-            <a:ext cx="1828800" cy="4480560"/>
-          </a:xfrm>
-          <a:prstGeom prst="roundRect">
-            <a:avLst/>
-          </a:prstGeom>
-          <a:solidFill>
-            <a:srgbClr val="1E40AF"/>
-          </a:solidFill>
-          <a:ln>
-            <a:noFill/>
-          </a:ln>
-          <a:effectLst/>
-        </p:spPr>
-        <p:style>
-          <a:lnRef idx="1">
-            <a:schemeClr val="accent1"/>
-          </a:lnRef>
-          <a:fillRef idx="3">
-            <a:schemeClr val="accent1"/>
-          </a:fillRef>
-          <a:effectRef idx="2">
-            <a:schemeClr val="accent1"/>
-          </a:effectRef>
-          <a:fontRef idx="minor">
-            <a:schemeClr val="lt1"/>
-          </a:fontRef>
-        </p:style>
-        <p:txBody>
-          <a:bodyPr rtlCol="0" anchor="ctr" wrap="square"/>
-          <a:lstStyle/>
-          <a:p>
-            <a:pPr algn="ctr">
-              <a:defRPr sz="1700" b="1">
-                <a:solidFill>
-                  <a:srgbClr val="FFFFFF"/>
-                </a:solidFill>
-              </a:defRPr>
-            </a:pPr>
-            <a:r>
-              <a:t>FRONTEND</a:t>
-            </a:r>
-          </a:p>
-          <a:p>
-            <a:pPr>
-              <a:defRPr sz="1300">
-                <a:solidFill>
-                  <a:srgbClr val="FFFFFF"/>
-                </a:solidFill>
-              </a:defRPr>
-            </a:pPr>
-            <a:r>
-              <a:t>React + Vite (SPA)</a:t>
-            </a:r>
-            <a:br/>
-            <a:r>
-              <a:t>Admin / Alumni</a:t>
-            </a:r>
-            <a:br/>
-            <a:r>
-              <a:t>proxy /api → 8000</a:t>
-            </a:r>
-          </a:p>
-        </p:txBody>
-      </p:sp>
-      <p:sp>
-        <p:nvSpPr>
-          <p:cNvPr id="6" name="Right Arrow 5"/>
-          <p:cNvSpPr/>
-          <p:nvPr/>
-        </p:nvSpPr>
-        <p:spPr>
-          <a:xfrm>
-            <a:off x="8202168" y="3474720"/>
-            <a:ext cx="219456" cy="365760"/>
-          </a:xfrm>
-          <a:prstGeom prst="rightArrow">
-            <a:avLst/>
-          </a:prstGeom>
-          <a:solidFill>
-            <a:srgbClr val="6B7280"/>
-          </a:solidFill>
-          <a:ln>
-            <a:noFill/>
-          </a:ln>
-        </p:spPr>
-        <p:style>
-          <a:lnRef idx="1">
-            <a:schemeClr val="accent1"/>
-          </a:lnRef>
-          <a:fillRef idx="3">
-            <a:schemeClr val="accent1"/>
-          </a:fillRef>
-          <a:effectRef idx="2">
-            <a:schemeClr val="accent1"/>
-          </a:effectRef>
-          <a:fontRef idx="minor">
-            <a:schemeClr val="lt1"/>
-          </a:fontRef>
-        </p:style>
-        <p:txBody>
-          <a:bodyPr rtlCol="0" anchor="ctr"/>
-          <a:lstStyle/>
-          <a:p>
-            <a:pPr algn="ctr"/>
-          </a:p>
-        </p:txBody>
-      </p:sp>
-      <p:sp>
-        <p:nvSpPr>
-          <p:cNvPr id="7" name="Rounded Rectangle 6"/>
-          <p:cNvSpPr/>
-          <p:nvPr/>
-        </p:nvSpPr>
-        <p:spPr>
-          <a:xfrm>
-            <a:off x="8485631" y="1463040"/>
-            <a:ext cx="1828800" cy="4480560"/>
+            <a:off x="822960" y="1371600"/>
+            <a:ext cx="822960" cy="502920"/>
           </a:xfrm>
           <a:prstGeom prst="roundRect">
             <a:avLst/>
@@ -5727,58 +5956,77 @@
           <a:lstStyle/>
           <a:p>
             <a:pPr algn="ctr">
-              <a:defRPr sz="1700" b="1">
+              <a:defRPr sz="1600" b="1">
                 <a:solidFill>
                   <a:srgbClr val="FFFFFF"/>
                 </a:solidFill>
               </a:defRPr>
             </a:pPr>
             <a:r>
-              <a:t>BACKEND</a:t>
-            </a:r>
-          </a:p>
-          <a:p>
-            <a:pPr>
-              <a:defRPr sz="1300">
-                <a:solidFill>
-                  <a:srgbClr val="FFFFFF"/>
-                </a:solidFill>
-              </a:defRPr>
-            </a:pPr>
-            <a:r>
-              <a:t>FastAPI</a:t>
-            </a:r>
-            <a:br/>
-            <a:r>
-              <a:t>82 endpoints, 16 routeurs</a:t>
-            </a:r>
-            <a:br/>
-            <a:r>
-              <a:t>auth OTP + JWT, clé API, RGPD</a:t>
-            </a:r>
-          </a:p>
-        </p:txBody>
-      </p:sp>
-      <p:sp>
-        <p:nvSpPr>
-          <p:cNvPr id="8" name="Right Arrow 7"/>
+              <a:t>O1</a:t>
+            </a:r>
+          </a:p>
+        </p:txBody>
+      </p:sp>
+      <p:sp>
+        <p:nvSpPr>
+          <p:cNvPr id="5" name="TextBox 4"/>
+          <p:cNvSpPr txBox="1"/>
+          <p:nvPr/>
+        </p:nvSpPr>
+        <p:spPr>
+          <a:xfrm>
+            <a:off x="1828800" y="1389888"/>
+            <a:ext cx="9509760" cy="457200"/>
+          </a:xfrm>
+          <a:prstGeom prst="rect">
+            <a:avLst/>
+          </a:prstGeom>
+          <a:noFill/>
+        </p:spPr>
+        <p:txBody>
+          <a:bodyPr wrap="square" lIns="45720" rIns="45720" tIns="27432" bIns="27432">
+            <a:spAutoFit/>
+          </a:bodyPr>
+          <a:lstStyle/>
+          <a:p>
+            <a:pPr algn="l">
+              <a:spcAft>
+                <a:spcPts val="200"/>
+              </a:spcAft>
+              <a:defRPr sz="1600" b="1">
+                <a:solidFill>
+                  <a:srgbClr val="111827"/>
+                </a:solidFill>
+              </a:defRPr>
+            </a:pPr>
+            <a:r>
+              <a:t>Un CRM complet : espace admin + espace alumni</a:t>
+            </a:r>
+          </a:p>
+        </p:txBody>
+      </p:sp>
+      <p:sp>
+        <p:nvSpPr>
+          <p:cNvPr id="6" name="Rounded Rectangle 5"/>
           <p:cNvSpPr/>
           <p:nvPr/>
         </p:nvSpPr>
         <p:spPr>
           <a:xfrm>
-            <a:off x="10286999" y="3474720"/>
-            <a:ext cx="219456" cy="365760"/>
-          </a:xfrm>
-          <a:prstGeom prst="rightArrow">
+            <a:off x="822960" y="1956816"/>
+            <a:ext cx="822960" cy="502920"/>
+          </a:xfrm>
+          <a:prstGeom prst="roundRect">
             <a:avLst/>
           </a:prstGeom>
           <a:solidFill>
-            <a:srgbClr val="6B7280"/>
+            <a:srgbClr val="10B981"/>
           </a:solidFill>
           <a:ln>
             <a:noFill/>
           </a:ln>
+          <a:effectLst/>
         </p:spPr>
         <p:style>
           <a:lnRef idx="1">
@@ -5795,29 +6043,76 @@
           </a:fontRef>
         </p:style>
         <p:txBody>
-          <a:bodyPr rtlCol="0" anchor="ctr"/>
-          <a:lstStyle/>
-          <a:p>
-            <a:pPr algn="ctr"/>
-          </a:p>
-        </p:txBody>
-      </p:sp>
-      <p:sp>
-        <p:nvSpPr>
-          <p:cNvPr id="9" name="Rounded Rectangle 8"/>
+          <a:bodyPr rtlCol="0" anchor="ctr" wrap="square"/>
+          <a:lstStyle/>
+          <a:p>
+            <a:pPr algn="ctr">
+              <a:defRPr sz="1600" b="1">
+                <a:solidFill>
+                  <a:srgbClr val="FFFFFF"/>
+                </a:solidFill>
+              </a:defRPr>
+            </a:pPr>
+            <a:r>
+              <a:t>O2</a:t>
+            </a:r>
+          </a:p>
+        </p:txBody>
+      </p:sp>
+      <p:sp>
+        <p:nvSpPr>
+          <p:cNvPr id="7" name="TextBox 6"/>
+          <p:cNvSpPr txBox="1"/>
+          <p:nvPr/>
+        </p:nvSpPr>
+        <p:spPr>
+          <a:xfrm>
+            <a:off x="1828800" y="1975104"/>
+            <a:ext cx="9509760" cy="457200"/>
+          </a:xfrm>
+          <a:prstGeom prst="rect">
+            <a:avLst/>
+          </a:prstGeom>
+          <a:noFill/>
+        </p:spPr>
+        <p:txBody>
+          <a:bodyPr wrap="square" lIns="45720" rIns="45720" tIns="27432" bIns="27432">
+            <a:spAutoFit/>
+          </a:bodyPr>
+          <a:lstStyle/>
+          <a:p>
+            <a:pPr algn="l">
+              <a:spcAft>
+                <a:spcPts val="200"/>
+              </a:spcAft>
+              <a:defRPr sz="1600" b="1">
+                <a:solidFill>
+                  <a:srgbClr val="111827"/>
+                </a:solidFill>
+              </a:defRPr>
+            </a:pPr>
+            <a:r>
+              <a:t>Une base relationnelle SQL modélisée (MCD/MLD)</a:t>
+            </a:r>
+          </a:p>
+        </p:txBody>
+      </p:sp>
+      <p:sp>
+        <p:nvSpPr>
+          <p:cNvPr id="8" name="Rounded Rectangle 7"/>
           <p:cNvSpPr/>
           <p:nvPr/>
         </p:nvSpPr>
         <p:spPr>
           <a:xfrm>
-            <a:off x="10570462" y="1463040"/>
-            <a:ext cx="1828800" cy="4480560"/>
+            <a:off x="822960" y="2542032"/>
+            <a:ext cx="822960" cy="502920"/>
           </a:xfrm>
           <a:prstGeom prst="roundRect">
             <a:avLst/>
           </a:prstGeom>
           <a:solidFill>
-            <a:srgbClr val="111827"/>
+            <a:srgbClr val="10B981"/>
           </a:solidFill>
           <a:ln>
             <a:noFill/>
@@ -5843,37 +6138,363 @@
           <a:lstStyle/>
           <a:p>
             <a:pPr algn="ctr">
-              <a:defRPr sz="1700" b="1">
+              <a:defRPr sz="1600" b="1">
                 <a:solidFill>
                   <a:srgbClr val="FFFFFF"/>
                 </a:solidFill>
               </a:defRPr>
             </a:pPr>
             <a:r>
-              <a:t>BASE DE DONNÉES</a:t>
-            </a:r>
-          </a:p>
-          <a:p>
-            <a:pPr>
-              <a:defRPr sz="1300">
+              <a:t>O3</a:t>
+            </a:r>
+          </a:p>
+        </p:txBody>
+      </p:sp>
+      <p:sp>
+        <p:nvSpPr>
+          <p:cNvPr id="9" name="TextBox 8"/>
+          <p:cNvSpPr txBox="1"/>
+          <p:nvPr/>
+        </p:nvSpPr>
+        <p:spPr>
+          <a:xfrm>
+            <a:off x="1828800" y="2560320"/>
+            <a:ext cx="9509760" cy="457200"/>
+          </a:xfrm>
+          <a:prstGeom prst="rect">
+            <a:avLst/>
+          </a:prstGeom>
+          <a:noFill/>
+        </p:spPr>
+        <p:txBody>
+          <a:bodyPr wrap="square" lIns="45720" rIns="45720" tIns="27432" bIns="27432">
+            <a:spAutoFit/>
+          </a:bodyPr>
+          <a:lstStyle/>
+          <a:p>
+            <a:pPr algn="l">
+              <a:spcAft>
+                <a:spcPts val="200"/>
+              </a:spcAft>
+              <a:defRPr sz="1600" b="1">
+                <a:solidFill>
+                  <a:srgbClr val="111827"/>
+                </a:solidFill>
+              </a:defRPr>
+            </a:pPr>
+            <a:r>
+              <a:t>Un tableau de bord avec indicateurs d'insertion</a:t>
+            </a:r>
+          </a:p>
+        </p:txBody>
+      </p:sp>
+      <p:sp>
+        <p:nvSpPr>
+          <p:cNvPr id="10" name="Rounded Rectangle 9"/>
+          <p:cNvSpPr/>
+          <p:nvPr/>
+        </p:nvSpPr>
+        <p:spPr>
+          <a:xfrm>
+            <a:off x="822960" y="3127248"/>
+            <a:ext cx="822960" cy="502920"/>
+          </a:xfrm>
+          <a:prstGeom prst="roundRect">
+            <a:avLst/>
+          </a:prstGeom>
+          <a:solidFill>
+            <a:srgbClr val="10B981"/>
+          </a:solidFill>
+          <a:ln>
+            <a:noFill/>
+          </a:ln>
+          <a:effectLst/>
+        </p:spPr>
+        <p:style>
+          <a:lnRef idx="1">
+            <a:schemeClr val="accent1"/>
+          </a:lnRef>
+          <a:fillRef idx="3">
+            <a:schemeClr val="accent1"/>
+          </a:fillRef>
+          <a:effectRef idx="2">
+            <a:schemeClr val="accent1"/>
+          </a:effectRef>
+          <a:fontRef idx="minor">
+            <a:schemeClr val="lt1"/>
+          </a:fontRef>
+        </p:style>
+        <p:txBody>
+          <a:bodyPr rtlCol="0" anchor="ctr" wrap="square"/>
+          <a:lstStyle/>
+          <a:p>
+            <a:pPr algn="ctr">
+              <a:defRPr sz="1600" b="1">
                 <a:solidFill>
                   <a:srgbClr val="FFFFFF"/>
                 </a:solidFill>
               </a:defRPr>
             </a:pPr>
             <a:r>
-              <a:t>PostgreSQL</a:t>
-            </a:r>
-            <a:br/>
-            <a:r>
-              <a:t>14 tables, 16 migrations, JSONB</a:t>
-            </a:r>
-          </a:p>
-        </p:txBody>
-      </p:sp>
-      <p:sp>
-        <p:nvSpPr>
-          <p:cNvPr id="10" name="TextBox 9"/>
+              <a:t>O4</a:t>
+            </a:r>
+          </a:p>
+        </p:txBody>
+      </p:sp>
+      <p:sp>
+        <p:nvSpPr>
+          <p:cNvPr id="11" name="TextBox 10"/>
+          <p:cNvSpPr txBox="1"/>
+          <p:nvPr/>
+        </p:nvSpPr>
+        <p:spPr>
+          <a:xfrm>
+            <a:off x="1828800" y="3145536"/>
+            <a:ext cx="9509760" cy="457200"/>
+          </a:xfrm>
+          <a:prstGeom prst="rect">
+            <a:avLst/>
+          </a:prstGeom>
+          <a:noFill/>
+        </p:spPr>
+        <p:txBody>
+          <a:bodyPr wrap="square" lIns="45720" rIns="45720" tIns="27432" bIns="27432">
+            <a:spAutoFit/>
+          </a:bodyPr>
+          <a:lstStyle/>
+          <a:p>
+            <a:pPr algn="l">
+              <a:spcAft>
+                <a:spcPts val="200"/>
+              </a:spcAft>
+              <a:defRPr sz="1600" b="1">
+                <a:solidFill>
+                  <a:srgbClr val="111827"/>
+                </a:solidFill>
+              </a:defRPr>
+            </a:pPr>
+            <a:r>
+              <a:t>Une conformité RGPD réelle (consentement, export, suppression, audit)</a:t>
+            </a:r>
+          </a:p>
+        </p:txBody>
+      </p:sp>
+      <p:sp>
+        <p:nvSpPr>
+          <p:cNvPr id="12" name="Rounded Rectangle 11"/>
+          <p:cNvSpPr/>
+          <p:nvPr/>
+        </p:nvSpPr>
+        <p:spPr>
+          <a:xfrm>
+            <a:off x="822960" y="3712464"/>
+            <a:ext cx="822960" cy="502920"/>
+          </a:xfrm>
+          <a:prstGeom prst="roundRect">
+            <a:avLst/>
+          </a:prstGeom>
+          <a:solidFill>
+            <a:srgbClr val="10B981"/>
+          </a:solidFill>
+          <a:ln>
+            <a:noFill/>
+          </a:ln>
+          <a:effectLst/>
+        </p:spPr>
+        <p:style>
+          <a:lnRef idx="1">
+            <a:schemeClr val="accent1"/>
+          </a:lnRef>
+          <a:fillRef idx="3">
+            <a:schemeClr val="accent1"/>
+          </a:fillRef>
+          <a:effectRef idx="2">
+            <a:schemeClr val="accent1"/>
+          </a:effectRef>
+          <a:fontRef idx="minor">
+            <a:schemeClr val="lt1"/>
+          </a:fontRef>
+        </p:style>
+        <p:txBody>
+          <a:bodyPr rtlCol="0" anchor="ctr" wrap="square"/>
+          <a:lstStyle/>
+          <a:p>
+            <a:pPr algn="ctr">
+              <a:defRPr sz="1600" b="1">
+                <a:solidFill>
+                  <a:srgbClr val="FFFFFF"/>
+                </a:solidFill>
+              </a:defRPr>
+            </a:pPr>
+            <a:r>
+              <a:t>O5</a:t>
+            </a:r>
+          </a:p>
+        </p:txBody>
+      </p:sp>
+      <p:sp>
+        <p:nvSpPr>
+          <p:cNvPr id="13" name="TextBox 12"/>
+          <p:cNvSpPr txBox="1"/>
+          <p:nvPr/>
+        </p:nvSpPr>
+        <p:spPr>
+          <a:xfrm>
+            <a:off x="1828800" y="3730752"/>
+            <a:ext cx="9509760" cy="457200"/>
+          </a:xfrm>
+          <a:prstGeom prst="rect">
+            <a:avLst/>
+          </a:prstGeom>
+          <a:noFill/>
+        </p:spPr>
+        <p:txBody>
+          <a:bodyPr wrap="square" lIns="45720" rIns="45720" tIns="27432" bIns="27432">
+            <a:spAutoFit/>
+          </a:bodyPr>
+          <a:lstStyle/>
+          <a:p>
+            <a:pPr algn="l">
+              <a:spcAft>
+                <a:spcPts val="200"/>
+              </a:spcAft>
+              <a:defRPr sz="1600" b="1">
+                <a:solidFill>
+                  <a:srgbClr val="111827"/>
+                </a:solidFill>
+              </a:defRPr>
+            </a:pPr>
+            <a:r>
+              <a:t>L'import/export automatisé (Excel / CSV)</a:t>
+            </a:r>
+          </a:p>
+        </p:txBody>
+      </p:sp>
+      <p:sp>
+        <p:nvSpPr>
+          <p:cNvPr id="14" name="Rounded Rectangle 13"/>
+          <p:cNvSpPr/>
+          <p:nvPr/>
+        </p:nvSpPr>
+        <p:spPr>
+          <a:xfrm>
+            <a:off x="822960" y="5349240"/>
+            <a:ext cx="10607040" cy="868680"/>
+          </a:xfrm>
+          <a:prstGeom prst="roundRect">
+            <a:avLst/>
+          </a:prstGeom>
+          <a:solidFill>
+            <a:srgbClr val="EFF6FF"/>
+          </a:solidFill>
+          <a:ln w="12700">
+            <a:solidFill>
+              <a:srgbClr val="10B981"/>
+            </a:solidFill>
+          </a:ln>
+          <a:effectLst/>
+        </p:spPr>
+        <p:style>
+          <a:lnRef idx="1">
+            <a:schemeClr val="accent1"/>
+          </a:lnRef>
+          <a:fillRef idx="3">
+            <a:schemeClr val="accent1"/>
+          </a:fillRef>
+          <a:effectRef idx="2">
+            <a:schemeClr val="accent1"/>
+          </a:effectRef>
+          <a:fontRef idx="minor">
+            <a:schemeClr val="lt1"/>
+          </a:fontRef>
+        </p:style>
+        <p:txBody>
+          <a:bodyPr rtlCol="0" anchor="ctr"/>
+          <a:lstStyle/>
+          <a:p>
+            <a:pPr algn="ctr"/>
+          </a:p>
+        </p:txBody>
+      </p:sp>
+      <p:sp>
+        <p:nvSpPr>
+          <p:cNvPr id="15" name="TextBox 14"/>
+          <p:cNvSpPr txBox="1"/>
+          <p:nvPr/>
+        </p:nvSpPr>
+        <p:spPr>
+          <a:xfrm>
+            <a:off x="1097280" y="5440680"/>
+            <a:ext cx="1920240" cy="640080"/>
+          </a:xfrm>
+          <a:prstGeom prst="rect">
+            <a:avLst/>
+          </a:prstGeom>
+          <a:noFill/>
+        </p:spPr>
+        <p:txBody>
+          <a:bodyPr wrap="square" lIns="45720" rIns="45720" tIns="27432" bIns="27432">
+            <a:spAutoFit/>
+          </a:bodyPr>
+          <a:lstStyle/>
+          <a:p>
+            <a:pPr algn="l">
+              <a:spcAft>
+                <a:spcPts val="200"/>
+              </a:spcAft>
+              <a:defRPr sz="1400" b="1">
+                <a:solidFill>
+                  <a:srgbClr val="10B981"/>
+                </a:solidFill>
+              </a:defRPr>
+            </a:pPr>
+            <a:r>
+              <a:t>EXEMPLE</a:t>
+            </a:r>
+          </a:p>
+        </p:txBody>
+      </p:sp>
+      <p:sp>
+        <p:nvSpPr>
+          <p:cNvPr id="16" name="TextBox 15"/>
+          <p:cNvSpPr txBox="1"/>
+          <p:nvPr/>
+        </p:nvSpPr>
+        <p:spPr>
+          <a:xfrm>
+            <a:off x="3017520" y="5458968"/>
+            <a:ext cx="8229600" cy="640080"/>
+          </a:xfrm>
+          <a:prstGeom prst="rect">
+            <a:avLst/>
+          </a:prstGeom>
+          <a:noFill/>
+        </p:spPr>
+        <p:txBody>
+          <a:bodyPr wrap="square" lIns="45720" rIns="45720" tIns="27432" bIns="27432">
+            <a:spAutoFit/>
+          </a:bodyPr>
+          <a:lstStyle/>
+          <a:p>
+            <a:pPr algn="l">
+              <a:spcAft>
+                <a:spcPts val="200"/>
+              </a:spcAft>
+              <a:defRPr sz="1500" b="0">
+                <a:solidFill>
+                  <a:srgbClr val="111827"/>
+                </a:solidFill>
+              </a:defRPr>
+            </a:pPr>
+            <a:r>
+              <a:t>Objectif O3 : un directeur voit en une page le taux d'emploi, le salaire moyen et la répartition par secteur de la promotion 2026.</a:t>
+            </a:r>
+          </a:p>
+        </p:txBody>
+      </p:sp>
+      <p:sp>
+        <p:nvSpPr>
+          <p:cNvPr id="17" name="TextBox 16"/>
           <p:cNvSpPr txBox="1"/>
           <p:nvPr/>
         </p:nvSpPr>
@@ -5979,7 +6600,7 @@
               </a:defRPr>
             </a:pPr>
             <a:r>
-              <a:t>Modèle de données (MCD/MLD)</a:t>
+              <a:t>Méthodologie et déroulement</a:t>
             </a:r>
           </a:p>
         </p:txBody>
@@ -6035,8 +6656,8 @@
         </p:nvSpPr>
         <p:spPr>
           <a:xfrm>
-            <a:off x="822960" y="1371600"/>
-            <a:ext cx="10607040" cy="4754880"/>
+            <a:off x="822960" y="1234440"/>
+            <a:ext cx="10607040" cy="3017520"/>
           </a:xfrm>
           <a:prstGeom prst="rect">
             <a:avLst/>
@@ -6051,98 +6672,190 @@
           <a:p>
             <a:pPr>
               <a:spcAft>
-                <a:spcPts val="1200"/>
+                <a:spcPts val="1000"/>
               </a:spcAft>
-              <a:defRPr sz="1800">
+              <a:defRPr sz="1700">
                 <a:solidFill>
                   <a:srgbClr val="111827"/>
                 </a:solidFill>
               </a:defRPr>
             </a:pPr>
             <a:r>
-              <a:t>• 5 domaines, 14 tables.</a:t>
+              <a:t>• Analyse : cahier des charges, étude des solutions, choix de la stack.</a:t>
             </a:r>
           </a:p>
           <a:p>
             <a:pPr>
               <a:spcAft>
-                <a:spcPts val="1200"/>
+                <a:spcPts val="1000"/>
               </a:spcAft>
-              <a:defRPr sz="1800">
+              <a:defRPr sz="1700">
                 <a:solidFill>
                   <a:srgbClr val="111827"/>
                 </a:solidFill>
               </a:defRPr>
             </a:pPr>
             <a:r>
-              <a:t>• Étudiants : ETUDIANT, PROMOTION (N:1).</a:t>
+              <a:t>• Conception : MCD/MLD (Looping), règles d'intégrité, schéma d'API.</a:t>
             </a:r>
           </a:p>
           <a:p>
             <a:pPr>
               <a:spcAft>
-                <a:spcPts val="1200"/>
+                <a:spcPts val="1000"/>
               </a:spcAft>
-              <a:defRPr sz="1800">
+              <a:defRPr sz="1700">
                 <a:solidFill>
                   <a:srgbClr val="111827"/>
                 </a:solidFill>
               </a:defRPr>
             </a:pPr>
             <a:r>
-              <a:t>• Parcours pro : ENTREPRISE, EXPERIENCE_PRO, CERTIFICATION, OBTIENT (N:M).</a:t>
+              <a:t>• Développement : backend FastAPI, frontend React, conformité RGPD.</a:t>
             </a:r>
           </a:p>
           <a:p>
             <a:pPr>
               <a:spcAft>
-                <a:spcPts val="1200"/>
+                <a:spcPts val="1000"/>
               </a:spcAft>
-              <a:defRPr sz="1800">
+              <a:defRPr sz="1700">
                 <a:solidFill>
                   <a:srgbClr val="111827"/>
                 </a:solidFill>
               </a:defRPr>
             </a:pPr>
             <a:r>
-              <a:t>• RGPD : CONSENTEMENT_RGPD, DEMANDE_RGPD, AUDIT_LOG.</a:t>
-            </a:r>
-          </a:p>
-          <a:p>
-            <a:pPr>
+              <a:t>• Consolidation : revue, documentation « comme du code », guide des processus.</a:t>
+            </a:r>
+          </a:p>
+        </p:txBody>
+      </p:sp>
+      <p:sp>
+        <p:nvSpPr>
+          <p:cNvPr id="5" name="Rounded Rectangle 4"/>
+          <p:cNvSpPr/>
+          <p:nvPr/>
+        </p:nvSpPr>
+        <p:spPr>
+          <a:xfrm>
+            <a:off x="822960" y="5349240"/>
+            <a:ext cx="10607040" cy="868680"/>
+          </a:xfrm>
+          <a:prstGeom prst="roundRect">
+            <a:avLst/>
+          </a:prstGeom>
+          <a:solidFill>
+            <a:srgbClr val="EFF6FF"/>
+          </a:solidFill>
+          <a:ln w="12700">
+            <a:solidFill>
+              <a:srgbClr val="10B981"/>
+            </a:solidFill>
+          </a:ln>
+          <a:effectLst/>
+        </p:spPr>
+        <p:style>
+          <a:lnRef idx="1">
+            <a:schemeClr val="accent1"/>
+          </a:lnRef>
+          <a:fillRef idx="3">
+            <a:schemeClr val="accent1"/>
+          </a:fillRef>
+          <a:effectRef idx="2">
+            <a:schemeClr val="accent1"/>
+          </a:effectRef>
+          <a:fontRef idx="minor">
+            <a:schemeClr val="lt1"/>
+          </a:fontRef>
+        </p:style>
+        <p:txBody>
+          <a:bodyPr rtlCol="0" anchor="ctr"/>
+          <a:lstStyle/>
+          <a:p>
+            <a:pPr algn="ctr"/>
+          </a:p>
+        </p:txBody>
+      </p:sp>
+      <p:sp>
+        <p:nvSpPr>
+          <p:cNvPr id="6" name="TextBox 5"/>
+          <p:cNvSpPr txBox="1"/>
+          <p:nvPr/>
+        </p:nvSpPr>
+        <p:spPr>
+          <a:xfrm>
+            <a:off x="1097280" y="5440680"/>
+            <a:ext cx="1920240" cy="640080"/>
+          </a:xfrm>
+          <a:prstGeom prst="rect">
+            <a:avLst/>
+          </a:prstGeom>
+          <a:noFill/>
+        </p:spPr>
+        <p:txBody>
+          <a:bodyPr wrap="square" lIns="45720" rIns="45720" tIns="27432" bIns="27432">
+            <a:spAutoFit/>
+          </a:bodyPr>
+          <a:lstStyle/>
+          <a:p>
+            <a:pPr algn="l">
               <a:spcAft>
-                <a:spcPts val="1200"/>
+                <a:spcPts val="200"/>
               </a:spcAft>
-              <a:defRPr sz="1800">
+              <a:defRPr sz="1400" b="1">
+                <a:solidFill>
+                  <a:srgbClr val="10B981"/>
+                </a:solidFill>
+              </a:defRPr>
+            </a:pPr>
+            <a:r>
+              <a:t>EXEMPLE</a:t>
+            </a:r>
+          </a:p>
+        </p:txBody>
+      </p:sp>
+      <p:sp>
+        <p:nvSpPr>
+          <p:cNvPr id="7" name="TextBox 6"/>
+          <p:cNvSpPr txBox="1"/>
+          <p:nvPr/>
+        </p:nvSpPr>
+        <p:spPr>
+          <a:xfrm>
+            <a:off x="3017520" y="5458968"/>
+            <a:ext cx="8229600" cy="640080"/>
+          </a:xfrm>
+          <a:prstGeom prst="rect">
+            <a:avLst/>
+          </a:prstGeom>
+          <a:noFill/>
+        </p:spPr>
+        <p:txBody>
+          <a:bodyPr wrap="square" lIns="45720" rIns="45720" tIns="27432" bIns="27432">
+            <a:spAutoFit/>
+          </a:bodyPr>
+          <a:lstStyle/>
+          <a:p>
+            <a:pPr algn="l">
+              <a:spcAft>
+                <a:spcPts val="200"/>
+              </a:spcAft>
+              <a:defRPr sz="1500" b="0">
                 <a:solidFill>
                   <a:srgbClr val="111827"/>
                 </a:solidFill>
               </a:defRPr>
             </a:pPr>
             <a:r>
-              <a:t>• Questionnaires : QUESTIONNAIRE, QUESTION, REPONSE_QUESTIONNAIRE (JSON).</a:t>
-            </a:r>
-          </a:p>
-          <a:p>
-            <a:pPr>
-              <a:spcAft>
-                <a:spcPts val="1200"/>
-              </a:spcAft>
-              <a:defRPr sz="1800">
-                <a:solidFill>
-                  <a:srgbClr val="111827"/>
-                </a:solidFill>
-              </a:defRPr>
-            </a:pPr>
-            <a:r>
-              <a:t>• Cascade et contraintes d'unicité garantissent la cohérence.</a:t>
-            </a:r>
-          </a:p>
-        </p:txBody>
-      </p:sp>
-      <p:sp>
-        <p:nvSpPr>
-          <p:cNvPr id="5" name="TextBox 4"/>
+              <a:t>Démarche itérative : chaque brique est livrée puis testée sur les parcours réels (connexion OTP, import Excel, demande RGPD) avant d'enchaîner la suivante.</a:t>
+            </a:r>
+          </a:p>
+        </p:txBody>
+      </p:sp>
+      <p:sp>
+        <p:nvSpPr>
+          <p:cNvPr id="8" name="TextBox 7"/>
           <p:cNvSpPr txBox="1"/>
           <p:nvPr/>
         </p:nvSpPr>
@@ -6248,7 +6961,7 @@
               </a:defRPr>
             </a:pPr>
             <a:r>
-              <a:t>Conformité RGPD</a:t>
+              <a:t>Architecture 3-tiers</a:t>
             </a:r>
           </a:p>
         </p:txBody>
@@ -6304,8 +7017,8 @@
         </p:nvSpPr>
         <p:spPr>
           <a:xfrm>
-            <a:off x="822960" y="1234440"/>
-            <a:ext cx="5394960" cy="2286000"/>
+            <a:off x="822960" y="1188720"/>
+            <a:ext cx="5486400" cy="2743200"/>
           </a:xfrm>
           <a:prstGeom prst="rect">
             <a:avLst/>
@@ -6320,7 +7033,7 @@
           <a:p>
             <a:pPr>
               <a:spcAft>
-                <a:spcPts val="600"/>
+                <a:spcPts val="700"/>
               </a:spcAft>
               <a:defRPr sz="1500">
                 <a:solidFill>
@@ -6329,13 +7042,13 @@
               </a:defRPr>
             </a:pPr>
             <a:r>
-              <a:t>• Consentement explicite : 4 types, horodaté et réellement consommé.</a:t>
+              <a:t>• Frontend React + Vite (SPA) : espace Admin et Alumni, proxy /api → 8000.</a:t>
             </a:r>
           </a:p>
           <a:p>
             <a:pPr>
               <a:spcAft>
-                <a:spcPts val="600"/>
+                <a:spcPts val="700"/>
               </a:spcAft>
               <a:defRPr sz="1500">
                 <a:solidFill>
@@ -6344,13 +7057,13 @@
               </a:defRPr>
             </a:pPr>
             <a:r>
-              <a:t>• Droits : export en auto-service (JSON/Excel/CSV), suppression avec workflow verrouillé.</a:t>
+              <a:t>• Backend FastAPI : 82 endpoints, 16 routeurs, validations Pydantic, Swagger.</a:t>
             </a:r>
           </a:p>
           <a:p>
             <a:pPr>
               <a:spcAft>
-                <a:spcPts val="600"/>
+                <a:spcPts val="700"/>
               </a:spcAft>
               <a:defRPr sz="1500">
                 <a:solidFill>
@@ -6359,62 +7072,444 @@
               </a:defRPr>
             </a:pPr>
             <a:r>
-              <a:t>• Anonymisation vs suppression ; journal d'audit ; purge différée.</a:t>
-            </a:r>
-          </a:p>
-        </p:txBody>
-      </p:sp>
-      <p:pic>
-        <p:nvPicPr>
-          <p:cNvPr id="5" name="Picture 4" descr="anC_consentement_light.png"/>
-          <p:cNvPicPr>
-            <a:picLocks noChangeAspect="1"/>
-          </p:cNvPicPr>
-          <p:nvPr/>
-        </p:nvPicPr>
-        <p:blipFill>
-          <a:blip r:embed="rId2"/>
-          <a:stretch>
-            <a:fillRect/>
-          </a:stretch>
-        </p:blipFill>
-        <p:spPr>
-          <a:xfrm>
-            <a:off x="822960" y="3657600"/>
-            <a:ext cx="4297680" cy="2686050"/>
-          </a:xfrm>
-          <a:prstGeom prst="rect">
-            <a:avLst/>
-          </a:prstGeom>
-        </p:spPr>
-      </p:pic>
-      <p:pic>
-        <p:nvPicPr>
-          <p:cNvPr id="6" name="Picture 5" descr="anB_demandes_rgpd_light.png"/>
-          <p:cNvPicPr>
-            <a:picLocks noChangeAspect="1"/>
-          </p:cNvPicPr>
-          <p:nvPr/>
-        </p:nvPicPr>
-        <p:blipFill>
-          <a:blip r:embed="rId3"/>
-          <a:stretch>
-            <a:fillRect/>
-          </a:stretch>
-        </p:blipFill>
-        <p:spPr>
-          <a:xfrm>
-            <a:off x="6400800" y="1234440"/>
-            <a:ext cx="5394960" cy="3371850"/>
-          </a:xfrm>
-          <a:prstGeom prst="rect">
-            <a:avLst/>
-          </a:prstGeom>
-        </p:spPr>
-      </p:pic>
+              <a:t>• PostgreSQL : 14 tables, 16 migrations versionnées, JSONB.</a:t>
+            </a:r>
+          </a:p>
+          <a:p>
+            <a:pPr>
+              <a:spcAft>
+                <a:spcPts val="700"/>
+              </a:spcAft>
+              <a:defRPr sz="1500">
+                <a:solidFill>
+                  <a:srgbClr val="111827"/>
+                </a:solidFill>
+              </a:defRPr>
+            </a:pPr>
+            <a:r>
+              <a:t>• Sécurité : OTP email, JWT, clé API admin, anti-IDOR.</a:t>
+            </a:r>
+          </a:p>
+        </p:txBody>
+      </p:sp>
+      <p:sp>
+        <p:nvSpPr>
+          <p:cNvPr id="5" name="Rounded Rectangle 4"/>
+          <p:cNvSpPr/>
+          <p:nvPr/>
+        </p:nvSpPr>
+        <p:spPr>
+          <a:xfrm>
+            <a:off x="822960" y="4434840"/>
+            <a:ext cx="10607040" cy="868680"/>
+          </a:xfrm>
+          <a:prstGeom prst="roundRect">
+            <a:avLst/>
+          </a:prstGeom>
+          <a:solidFill>
+            <a:srgbClr val="EFF6FF"/>
+          </a:solidFill>
+          <a:ln w="12700">
+            <a:solidFill>
+              <a:srgbClr val="10B981"/>
+            </a:solidFill>
+          </a:ln>
+          <a:effectLst/>
+        </p:spPr>
+        <p:style>
+          <a:lnRef idx="1">
+            <a:schemeClr val="accent1"/>
+          </a:lnRef>
+          <a:fillRef idx="3">
+            <a:schemeClr val="accent1"/>
+          </a:fillRef>
+          <a:effectRef idx="2">
+            <a:schemeClr val="accent1"/>
+          </a:effectRef>
+          <a:fontRef idx="minor">
+            <a:schemeClr val="lt1"/>
+          </a:fontRef>
+        </p:style>
+        <p:txBody>
+          <a:bodyPr rtlCol="0" anchor="ctr"/>
+          <a:lstStyle/>
+          <a:p>
+            <a:pPr algn="ctr"/>
+          </a:p>
+        </p:txBody>
+      </p:sp>
+      <p:sp>
+        <p:nvSpPr>
+          <p:cNvPr id="6" name="TextBox 5"/>
+          <p:cNvSpPr txBox="1"/>
+          <p:nvPr/>
+        </p:nvSpPr>
+        <p:spPr>
+          <a:xfrm>
+            <a:off x="1097280" y="4526280"/>
+            <a:ext cx="1920240" cy="640080"/>
+          </a:xfrm>
+          <a:prstGeom prst="rect">
+            <a:avLst/>
+          </a:prstGeom>
+          <a:noFill/>
+        </p:spPr>
+        <p:txBody>
+          <a:bodyPr wrap="square" lIns="45720" rIns="45720" tIns="27432" bIns="27432">
+            <a:spAutoFit/>
+          </a:bodyPr>
+          <a:lstStyle/>
+          <a:p>
+            <a:pPr algn="l">
+              <a:spcAft>
+                <a:spcPts val="200"/>
+              </a:spcAft>
+              <a:defRPr sz="1400" b="1">
+                <a:solidFill>
+                  <a:srgbClr val="10B981"/>
+                </a:solidFill>
+              </a:defRPr>
+            </a:pPr>
+            <a:r>
+              <a:t>EXEMPLE</a:t>
+            </a:r>
+          </a:p>
+        </p:txBody>
+      </p:sp>
       <p:sp>
         <p:nvSpPr>
           <p:cNvPr id="7" name="TextBox 6"/>
+          <p:cNvSpPr txBox="1"/>
+          <p:nvPr/>
+        </p:nvSpPr>
+        <p:spPr>
+          <a:xfrm>
+            <a:off x="3017520" y="4544568"/>
+            <a:ext cx="8229600" cy="640080"/>
+          </a:xfrm>
+          <a:prstGeom prst="rect">
+            <a:avLst/>
+          </a:prstGeom>
+          <a:noFill/>
+        </p:spPr>
+        <p:txBody>
+          <a:bodyPr wrap="square" lIns="45720" rIns="45720" tIns="27432" bIns="27432">
+            <a:spAutoFit/>
+          </a:bodyPr>
+          <a:lstStyle/>
+          <a:p>
+            <a:pPr algn="l">
+              <a:spcAft>
+                <a:spcPts val="200"/>
+              </a:spcAft>
+              <a:defRPr sz="1500" b="0">
+                <a:solidFill>
+                  <a:srgbClr val="111827"/>
+                </a:solidFill>
+              </a:defRPr>
+            </a:pPr>
+            <a:r>
+              <a:t>Flux d'une requête : un alumni saisit son code OTP à 6 chiffres → FastAPI le valide → un JWT est émis pour accéder à son profil.</a:t>
+            </a:r>
+          </a:p>
+        </p:txBody>
+      </p:sp>
+      <p:sp>
+        <p:nvSpPr>
+          <p:cNvPr id="8" name="Rounded Rectangle 7"/>
+          <p:cNvSpPr/>
+          <p:nvPr/>
+        </p:nvSpPr>
+        <p:spPr>
+          <a:xfrm>
+            <a:off x="6583680" y="1417320"/>
+            <a:ext cx="1691640" cy="2743200"/>
+          </a:xfrm>
+          <a:prstGeom prst="roundRect">
+            <a:avLst/>
+          </a:prstGeom>
+          <a:solidFill>
+            <a:srgbClr val="1E40AF"/>
+          </a:solidFill>
+          <a:ln>
+            <a:noFill/>
+          </a:ln>
+          <a:effectLst/>
+        </p:spPr>
+        <p:style>
+          <a:lnRef idx="1">
+            <a:schemeClr val="accent1"/>
+          </a:lnRef>
+          <a:fillRef idx="3">
+            <a:schemeClr val="accent1"/>
+          </a:fillRef>
+          <a:effectRef idx="2">
+            <a:schemeClr val="accent1"/>
+          </a:effectRef>
+          <a:fontRef idx="minor">
+            <a:schemeClr val="lt1"/>
+          </a:fontRef>
+        </p:style>
+        <p:txBody>
+          <a:bodyPr rtlCol="0" anchor="ctr" wrap="square"/>
+          <a:lstStyle/>
+          <a:p>
+            <a:pPr algn="ctr">
+              <a:defRPr sz="1500" b="1">
+                <a:solidFill>
+                  <a:srgbClr val="FFFFFF"/>
+                </a:solidFill>
+              </a:defRPr>
+            </a:pPr>
+            <a:r>
+              <a:t>FRONTEND</a:t>
+            </a:r>
+          </a:p>
+          <a:p>
+            <a:pPr algn="ctr">
+              <a:defRPr sz="1200">
+                <a:solidFill>
+                  <a:srgbClr val="FFFFFF"/>
+                </a:solidFill>
+              </a:defRPr>
+            </a:pPr>
+            <a:r>
+              <a:t>React + Vite</a:t>
+            </a:r>
+            <a:br/>
+            <a:r>
+              <a:t>(SPA)</a:t>
+            </a:r>
+          </a:p>
+        </p:txBody>
+      </p:sp>
+      <p:sp>
+        <p:nvSpPr>
+          <p:cNvPr id="9" name="Right Arrow 8"/>
+          <p:cNvSpPr/>
+          <p:nvPr/>
+        </p:nvSpPr>
+        <p:spPr>
+          <a:xfrm>
+            <a:off x="8247888" y="2560320"/>
+            <a:ext cx="201168" cy="411480"/>
+          </a:xfrm>
+          <a:prstGeom prst="rightArrow">
+            <a:avLst/>
+          </a:prstGeom>
+          <a:solidFill>
+            <a:srgbClr val="6B7280"/>
+          </a:solidFill>
+          <a:ln>
+            <a:noFill/>
+          </a:ln>
+        </p:spPr>
+        <p:style>
+          <a:lnRef idx="1">
+            <a:schemeClr val="accent1"/>
+          </a:lnRef>
+          <a:fillRef idx="3">
+            <a:schemeClr val="accent1"/>
+          </a:fillRef>
+          <a:effectRef idx="2">
+            <a:schemeClr val="accent1"/>
+          </a:effectRef>
+          <a:fontRef idx="minor">
+            <a:schemeClr val="lt1"/>
+          </a:fontRef>
+        </p:style>
+        <p:txBody>
+          <a:bodyPr rtlCol="0" anchor="ctr"/>
+          <a:lstStyle/>
+          <a:p>
+            <a:pPr algn="ctr"/>
+          </a:p>
+        </p:txBody>
+      </p:sp>
+      <p:sp>
+        <p:nvSpPr>
+          <p:cNvPr id="10" name="Rounded Rectangle 9"/>
+          <p:cNvSpPr/>
+          <p:nvPr/>
+        </p:nvSpPr>
+        <p:spPr>
+          <a:xfrm>
+            <a:off x="8522208" y="1417320"/>
+            <a:ext cx="1691640" cy="2743200"/>
+          </a:xfrm>
+          <a:prstGeom prst="roundRect">
+            <a:avLst/>
+          </a:prstGeom>
+          <a:solidFill>
+            <a:srgbClr val="10B981"/>
+          </a:solidFill>
+          <a:ln>
+            <a:noFill/>
+          </a:ln>
+          <a:effectLst/>
+        </p:spPr>
+        <p:style>
+          <a:lnRef idx="1">
+            <a:schemeClr val="accent1"/>
+          </a:lnRef>
+          <a:fillRef idx="3">
+            <a:schemeClr val="accent1"/>
+          </a:fillRef>
+          <a:effectRef idx="2">
+            <a:schemeClr val="accent1"/>
+          </a:effectRef>
+          <a:fontRef idx="minor">
+            <a:schemeClr val="lt1"/>
+          </a:fontRef>
+        </p:style>
+        <p:txBody>
+          <a:bodyPr rtlCol="0" anchor="ctr" wrap="square"/>
+          <a:lstStyle/>
+          <a:p>
+            <a:pPr algn="ctr">
+              <a:defRPr sz="1500" b="1">
+                <a:solidFill>
+                  <a:srgbClr val="FFFFFF"/>
+                </a:solidFill>
+              </a:defRPr>
+            </a:pPr>
+            <a:r>
+              <a:t>BACKEND</a:t>
+            </a:r>
+          </a:p>
+          <a:p>
+            <a:pPr algn="ctr">
+              <a:defRPr sz="1200">
+                <a:solidFill>
+                  <a:srgbClr val="FFFFFF"/>
+                </a:solidFill>
+              </a:defRPr>
+            </a:pPr>
+            <a:r>
+              <a:t>FastAPI</a:t>
+            </a:r>
+            <a:br/>
+            <a:r>
+              <a:t>82 endpoints</a:t>
+            </a:r>
+          </a:p>
+        </p:txBody>
+      </p:sp>
+      <p:sp>
+        <p:nvSpPr>
+          <p:cNvPr id="11" name="Right Arrow 10"/>
+          <p:cNvSpPr/>
+          <p:nvPr/>
+        </p:nvSpPr>
+        <p:spPr>
+          <a:xfrm>
+            <a:off x="10186416" y="2560320"/>
+            <a:ext cx="201168" cy="411480"/>
+          </a:xfrm>
+          <a:prstGeom prst="rightArrow">
+            <a:avLst/>
+          </a:prstGeom>
+          <a:solidFill>
+            <a:srgbClr val="6B7280"/>
+          </a:solidFill>
+          <a:ln>
+            <a:noFill/>
+          </a:ln>
+        </p:spPr>
+        <p:style>
+          <a:lnRef idx="1">
+            <a:schemeClr val="accent1"/>
+          </a:lnRef>
+          <a:fillRef idx="3">
+            <a:schemeClr val="accent1"/>
+          </a:fillRef>
+          <a:effectRef idx="2">
+            <a:schemeClr val="accent1"/>
+          </a:effectRef>
+          <a:fontRef idx="minor">
+            <a:schemeClr val="lt1"/>
+          </a:fontRef>
+        </p:style>
+        <p:txBody>
+          <a:bodyPr rtlCol="0" anchor="ctr"/>
+          <a:lstStyle/>
+          <a:p>
+            <a:pPr algn="ctr"/>
+          </a:p>
+        </p:txBody>
+      </p:sp>
+      <p:sp>
+        <p:nvSpPr>
+          <p:cNvPr id="12" name="Rounded Rectangle 11"/>
+          <p:cNvSpPr/>
+          <p:nvPr/>
+        </p:nvSpPr>
+        <p:spPr>
+          <a:xfrm>
+            <a:off x="10460736" y="1417320"/>
+            <a:ext cx="1691640" cy="2743200"/>
+          </a:xfrm>
+          <a:prstGeom prst="roundRect">
+            <a:avLst/>
+          </a:prstGeom>
+          <a:solidFill>
+            <a:srgbClr val="111827"/>
+          </a:solidFill>
+          <a:ln>
+            <a:noFill/>
+          </a:ln>
+          <a:effectLst/>
+        </p:spPr>
+        <p:style>
+          <a:lnRef idx="1">
+            <a:schemeClr val="accent1"/>
+          </a:lnRef>
+          <a:fillRef idx="3">
+            <a:schemeClr val="accent1"/>
+          </a:fillRef>
+          <a:effectRef idx="2">
+            <a:schemeClr val="accent1"/>
+          </a:effectRef>
+          <a:fontRef idx="minor">
+            <a:schemeClr val="lt1"/>
+          </a:fontRef>
+        </p:style>
+        <p:txBody>
+          <a:bodyPr rtlCol="0" anchor="ctr" wrap="square"/>
+          <a:lstStyle/>
+          <a:p>
+            <a:pPr algn="ctr">
+              <a:defRPr sz="1500" b="1">
+                <a:solidFill>
+                  <a:srgbClr val="FFFFFF"/>
+                </a:solidFill>
+              </a:defRPr>
+            </a:pPr>
+            <a:r>
+              <a:t>BASE</a:t>
+            </a:r>
+          </a:p>
+          <a:p>
+            <a:pPr algn="ctr">
+              <a:defRPr sz="1200">
+                <a:solidFill>
+                  <a:srgbClr val="FFFFFF"/>
+                </a:solidFill>
+              </a:defRPr>
+            </a:pPr>
+            <a:r>
+              <a:t>PostgreSQL</a:t>
+            </a:r>
+            <a:br/>
+            <a:r>
+              <a:t>14 tables</a:t>
+            </a:r>
+          </a:p>
+        </p:txBody>
+      </p:sp>
+      <p:sp>
+        <p:nvSpPr>
+          <p:cNvPr id="13" name="TextBox 12"/>
           <p:cNvSpPr txBox="1"/>
           <p:nvPr/>
         </p:nvSpPr>
@@ -6520,19 +7615,7 @@
               </a:defRPr>
             </a:pPr>
             <a:r>
-              <a:t>Démonstration — Espace Administration</a:t>
-            </a:r>
-          </a:p>
-          <a:p>
-            <a:pPr>
-              <a:defRPr sz="1400">
-                <a:solidFill>
-                  <a:srgbClr val="EFF6FF"/>
-                </a:solidFill>
-              </a:defRPr>
-            </a:pPr>
-            <a:r>
-              <a:t>Tableau de bord, annuaire, RGPD</a:t>
+              <a:t>Modèle de données (MCD)</a:t>
             </a:r>
           </a:p>
         </p:txBody>
@@ -6580,9 +7663,62 @@
           </a:p>
         </p:txBody>
       </p:sp>
+      <p:sp>
+        <p:nvSpPr>
+          <p:cNvPr id="4" name="TextBox 3"/>
+          <p:cNvSpPr txBox="1"/>
+          <p:nvPr/>
+        </p:nvSpPr>
+        <p:spPr>
+          <a:xfrm>
+            <a:off x="822960" y="1143000"/>
+            <a:ext cx="10607040" cy="1280160"/>
+          </a:xfrm>
+          <a:prstGeom prst="rect">
+            <a:avLst/>
+          </a:prstGeom>
+          <a:noFill/>
+        </p:spPr>
+        <p:txBody>
+          <a:bodyPr wrap="square" lIns="45720" tIns="27432">
+            <a:spAutoFit/>
+          </a:bodyPr>
+          <a:lstStyle/>
+          <a:p>
+            <a:pPr>
+              <a:spcAft>
+                <a:spcPts val="500"/>
+              </a:spcAft>
+              <a:defRPr sz="1500">
+                <a:solidFill>
+                  <a:srgbClr val="111827"/>
+                </a:solidFill>
+              </a:defRPr>
+            </a:pPr>
+            <a:r>
+              <a:t>• 5 domaines, 14 tables : étudiants, parcours pro, RGPD, questionnaires, INFRA.</a:t>
+            </a:r>
+          </a:p>
+          <a:p>
+            <a:pPr>
+              <a:spcAft>
+                <a:spcPts val="500"/>
+              </a:spcAft>
+              <a:defRPr sz="1500">
+                <a:solidFill>
+                  <a:srgbClr val="111827"/>
+                </a:solidFill>
+              </a:defRPr>
+            </a:pPr>
+            <a:r>
+              <a:t>• Relations clés : ETUDIANT → PROMOTION (N:1) ; EXPERIENCE_PRO (postes &amp; salaires) ; OBTIENT (certifications N:M).</a:t>
+            </a:r>
+          </a:p>
+        </p:txBody>
+      </p:sp>
       <p:pic>
         <p:nvPicPr>
-          <p:cNvPr id="4" name="Picture 3" descr="anB_dashboard_light.png"/>
+          <p:cNvPr id="5" name="Picture 4" descr="MCD.png"/>
           <p:cNvPicPr>
             <a:picLocks noChangeAspect="1"/>
           </p:cNvPicPr>
@@ -6596,8 +7732,8 @@
         </p:blipFill>
         <p:spPr>
           <a:xfrm>
-            <a:off x="1737360" y="1234440"/>
-            <a:ext cx="8119872" cy="5074920"/>
+            <a:off x="2399295" y="2514600"/>
+            <a:ext cx="7393104" cy="3749039"/>
           </a:xfrm>
           <a:prstGeom prst="rect">
             <a:avLst/>
@@ -6606,7 +7742,7 @@
       </p:pic>
       <p:sp>
         <p:nvSpPr>
-          <p:cNvPr id="5" name="TextBox 4"/>
+          <p:cNvPr id="6" name="TextBox 5"/>
           <p:cNvSpPr txBox="1"/>
           <p:nvPr/>
         </p:nvSpPr>
@@ -6712,19 +7848,7 @@
               </a:defRPr>
             </a:pPr>
             <a:r>
-              <a:t>Démonstration — Espace Alumni</a:t>
-            </a:r>
-          </a:p>
-          <a:p>
-            <a:pPr>
-              <a:defRPr sz="1400">
-                <a:solidFill>
-                  <a:srgbClr val="EFF6FF"/>
-                </a:solidFill>
-              </a:defRPr>
-            </a:pPr>
-            <a:r>
-              <a:t>Profil, parcours, consentement, questionnaire</a:t>
+              <a:t>Conformité RGPD</a:t>
             </a:r>
           </a:p>
         </p:txBody>
@@ -6772,9 +7896,77 @@
           </a:p>
         </p:txBody>
       </p:sp>
+      <p:sp>
+        <p:nvSpPr>
+          <p:cNvPr id="4" name="TextBox 3"/>
+          <p:cNvSpPr txBox="1"/>
+          <p:nvPr/>
+        </p:nvSpPr>
+        <p:spPr>
+          <a:xfrm>
+            <a:off x="822960" y="1143000"/>
+            <a:ext cx="10607040" cy="1554480"/>
+          </a:xfrm>
+          <a:prstGeom prst="rect">
+            <a:avLst/>
+          </a:prstGeom>
+          <a:noFill/>
+        </p:spPr>
+        <p:txBody>
+          <a:bodyPr wrap="square" lIns="45720" tIns="27432">
+            <a:spAutoFit/>
+          </a:bodyPr>
+          <a:lstStyle/>
+          <a:p>
+            <a:pPr>
+              <a:spcAft>
+                <a:spcPts val="600"/>
+              </a:spcAft>
+              <a:defRPr sz="1500">
+                <a:solidFill>
+                  <a:srgbClr val="111827"/>
+                </a:solidFill>
+              </a:defRPr>
+            </a:pPr>
+            <a:r>
+              <a:t>• Consentement explicite (4 types), horodaté et réellement consommé.</a:t>
+            </a:r>
+          </a:p>
+          <a:p>
+            <a:pPr>
+              <a:spcAft>
+                <a:spcPts val="600"/>
+              </a:spcAft>
+              <a:defRPr sz="1500">
+                <a:solidFill>
+                  <a:srgbClr val="111827"/>
+                </a:solidFill>
+              </a:defRPr>
+            </a:pPr>
+            <a:r>
+              <a:t>• Droits : export en auto-service (JSON/Excel/CSV), suppression avec workflow verrouillé et anonymisation.</a:t>
+            </a:r>
+          </a:p>
+          <a:p>
+            <a:pPr>
+              <a:spcAft>
+                <a:spcPts val="600"/>
+              </a:spcAft>
+              <a:defRPr sz="1500">
+                <a:solidFill>
+                  <a:srgbClr val="111827"/>
+                </a:solidFill>
+              </a:defRPr>
+            </a:pPr>
+            <a:r>
+              <a:t>• Traçabilité : journal d'audit, purge différée des comptes anonymisés.</a:t>
+            </a:r>
+          </a:p>
+        </p:txBody>
+      </p:sp>
       <p:pic>
         <p:nvPicPr>
-          <p:cNvPr id="4" name="Picture 3" descr="anC_parcours_light.png"/>
+          <p:cNvPr id="5" name="Picture 4" descr="anC_consentement_light.png"/>
           <p:cNvPicPr>
             <a:picLocks noChangeAspect="1"/>
           </p:cNvPicPr>
@@ -6788,17 +7980,41 @@
         </p:blipFill>
         <p:spPr>
           <a:xfrm>
-            <a:off x="1737360" y="1234440"/>
-            <a:ext cx="8119872" cy="5074920"/>
+            <a:off x="822960" y="2834640"/>
+            <a:ext cx="4206240" cy="2628900"/>
           </a:xfrm>
           <a:prstGeom prst="rect">
             <a:avLst/>
           </a:prstGeom>
         </p:spPr>
       </p:pic>
-      <p:sp>
-        <p:nvSpPr>
-          <p:cNvPr id="5" name="TextBox 4"/>
+      <p:pic>
+        <p:nvPicPr>
+          <p:cNvPr id="6" name="Picture 5" descr="anB_demandes_rgpd_light.png"/>
+          <p:cNvPicPr>
+            <a:picLocks noChangeAspect="1"/>
+          </p:cNvPicPr>
+          <p:nvPr/>
+        </p:nvPicPr>
+        <p:blipFill>
+          <a:blip r:embed="rId3"/>
+          <a:stretch>
+            <a:fillRect/>
+          </a:stretch>
+        </p:blipFill>
+        <p:spPr>
+          <a:xfrm>
+            <a:off x="5577840" y="2834640"/>
+            <a:ext cx="4206240" cy="2628900"/>
+          </a:xfrm>
+          <a:prstGeom prst="rect">
+            <a:avLst/>
+          </a:prstGeom>
+        </p:spPr>
+      </p:pic>
+      <p:sp>
+        <p:nvSpPr>
+          <p:cNvPr id="7" name="TextBox 6"/>
           <p:cNvSpPr txBox="1"/>
           <p:nvPr/>
         </p:nvSpPr>
@@ -6904,7 +8120,19 @@
               </a:defRPr>
             </a:pPr>
             <a:r>
-              <a:t>Indicateurs d'insertion professionnelle</a:t>
+              <a:t>Démonstration — Espace Administration</a:t>
+            </a:r>
+          </a:p>
+          <a:p>
+            <a:pPr>
+              <a:defRPr sz="1400">
+                <a:solidFill>
+                  <a:srgbClr val="EFF6FF"/>
+                </a:solidFill>
+              </a:defRPr>
+            </a:pPr>
+            <a:r>
+              <a:t>Tableau de bord, annuaire, RGPD</a:t>
             </a:r>
           </a:p>
         </p:txBody>
@@ -6952,122 +8180,9 @@
           </a:p>
         </p:txBody>
       </p:sp>
-      <p:sp>
-        <p:nvSpPr>
-          <p:cNvPr id="4" name="TextBox 3"/>
-          <p:cNvSpPr txBox="1"/>
-          <p:nvPr/>
-        </p:nvSpPr>
-        <p:spPr>
-          <a:xfrm>
-            <a:off x="822960" y="1371600"/>
-            <a:ext cx="5394960" cy="4937760"/>
-          </a:xfrm>
-          <a:prstGeom prst="rect">
-            <a:avLst/>
-          </a:prstGeom>
-          <a:noFill/>
-        </p:spPr>
-        <p:txBody>
-          <a:bodyPr wrap="square" lIns="45720" tIns="27432">
-            <a:spAutoFit/>
-          </a:bodyPr>
-          <a:lstStyle/>
-          <a:p>
-            <a:pPr>
-              <a:spcAft>
-                <a:spcPts val="800"/>
-              </a:spcAft>
-              <a:defRPr sz="1700">
-                <a:solidFill>
-                  <a:srgbClr val="111827"/>
-                </a:solidFill>
-              </a:defRPr>
-            </a:pPr>
-            <a:r>
-              <a:t>• 8 indicateurs reproductibles, formule et source explicites.</a:t>
-            </a:r>
-          </a:p>
-          <a:p>
-            <a:pPr>
-              <a:spcAft>
-                <a:spcPts val="800"/>
-              </a:spcAft>
-              <a:defRPr sz="1700">
-                <a:solidFill>
-                  <a:srgbClr val="111827"/>
-                </a:solidFill>
-              </a:defRPr>
-            </a:pPr>
-            <a:r>
-              <a:t>• Taux d'emploi à 6 mois (expériences actives).</a:t>
-            </a:r>
-          </a:p>
-          <a:p>
-            <a:pPr>
-              <a:spcAft>
-                <a:spcPts val="800"/>
-              </a:spcAft>
-              <a:defRPr sz="1700">
-                <a:solidFill>
-                  <a:srgbClr val="111827"/>
-                </a:solidFill>
-              </a:defRPr>
-            </a:pPr>
-            <a:r>
-              <a:t>• Adéquation formation/emploi via les tags KPI.</a:t>
-            </a:r>
-          </a:p>
-          <a:p>
-            <a:pPr>
-              <a:spcAft>
-                <a:spcPts val="800"/>
-              </a:spcAft>
-              <a:defRPr sz="1700">
-                <a:solidFill>
-                  <a:srgbClr val="111827"/>
-                </a:solidFill>
-              </a:defRPr>
-            </a:pPr>
-            <a:r>
-              <a:t>• Salaire moyen / min / max (champ annuel).</a:t>
-            </a:r>
-          </a:p>
-          <a:p>
-            <a:pPr>
-              <a:spcAft>
-                <a:spcPts val="800"/>
-              </a:spcAft>
-              <a:defRPr sz="1700">
-                <a:solidFill>
-                  <a:srgbClr val="111827"/>
-                </a:solidFill>
-              </a:defRPr>
-            </a:pPr>
-            <a:r>
-              <a:t>• Répartition par promotion et secteur, taux de complétion.</a:t>
-            </a:r>
-          </a:p>
-          <a:p>
-            <a:pPr>
-              <a:spcAft>
-                <a:spcPts val="800"/>
-              </a:spcAft>
-              <a:defRPr sz="1700">
-                <a:solidFill>
-                  <a:srgbClr val="111827"/>
-                </a:solidFill>
-              </a:defRPr>
-            </a:pPr>
-            <a:r>
-              <a:t>• Pas de chiffre trompeur : cohortes immatures → « non disponible ».</a:t>
-            </a:r>
-          </a:p>
-        </p:txBody>
-      </p:sp>
       <p:pic>
         <p:nvPicPr>
-          <p:cNvPr id="5" name="Picture 4" descr="anB_dashboard_light.png"/>
+          <p:cNvPr id="4" name="Picture 3" descr="anB_dashboard_light.png"/>
           <p:cNvPicPr>
             <a:picLocks noChangeAspect="1"/>
           </p:cNvPicPr>
@@ -7081,8 +8196,8 @@
         </p:blipFill>
         <p:spPr>
           <a:xfrm>
-            <a:off x="6400800" y="1737360"/>
-            <a:ext cx="5120640" cy="3200400"/>
+            <a:off x="1737360" y="1234440"/>
+            <a:ext cx="8119872" cy="5074920"/>
           </a:xfrm>
           <a:prstGeom prst="rect">
             <a:avLst/>
@@ -7091,7 +8206,7 @@
       </p:pic>
       <p:sp>
         <p:nvSpPr>
-          <p:cNvPr id="6" name="TextBox 5"/>
+          <p:cNvPr id="5" name="TextBox 4"/>
           <p:cNvSpPr txBox="1"/>
           <p:nvPr/>
         </p:nvSpPr>

</xml_diff>

<commit_message>
docs(livrables): update endpoint count 82->83 (new GET /bulk/export), regenerate PDF/PPTX/DOCX deliverables and add Rapport de Stage PDF
</commit_message>
<xml_diff>
--- a/Rapport/Soutenance - Alumni CRM - PreMSc 2026.pptx
+++ b/Rapport/Soutenance - Alumni CRM - PreMSc 2026.pptx
@@ -7057,7 +7057,7 @@
               </a:defRPr>
             </a:pPr>
             <a:r>
-              <a:t>• Backend FastAPI : 82 endpoints, 16 routeurs, validations Pydantic, Swagger.</a:t>
+              <a:t>• Backend FastAPI : 83 endpoints, 16 routeurs, validations Pydantic, Swagger.</a:t>
             </a:r>
           </a:p>
           <a:p>
@@ -7390,7 +7390,7 @@
             </a:r>
             <a:br/>
             <a:r>
-              <a:t>82 endpoints</a:t>
+              <a:t>83 endpoints</a:t>
             </a:r>
           </a:p>
         </p:txBody>

</xml_diff>

<commit_message>
feat(dashboard): redesign donut chart, add lucide icons & recent responses
- Redesign DonutChart with thin ring, gradients, gaps and grid legend
- Replace inline SVG icons with lucide-react (Users, Briefcase, TrendingUp, etc.)
- Add RecentResponses component for text question KPIs
- Remove Sparkline component
- AdminRgpdDemandes: hide mark/reject when all selected are processed
- AuthPage: remove console OTP hint
- Add lucide-react dependency
- Update Rapport deliverables
</commit_message>
<xml_diff>
--- a/Rapport/Soutenance - Alumni CRM - PreMSc 2026.pptx
+++ b/Rapport/Soutenance - Alumni CRM - PreMSc 2026.pptx
@@ -4071,7 +4071,7 @@
                 </a:solidFill>
                 <a:latin typeface="Calibri"/>
               </a:rPr>
-              <a:t>8 indicateurs reproductibles : formule, source et champ explicites.</a:t>
+              <a:t>8 indicateurs de base reproductibles : formule, source et champ explicites.</a:t>
             </a:r>
           </a:p>
           <a:p>
@@ -4684,7 +4684,7 @@
                 </a:solidFill>
                 <a:latin typeface="Calibri"/>
               </a:rPr>
-              <a:t>Livré : app full-stack opérationnelle (admin + alumni), 83 endpoints, 14 tables, 8 indicateurs.</a:t>
+              <a:t>Livré : app full-stack opérationnelle (admin + alumni), 83 endpoints, 14 tables, 8 indicateurs (extensibles par tags KPI).</a:t>
             </a:r>
           </a:p>
           <a:p>
@@ -7618,7 +7618,7 @@
               </a:defRPr>
             </a:pPr>
             <a:r>
-              <a:t>Un tableau de bord avec 8 indicateurs d'insertion reproductibles</a:t>
+              <a:t>Un tableau de bord avec 8 indicateurs de base, extensibles par tags KPI</a:t>
             </a:r>
           </a:p>
         </p:txBody>

</xml_diff>